<commit_message>
Deck, poster and talking points updated to 1 Oct results; question preparation; aliasing and RMS limitations in the report
</commit_message>
<xml_diff>
--- a/Presentation/SW7_Poster_A1.pptx
+++ b/Presentation/SW7_Poster_A1.pptx
@@ -877,7 +877,7 @@
       </p:grpSpPr>
       <p:pic>
         <p:nvPicPr>
-          <p:cNvPr id="2" name="Image 0" descr="C:\Users\0geda\AppData\Local\Temp\claude\c--Users-0geda-OneDrive---University-of-Cape-Town-Documents-PlatformIO-Projects\02999ba8-77fc-45f7-8817-da26b024fcdd\scratchpad\deck\assets\uct_banner.jpg">    </p:cNvPr>
+          <p:cNvPr id="2" name="Image 0" descr="C:\Users\0geda\OneDrive - University of Cape Town\Documents\PlatformIO\Projects\Tukzie-HPEC-HUD\Presentation\source\assets\uct_banner.jpg">    </p:cNvPr>
           <p:cNvPicPr>
             <a:picLocks noChangeAspect="1"/>
           </p:cNvPicPr>
@@ -1255,7 +1255,7 @@
                 <a:ea typeface="Calibri" pitchFamily="34" charset="-122"/>
                 <a:cs typeface="Calibri" pitchFamily="34" charset="-120"/>
               </a:rPr>
-              <a:t>Aim: a low-cost unit that characterises the trike's ride at the edge and shows only safety-relevant data head-up.</a:t>
+              <a:t>Aim: a low-cost unit that characterises the trike's ride at the edge and gives the driver only safety-relevant alerts.</a:t>
             </a:r>
             <a:endParaRPr lang="en-US" sz="3200" dirty="0"/>
           </a:p>
@@ -1393,7 +1393,7 @@
       </p:sp>
       <p:pic>
         <p:nvPicPr>
-          <p:cNvPr id="15" name="Image 1" descr="C:\Users\0geda\AppData\Local\Temp\claude\c--Users-0geda-OneDrive---University-of-Cape-Town-Documents-PlatformIO-Projects\02999ba8-77fc-45f7-8817-da26b024fcdd\scratchpad\deck\assets\bench_labelled.png">    </p:cNvPr>
+          <p:cNvPr id="15" name="Image 1" descr="C:\Users\0geda\OneDrive - University of Cape Town\Documents\PlatformIO\Projects\Tukzie-HPEC-HUD\Presentation\source\assets\bench_labelled.png">    </p:cNvPr>
           <p:cNvPicPr>
             <a:picLocks noChangeAspect="1"/>
           </p:cNvPicPr>
@@ -1448,7 +1448,7 @@
                 <a:ea typeface="Calibri" pitchFamily="34" charset="-122"/>
                 <a:cs typeface="Calibri" pitchFamily="34" charset="-120"/>
               </a:rPr>
-              <a:t>Bench setup: ESP32-S3 telemetry unit with LTE modem, two IMUs, GNSS and BLE battery link; Raspberry Pi 4 camera, time-aligned by a sync-pulse wire.</a:t>
+              <a:t>Bench setup: ESP32-S3 telemetry unit with LTE modem, two IMUs, GNSS, BLE battery link and Hall counter; Raspberry Pi 4 with camera detector and three distance sensors, time-aligned by a sync-pulse wire.</a:t>
             </a:r>
             <a:endParaRPr lang="en-US" sz="2400" dirty="0"/>
           </a:p>
@@ -2318,7 +2318,7 @@
                 <a:ea typeface="Calibri" pitchFamily="34" charset="-122"/>
                 <a:cs typeface="Calibri" pitchFamily="34" charset="-120"/>
               </a:rPr>
-              <a:t>8%</a:t>
+              <a:t>102 ms</a:t>
             </a:r>
             <a:endParaRPr lang="en-US" sz="6600" dirty="0"/>
           </a:p>
@@ -2357,7 +2357,7 @@
                 <a:ea typeface="Calibri" pitchFamily="34" charset="-122"/>
                 <a:cs typeface="Calibri" pitchFamily="34" charset="-120"/>
               </a:rPr>
-              <a:t>gap between the two IMUs, calibrated down to noise</a:t>
+              <a:t>median camera latency, sensor to result, at 19.5 fps</a:t>
             </a:r>
             <a:endParaRPr lang="en-US" sz="2600" dirty="0"/>
           </a:p>
@@ -2423,7 +2423,7 @@
                 <a:ea typeface="Calibri" pitchFamily="34" charset="-122"/>
                 <a:cs typeface="Calibri" pitchFamily="34" charset="-120"/>
               </a:rPr>
-              <a:t>&lt; 1 s</a:t>
+              <a:t>2.7 m</a:t>
             </a:r>
             <a:endParaRPr lang="en-US" sz="6600" dirty="0"/>
           </a:p>
@@ -2462,7 +2462,7 @@
                 <a:ea typeface="Calibri" pitchFamily="34" charset="-122"/>
                 <a:cs typeface="Calibri" pitchFamily="34" charset="-120"/>
               </a:rPr>
-              <a:t>camera aligned to the IMU data</a:t>
+              <a:t>median GNSS error against a phone, 104 fixes</a:t>
             </a:r>
             <a:endParaRPr lang="en-US" sz="2600" dirty="0"/>
           </a:p>
@@ -2575,7 +2575,7 @@
       </p:sp>
       <p:pic>
         <p:nvPicPr>
-          <p:cNvPr id="48" name="Image 2" descr="C:\Users\0geda\AppData\Local\Temp\claude\c--Users-0geda-OneDrive---University-of-Cape-Town-Documents-PlatformIO-Projects\02999ba8-77fc-45f7-8817-da26b024fcdd\scratchpad\deck\assets\vibration_chart.png">    </p:cNvPr>
+          <p:cNvPr id="48" name="Image 2" descr="C:\Users\0geda\OneDrive - University of Cape Town\Documents\PlatformIO\Projects\Tukzie-HPEC-HUD\Presentation\source\assets\vibration_chart.png">    </p:cNvPr>
           <p:cNvPicPr>
             <a:picLocks noChangeAspect="1"/>
           </p:cNvPicPr>
@@ -2645,11 +2645,11 @@
         <p:spPr>
           <a:xfrm>
             <a:off x="15549372" y="25242370"/>
-            <a:ext cx="13629132" cy="7223760"/>
+            <a:ext cx="13629132" cy="8229600"/>
           </a:xfrm>
           <a:prstGeom prst="roundRect">
             <a:avLst>
-              <a:gd name="adj" fmla="val 4430"/>
+              <a:gd name="adj" fmla="val 3889"/>
             </a:avLst>
           </a:prstGeom>
           <a:solidFill>
@@ -2775,7 +2775,7 @@
         <p:spPr>
           <a:xfrm>
             <a:off x="16189452" y="27254050"/>
-            <a:ext cx="12348972" cy="4937760"/>
+            <a:ext cx="12348972" cy="5943600"/>
           </a:xfrm>
           <a:prstGeom prst="rect">
             <a:avLst/>
@@ -2795,7 +2795,7 @@
               <a:buChar char="•"/>
             </a:pPr>
             <a:r>
-              <a:rPr lang="en-US" sz="3000" dirty="0">
+              <a:rPr lang="en-US" sz="2700" dirty="0">
                 <a:solidFill>
                   <a:srgbClr val="1B1F24"/>
                 </a:solidFill>
@@ -2803,9 +2803,9 @@
                 <a:ea typeface="Calibri" pitchFamily="34" charset="-122"/>
                 <a:cs typeface="Calibri" pitchFamily="34" charset="-120"/>
               </a:rPr>
-              <a:t>GNSS reply: assumed 13 fields, measured 9; the manual documents 16, with speed in knots.</a:t>
-            </a:r>
-            <a:endParaRPr lang="en-US" sz="3000" dirty="0"/>
+              <a:t>GNSS reply layout differed from the one assumed, so satellite counts were read as the position; the parser was rewritten.</a:t>
+            </a:r>
+            <a:endParaRPr lang="en-US" sz="2700" dirty="0"/>
           </a:p>
           <a:p>
             <a:pPr marL="406400" indent="-406400">
@@ -2816,7 +2816,7 @@
               <a:buChar char="•"/>
             </a:pPr>
             <a:r>
-              <a:rPr lang="en-US" sz="3000" dirty="0">
+              <a:rPr lang="en-US" sz="2700" dirty="0">
                 <a:solidFill>
                   <a:srgbClr val="1B1F24"/>
                 </a:solidFill>
@@ -2824,9 +2824,9 @@
                 <a:ea typeface="Calibri" pitchFamily="34" charset="-122"/>
                 <a:cs typeface="Calibri" pitchFamily="34" charset="-120"/>
               </a:rPr>
-              <a:t>Battery (BLE) service lookup was wrong; fixed, and the frame decoding matched an independent parser byte for byte.</a:t>
-            </a:r>
-            <a:endParaRPr lang="en-US" sz="3000" dirty="0"/>
+              <a:t>Battery checksum included one byte too many, so every real frame failed; fixed and confirmed on the pack.</a:t>
+            </a:r>
+            <a:endParaRPr lang="en-US" sz="2700" dirty="0"/>
           </a:p>
           <a:p>
             <a:pPr marL="406400" indent="-406400">
@@ -2837,7 +2837,7 @@
               <a:buChar char="•"/>
             </a:pPr>
             <a:r>
-              <a:rPr lang="en-US" sz="3000" dirty="0">
+              <a:rPr lang="en-US" sz="2700" dirty="0">
                 <a:solidFill>
                   <a:srgbClr val="1B1F24"/>
                 </a:solidFill>
@@ -2845,9 +2845,9 @@
                 <a:ea typeface="Calibri" pitchFamily="34" charset="-122"/>
                 <a:cs typeface="Calibri" pitchFamily="34" charset="-120"/>
               </a:rPr>
-              <a:t>The microSD chip-select is not fitted, so logging moved to the processor's own flash.</a:t>
-            </a:r>
-            <a:endParaRPr lang="en-US" sz="3000" dirty="0"/>
+              <a:t>Flash writes stalled both IMUs (proved by switching the log off); the log is now buffered and written once a minute.</a:t>
+            </a:r>
+            <a:endParaRPr lang="en-US" sz="2700" dirty="0"/>
           </a:p>
           <a:p>
             <a:pPr marL="406400" indent="-406400">
@@ -2858,7 +2858,7 @@
               <a:buChar char="•"/>
             </a:pPr>
             <a:r>
-              <a:rPr lang="en-US" sz="3000" dirty="0">
+              <a:rPr lang="en-US" sz="2700" dirty="0">
                 <a:solidFill>
                   <a:srgbClr val="1B1F24"/>
                 </a:solidFill>
@@ -2866,9 +2866,30 @@
                 <a:ea typeface="Calibri" pitchFamily="34" charset="-122"/>
                 <a:cs typeface="Calibri" pitchFamily="34" charset="-120"/>
               </a:rPr>
-              <a:t>A boot loop traced to a flash-size mismatch with the 16 MB partition table.</a:t>
-            </a:r>
-            <a:endParaRPr lang="en-US" sz="3000" dirty="0"/>
+              <a:t>Pink image: the camera has no infrared filter; the NoIR tuning plus saturation 1.8 restores the colours.</a:t>
+            </a:r>
+            <a:endParaRPr lang="en-US" sz="2700" dirty="0"/>
+          </a:p>
+          <a:p>
+            <a:pPr marL="406400" indent="-406400">
+              <a:spcAft>
+                <a:spcPts val="1400"/>
+              </a:spcAft>
+              <a:buSzPct val="100000"/>
+              <a:buChar char="•"/>
+            </a:pPr>
+            <a:r>
+              <a:rPr lang="en-US" sz="2700" dirty="0">
+                <a:solidFill>
+                  <a:srgbClr val="1B1F24"/>
+                </a:solidFill>
+                <a:latin typeface="Calibri" pitchFamily="34" charset="0"/>
+                <a:ea typeface="Calibri" pitchFamily="34" charset="-122"/>
+                <a:cs typeface="Calibri" pitchFamily="34" charset="-120"/>
+              </a:rPr>
+              <a:t>Stored records held nan, which is not valid JSON; now written as null.</a:t>
+            </a:r>
+            <a:endParaRPr lang="en-US" sz="2700" dirty="0"/>
           </a:p>
         </p:txBody>
       </p:sp>
@@ -2880,12 +2901,12 @@
         </p:nvSpPr>
         <p:spPr>
           <a:xfrm>
-            <a:off x="15549372" y="33289090"/>
-            <a:ext cx="13629132" cy="6679334"/>
+            <a:off x="15549372" y="34294930"/>
+            <a:ext cx="13629132" cy="5673494"/>
           </a:xfrm>
           <a:prstGeom prst="roundRect">
             <a:avLst>
-              <a:gd name="adj" fmla="val 4791"/>
+              <a:gd name="adj" fmla="val 5641"/>
             </a:avLst>
           </a:prstGeom>
           <a:solidFill>
@@ -2907,7 +2928,7 @@
         </p:nvSpPr>
         <p:spPr>
           <a:xfrm>
-            <a:off x="16052292" y="33746290"/>
+            <a:off x="16052292" y="34752130"/>
             <a:ext cx="1143000" cy="1143000"/>
           </a:xfrm>
           <a:prstGeom prst="ellipse">
@@ -2932,7 +2953,7 @@
         </p:nvSpPr>
         <p:spPr>
           <a:xfrm>
-            <a:off x="16052292" y="33746290"/>
+            <a:off x="16052292" y="34752130"/>
             <a:ext cx="1143000" cy="1143000"/>
           </a:xfrm>
           <a:prstGeom prst="rect">
@@ -2971,7 +2992,7 @@
         </p:nvSpPr>
         <p:spPr>
           <a:xfrm>
-            <a:off x="17515332" y="33700570"/>
+            <a:off x="17515332" y="34706410"/>
             <a:ext cx="11251692" cy="1234440"/>
           </a:xfrm>
           <a:prstGeom prst="rect">
@@ -3010,8 +3031,8 @@
         </p:nvSpPr>
         <p:spPr>
           <a:xfrm>
-            <a:off x="16189452" y="35300770"/>
-            <a:ext cx="12348972" cy="4393334"/>
+            <a:off x="16189452" y="36306610"/>
+            <a:ext cx="12348972" cy="3387494"/>
           </a:xfrm>
           <a:prstGeom prst="rect">
             <a:avLst/>
@@ -3031,7 +3052,7 @@
               <a:buChar char="•"/>
             </a:pPr>
             <a:r>
-              <a:rPr lang="en-US" sz="3000" dirty="0">
+              <a:rPr lang="en-US" sz="2700" dirty="0">
                 <a:solidFill>
                   <a:srgbClr val="1B1F24"/>
                 </a:solidFill>
@@ -3039,9 +3060,9 @@
                 <a:ea typeface="Calibri" pitchFamily="34" charset="-122"/>
                 <a:cs typeface="Calibri" pitchFamily="34" charset="-120"/>
               </a:rPr>
-              <a:t>Every subsystem runs together on the target board, with dual-IMU fusion verified live.</a:t>
-            </a:r>
-            <a:endParaRPr lang="en-US" sz="3000" dirty="0"/>
+              <a:t>Every subsystem runs together on the target board; camera alerts reach the existing dashboard in about 0.1 s.</a:t>
+            </a:r>
+            <a:endParaRPr lang="en-US" sz="2700" dirty="0"/>
           </a:p>
           <a:p>
             <a:pPr marL="406400" indent="-406400">
@@ -3052,7 +3073,7 @@
               <a:buChar char="•"/>
             </a:pPr>
             <a:r>
-              <a:rPr lang="en-US" sz="3000" dirty="0">
+              <a:rPr lang="en-US" sz="2700" dirty="0">
                 <a:solidFill>
                   <a:srgbClr val="1B1F24"/>
                 </a:solidFill>
@@ -3060,15 +3081,15 @@
                 <a:ea typeface="Calibri" pitchFamily="34" charset="-122"/>
                 <a:cs typeface="Calibri" pitchFamily="34" charset="-120"/>
               </a:rPr>
-              <a:t>Next: recalibrate the IMUs and run the on-vehicle field test, then integrate the time-of-flight and air-quality sensors and build the HUD.</a:t>
-            </a:r>
-            <a:endParaRPr lang="en-US" sz="3000" dirty="0"/>
+              <a:t>Next: mount on the trike, recalibrate in place, and run the field test for the ride and latency questions.</a:t>
+            </a:r>
+            <a:endParaRPr lang="en-US" sz="2700" dirty="0"/>
           </a:p>
         </p:txBody>
       </p:sp>
       <p:pic>
         <p:nvPicPr>
-          <p:cNvPr id="60" name="Image 3" descr="C:\Users\0geda\AppData\Local\Temp\claude\c--Users-0geda-OneDrive---University-of-Cape-Town-Documents-PlatformIO-Projects\02999ba8-77fc-45f7-8817-da26b024fcdd\scratchpad\deck\assets\uct_logo.png">    </p:cNvPr>
+          <p:cNvPr id="60" name="Image 3" descr="C:\Users\0geda\OneDrive - University of Cape Town\Documents\PlatformIO\Projects\Tukzie-HPEC-HUD\Presentation\source\assets\uct_logo.png">    </p:cNvPr>
           <p:cNvPicPr>
             <a:picLocks noChangeAspect="1"/>
           </p:cNvPicPr>

</xml_diff>

<commit_message>
Title and RQ2 changed to dashboard integration in report, deck and poster (supervisor agreed 1 Oct)
</commit_message>
<xml_diff>
--- a/Presentation/SW7_Poster_A1.pptx
+++ b/Presentation/SW7_Poster_A1.pptx
@@ -977,7 +977,7 @@
                 <a:ea typeface="Calibri" pitchFamily="34" charset="-122"/>
                 <a:cs typeface="Calibri" pitchFamily="34" charset="-120"/>
               </a:rPr>
-              <a:t>An Embedded Telemetry Unit and Windshield HUD</a:t>
+              <a:t>Development of an Embedded HPEC Telemetry Unit</a:t>
             </a:r>
             <a:endParaRPr lang="en-US" sz="7800" dirty="0"/>
           </a:p>
@@ -994,7 +994,7 @@
                 <a:ea typeface="Calibri" pitchFamily="34" charset="-122"/>
                 <a:cs typeface="Calibri" pitchFamily="34" charset="-120"/>
               </a:rPr>
-              <a:t>for the TUKZIE Rev 0 Electric Cargo Trike</a:t>
+              <a:t>and Dashboard Integration for the TUKZIE Rev 0 Platform</a:t>
             </a:r>
             <a:endParaRPr lang="en-US" sz="7800" dirty="0"/>
           </a:p>

</xml_diff>

<commit_message>
Presentation updated with 7 to 11 Oct results (deck, poster, talking points, Q&A; talk about 9.2 min); bench observations of 10 to 11 Oct recorded as evidence (ToF hand test, Pi 4 temperatures and reboots, detector 14.6 fps / 120 ms, voice)
</commit_message>
<xml_diff>
--- a/Presentation/SW7_Poster_A1.pptx
+++ b/Presentation/SW7_Poster_A1.pptx
@@ -2017,7 +2017,7 @@
                 <a:ea typeface="Calibri" pitchFamily="34" charset="-122"/>
                 <a:cs typeface="Calibri" pitchFamily="34" charset="-120"/>
               </a:rPr>
-              <a:t>Each stage is tested before the next is built on it. Stage 5 is still to come.</a:t>
+              <a:t>Each stage is tested before the next is built on it. Stage 5: road test planned for 14 October.</a:t>
             </a:r>
             <a:endParaRPr lang="en-US" sz="2400" dirty="0"/>
           </a:p>
@@ -2645,11 +2645,11 @@
         <p:spPr>
           <a:xfrm>
             <a:off x="15549372" y="25242370"/>
-            <a:ext cx="13629132" cy="8229600"/>
+            <a:ext cx="13629132" cy="8503920"/>
           </a:xfrm>
           <a:prstGeom prst="roundRect">
             <a:avLst>
-              <a:gd name="adj" fmla="val 3889"/>
+              <a:gd name="adj" fmla="val 3763"/>
             </a:avLst>
           </a:prstGeom>
           <a:solidFill>
@@ -2775,7 +2775,7 @@
         <p:spPr>
           <a:xfrm>
             <a:off x="16189452" y="27254050"/>
-            <a:ext cx="12348972" cy="5943600"/>
+            <a:ext cx="12348972" cy="6217920"/>
           </a:xfrm>
           <a:prstGeom prst="rect">
             <a:avLst/>
@@ -2887,7 +2887,28 @@
                 <a:ea typeface="Calibri" pitchFamily="34" charset="-122"/>
                 <a:cs typeface="Calibri" pitchFamily="34" charset="-120"/>
               </a:rPr>
-              <a:t>Stored records held nan, which is not valid JSON; now written as null.</a:t>
+              <a:t>Pi 4 brown-outs: the ESP32's LTE modem drew its current through the Pi's USB; it needs its own powered hub. A fan took the Pi from 81 C to 48 to 57 C.</a:t>
+            </a:r>
+            <a:endParaRPr lang="en-US" sz="2700" dirty="0"/>
+          </a:p>
+          <a:p>
+            <a:pPr marL="406400" indent="-406400">
+              <a:spcAft>
+                <a:spcPts val="1400"/>
+              </a:spcAft>
+              <a:buSzPct val="100000"/>
+              <a:buChar char="•"/>
+            </a:pPr>
+            <a:r>
+              <a:rPr lang="en-US" sz="2700" dirty="0">
+                <a:solidFill>
+                  <a:srgbClr val="1B1F24"/>
+                </a:solidFill>
+                <a:latin typeface="Calibri" pitchFamily="34" charset="0"/>
+                <a:ea typeface="Calibri" pitchFamily="34" charset="-122"/>
+                <a:cs typeface="Calibri" pitchFamily="34" charset="-120"/>
+              </a:rPr>
+              <a:t>One stuck distance sensor froze the reader; a 0.5 s timeout now skips it, and all three read.</a:t>
             </a:r>
             <a:endParaRPr lang="en-US" sz="2700" dirty="0"/>
           </a:p>
@@ -2901,12 +2922,12 @@
         </p:nvSpPr>
         <p:spPr>
           <a:xfrm>
-            <a:off x="15549372" y="34294930"/>
-            <a:ext cx="13629132" cy="5673494"/>
+            <a:off x="15549372" y="34569250"/>
+            <a:ext cx="13629132" cy="5399174"/>
           </a:xfrm>
           <a:prstGeom prst="roundRect">
             <a:avLst>
-              <a:gd name="adj" fmla="val 5641"/>
+              <a:gd name="adj" fmla="val 5928"/>
             </a:avLst>
           </a:prstGeom>
           <a:solidFill>
@@ -2928,7 +2949,7 @@
         </p:nvSpPr>
         <p:spPr>
           <a:xfrm>
-            <a:off x="16052292" y="34752130"/>
+            <a:off x="16052292" y="35026450"/>
             <a:ext cx="1143000" cy="1143000"/>
           </a:xfrm>
           <a:prstGeom prst="ellipse">
@@ -2953,7 +2974,7 @@
         </p:nvSpPr>
         <p:spPr>
           <a:xfrm>
-            <a:off x="16052292" y="34752130"/>
+            <a:off x="16052292" y="35026450"/>
             <a:ext cx="1143000" cy="1143000"/>
           </a:xfrm>
           <a:prstGeom prst="rect">
@@ -2992,7 +3013,7 @@
         </p:nvSpPr>
         <p:spPr>
           <a:xfrm>
-            <a:off x="17515332" y="34706410"/>
+            <a:off x="17515332" y="34980730"/>
             <a:ext cx="11251692" cy="1234440"/>
           </a:xfrm>
           <a:prstGeom prst="rect">
@@ -3031,8 +3052,8 @@
         </p:nvSpPr>
         <p:spPr>
           <a:xfrm>
-            <a:off x="16189452" y="36306610"/>
-            <a:ext cx="12348972" cy="3387494"/>
+            <a:off x="16189452" y="36580930"/>
+            <a:ext cx="12348972" cy="3113174"/>
           </a:xfrm>
           <a:prstGeom prst="rect">
             <a:avLst/>
@@ -3060,7 +3081,7 @@
                 <a:ea typeface="Calibri" pitchFamily="34" charset="-122"/>
                 <a:cs typeface="Calibri" pitchFamily="34" charset="-120"/>
               </a:rPr>
-              <a:t>Every subsystem runs together on the target board; camera and distance hazards are fused and shown live on the existing dashboard (Pi 5).</a:t>
+              <a:t>Every subsystem runs together on the target hardware; hazards, navigation and spoken directions run on the existing dashboard (Pi 5).</a:t>
             </a:r>
             <a:endParaRPr lang="en-US" sz="2700" dirty="0"/>
           </a:p>
@@ -3081,7 +3102,28 @@
                 <a:ea typeface="Calibri" pitchFamily="34" charset="-122"/>
                 <a:cs typeface="Calibri" pitchFamily="34" charset="-120"/>
               </a:rPr>
-              <a:t>Next: mount on the trike, recalibrate in place, and run the field test for the ride and latency questions.</a:t>
+              <a:t>In progress: central database with backlog replay (v0.7.4) and the pothole model on the Pi 4.</a:t>
+            </a:r>
+            <a:endParaRPr lang="en-US" sz="2700" dirty="0"/>
+          </a:p>
+          <a:p>
+            <a:pPr marL="406400" indent="-406400">
+              <a:spcAft>
+                <a:spcPts val="1400"/>
+              </a:spcAft>
+              <a:buSzPct val="100000"/>
+              <a:buChar char="•"/>
+            </a:pPr>
+            <a:r>
+              <a:rPr lang="en-US" sz="2700" dirty="0">
+                <a:solidFill>
+                  <a:srgbClr val="1B1F24"/>
+                </a:solidFill>
+                <a:latin typeface="Calibri" pitchFamily="34" charset="0"/>
+                <a:ea typeface="Calibri" pitchFamily="34" charset="-122"/>
+                <a:cs typeface="Calibri" pitchFamily="34" charset="-120"/>
+              </a:rPr>
+              <a:t>Next: road test (planned 14 Oct), recalibrate in place, answer RQ3 and RQ4 on the move.</a:t>
             </a:r>
             <a:endParaRPr lang="en-US" sz="2700" dirty="0"/>
           </a:p>

</xml_diff>

<commit_message>
Presentation refresh: T15 database result, pothole status, seven fault investigations, search and dashboard updates, corrected figures (14.6 fps / 120 ms full system, no 8 % or 0.5 s claims); word-for-word speaker script (9:37); Open Day demo script; Q&A sections on new items and review weak points
</commit_message>
<xml_diff>
--- a/Presentation/SW7_Poster_A1.pptx
+++ b/Presentation/SW7_Poster_A1.pptx
@@ -1448,7 +1448,7 @@
                 <a:ea typeface="Calibri" pitchFamily="34" charset="-122"/>
                 <a:cs typeface="Calibri" pitchFamily="34" charset="-120"/>
               </a:rPr>
-              <a:t>Bench setup: ESP32-S3 telemetry unit with LTE modem, two IMUs, GNSS, BLE battery link and Hall counter; Raspberry Pi 4 with camera detector and three distance sensors, time-aligned by a sync-pulse wire.</a:t>
+              <a:t>Bench setup: ESP32-S3 telemetry unit with LTE modem, two IMUs, GNSS, BLE battery link and Hall counter; Raspberry Pi 4 with camera detector and three distance sensors, time-aligned by a sync-pulse wire; records stored in a central database on the Pi 5.</a:t>
             </a:r>
             <a:endParaRPr lang="en-US" sz="2400" dirty="0"/>
           </a:p>
@@ -1898,7 +1898,7 @@
                 <a:ea typeface="Calibri" pitchFamily="34" charset="-122"/>
                 <a:cs typeface="Calibri" pitchFamily="34" charset="-120"/>
               </a:rPr>
-              <a:t>Log locally and publish over LTE</a:t>
+              <a:t>Log locally, publish over LTE, replay after an outage</a:t>
             </a:r>
             <a:endParaRPr lang="en-US" sz="3000" dirty="0"/>
           </a:p>
@@ -2252,7 +2252,7 @@
                 <a:ea typeface="Calibri" pitchFamily="34" charset="-122"/>
                 <a:cs typeface="Calibri" pitchFamily="34" charset="-120"/>
               </a:rPr>
-              <a:t>both IMUs, zero dropped samples</a:t>
+              <a:t>both IMUs, no samples dropped; 149 of 149 windows fused</a:t>
             </a:r>
             <a:endParaRPr lang="en-US" sz="2600" dirty="0"/>
           </a:p>
@@ -2318,7 +2318,7 @@
                 <a:ea typeface="Calibri" pitchFamily="34" charset="-122"/>
                 <a:cs typeface="Calibri" pitchFamily="34" charset="-120"/>
               </a:rPr>
-              <a:t>102 ms</a:t>
+              <a:t>120 ms</a:t>
             </a:r>
             <a:endParaRPr lang="en-US" sz="6600" dirty="0"/>
           </a:p>
@@ -2357,7 +2357,7 @@
                 <a:ea typeface="Calibri" pitchFamily="34" charset="-122"/>
                 <a:cs typeface="Calibri" pitchFamily="34" charset="-120"/>
               </a:rPr>
-              <a:t>median camera latency, sensor to result, at 19.5 fps</a:t>
+              <a:t>median camera latency in the full system at 14.6 fps (detector alone: 102 ms)</a:t>
             </a:r>
             <a:endParaRPr lang="en-US" sz="2600" dirty="0"/>
           </a:p>
@@ -2528,7 +2528,7 @@
                 <a:ea typeface="Calibri" pitchFamily="34" charset="-122"/>
                 <a:cs typeface="Calibri" pitchFamily="34" charset="-120"/>
               </a:rPr>
-              <a:t>149 / 149</a:t>
+              <a:t>112 / 112</a:t>
             </a:r>
             <a:endParaRPr lang="en-US" sz="6600" dirty="0"/>
           </a:p>
@@ -2567,7 +2567,7 @@
                 <a:ea typeface="Calibri" pitchFamily="34" charset="-122"/>
                 <a:cs typeface="Calibri" pitchFamily="34" charset="-120"/>
               </a:rPr>
-              <a:t>windows fused from both IMUs</a:t>
+              <a:t>records stored in the database across a 10-minute LTE outage</a:t>
             </a:r>
             <a:endParaRPr lang="en-US" sz="2600" dirty="0"/>
           </a:p>
@@ -2645,11 +2645,11 @@
         <p:spPr>
           <a:xfrm>
             <a:off x="15549372" y="25242370"/>
-            <a:ext cx="13629132" cy="8503920"/>
+            <a:ext cx="13629132" cy="8961120"/>
           </a:xfrm>
           <a:prstGeom prst="roundRect">
             <a:avLst>
-              <a:gd name="adj" fmla="val 3763"/>
+              <a:gd name="adj" fmla="val 3571"/>
             </a:avLst>
           </a:prstGeom>
           <a:solidFill>
@@ -2760,7 +2760,7 @@
                 <a:ea typeface="Calibri" pitchFamily="34" charset="-122"/>
                 <a:cs typeface="Calibri" pitchFamily="34" charset="-120"/>
               </a:rPr>
-              <a:t>Found and fixed</a:t>
+              <a:t>Fault investigations</a:t>
             </a:r>
             <a:endParaRPr lang="en-US" sz="5600" dirty="0"/>
           </a:p>
@@ -2775,7 +2775,7 @@
         <p:spPr>
           <a:xfrm>
             <a:off x="16189452" y="27254050"/>
-            <a:ext cx="12348972" cy="6217920"/>
+            <a:ext cx="12348972" cy="6766560"/>
           </a:xfrm>
           <a:prstGeom prst="rect">
             <a:avLst/>
@@ -2795,7 +2795,7 @@
               <a:buChar char="•"/>
             </a:pPr>
             <a:r>
-              <a:rPr lang="en-US" sz="2700" dirty="0">
+              <a:rPr lang="en-US" sz="2500" dirty="0">
                 <a:solidFill>
                   <a:srgbClr val="1B1F24"/>
                 </a:solidFill>
@@ -2803,9 +2803,9 @@
                 <a:ea typeface="Calibri" pitchFamily="34" charset="-122"/>
                 <a:cs typeface="Calibri" pitchFamily="34" charset="-120"/>
               </a:rPr>
-              <a:t>GNSS reply layout differed from the one assumed, so satellite counts were read as the position; the parser was rewritten.</a:t>
-            </a:r>
-            <a:endParaRPr lang="en-US" sz="2700" dirty="0"/>
+              <a:t>Boot loop: flash asked for quad mode on a dual-mode chip; size, mode and table now set together.</a:t>
+            </a:r>
+            <a:endParaRPr lang="en-US" sz="2500" dirty="0"/>
           </a:p>
           <a:p>
             <a:pPr marL="406400" indent="-406400">
@@ -2816,7 +2816,7 @@
               <a:buChar char="•"/>
             </a:pPr>
             <a:r>
-              <a:rPr lang="en-US" sz="2700" dirty="0">
+              <a:rPr lang="en-US" sz="2500" dirty="0">
                 <a:solidFill>
                   <a:srgbClr val="1B1F24"/>
                 </a:solidFill>
@@ -2824,9 +2824,9 @@
                 <a:ea typeface="Calibri" pitchFamily="34" charset="-122"/>
                 <a:cs typeface="Calibri" pitchFamily="34" charset="-120"/>
               </a:rPr>
-              <a:t>Battery checksum included one byte too many, so every real frame failed; fixed and confirmed on the pack.</a:t>
-            </a:r>
-            <a:endParaRPr lang="en-US" sz="2700" dirty="0"/>
+              <a:t>GNSS reply layout not as assumed; the parser anchors on the hemisphere letter (2.7 m median).</a:t>
+            </a:r>
+            <a:endParaRPr lang="en-US" sz="2500" dirty="0"/>
           </a:p>
           <a:p>
             <a:pPr marL="406400" indent="-406400">
@@ -2837,7 +2837,7 @@
               <a:buChar char="•"/>
             </a:pPr>
             <a:r>
-              <a:rPr lang="en-US" sz="2700" dirty="0">
+              <a:rPr lang="en-US" sz="2500" dirty="0">
                 <a:solidFill>
                   <a:srgbClr val="1B1F24"/>
                 </a:solidFill>
@@ -2845,9 +2845,9 @@
                 <a:ea typeface="Calibri" pitchFamily="34" charset="-122"/>
                 <a:cs typeface="Calibri" pitchFamily="34" charset="-120"/>
               </a:rPr>
-              <a:t>Flash writes stalled both IMUs (proved by switching the log off); the log is now buffered and written once a minute.</a:t>
-            </a:r>
-            <a:endParaRPr lang="en-US" sz="2700" dirty="0"/>
+              <a:t>Battery checksum summed one byte too many, so every frame failed by 3; fixed, 74.78 V read.</a:t>
+            </a:r>
+            <a:endParaRPr lang="en-US" sz="2500" dirty="0"/>
           </a:p>
           <a:p>
             <a:pPr marL="406400" indent="-406400">
@@ -2858,7 +2858,7 @@
               <a:buChar char="•"/>
             </a:pPr>
             <a:r>
-              <a:rPr lang="en-US" sz="2700" dirty="0">
+              <a:rPr lang="en-US" sz="2500" dirty="0">
                 <a:solidFill>
                   <a:srgbClr val="1B1F24"/>
                 </a:solidFill>
@@ -2866,9 +2866,9 @@
                 <a:ea typeface="Calibri" pitchFamily="34" charset="-122"/>
                 <a:cs typeface="Calibri" pitchFamily="34" charset="-120"/>
               </a:rPr>
-              <a:t>Pink image: the camera has no infrared filter; the NoIR tuning plus saturation 1.8 restores the colours.</a:t>
-            </a:r>
-            <a:endParaRPr lang="en-US" sz="2700" dirty="0"/>
+              <a:t>92% of logged records were invalid JSON (nan); read-back proved transfer intact; now null.</a:t>
+            </a:r>
+            <a:endParaRPr lang="en-US" sz="2500" dirty="0"/>
           </a:p>
           <a:p>
             <a:pPr marL="406400" indent="-406400">
@@ -2879,7 +2879,7 @@
               <a:buChar char="•"/>
             </a:pPr>
             <a:r>
-              <a:rPr lang="en-US" sz="2700" dirty="0">
+              <a:rPr lang="en-US" sz="2500" dirty="0">
                 <a:solidFill>
                   <a:srgbClr val="1B1F24"/>
                 </a:solidFill>
@@ -2887,9 +2887,9 @@
                 <a:ea typeface="Calibri" pitchFamily="34" charset="-122"/>
                 <a:cs typeface="Calibri" pitchFamily="34" charset="-120"/>
               </a:rPr>
-              <a:t>Pi 4 brown-outs: the ESP32's LTE modem drew its current through the Pi's USB; it needs its own powered hub. A fan took the Pi from 81 C to 48 to 57 C.</a:t>
-            </a:r>
-            <a:endParaRPr lang="en-US" sz="2700" dirty="0"/>
+              <a:t>Pink image: no infrared-cut filter on the camera; NoIR tuning and saturation 1.8.</a:t>
+            </a:r>
+            <a:endParaRPr lang="en-US" sz="2500" dirty="0"/>
           </a:p>
           <a:p>
             <a:pPr marL="406400" indent="-406400">
@@ -2900,7 +2900,7 @@
               <a:buChar char="•"/>
             </a:pPr>
             <a:r>
-              <a:rPr lang="en-US" sz="2700" dirty="0">
+              <a:rPr lang="en-US" sz="2500" dirty="0">
                 <a:solidFill>
                   <a:srgbClr val="1B1F24"/>
                 </a:solidFill>
@@ -2908,9 +2908,51 @@
                 <a:ea typeface="Calibri" pitchFamily="34" charset="-122"/>
                 <a:cs typeface="Calibri" pitchFamily="34" charset="-120"/>
               </a:rPr>
-              <a:t>One stuck distance sensor froze the reader; a 0.5 s timeout now skips it, and all three read.</a:t>
-            </a:r>
-            <a:endParaRPr lang="en-US" sz="2700" dirty="0"/>
+              <a:t>One stuck distance sensor froze all three; 0.5 s timeout, wiring re-seated.</a:t>
+            </a:r>
+            <a:endParaRPr lang="en-US" sz="2500" dirty="0"/>
+          </a:p>
+          <a:p>
+            <a:pPr marL="406400" indent="-406400">
+              <a:spcAft>
+                <a:spcPts val="1400"/>
+              </a:spcAft>
+              <a:buSzPct val="100000"/>
+              <a:buChar char="•"/>
+            </a:pPr>
+            <a:r>
+              <a:rPr lang="en-US" sz="2500" dirty="0">
+                <a:solidFill>
+                  <a:srgbClr val="1B1F24"/>
+                </a:solidFill>
+                <a:latin typeface="Calibri" pitchFamily="34" charset="0"/>
+                <a:ea typeface="Calibri" pitchFamily="34" charset="-122"/>
+                <a:cs typeface="Calibri" pitchFamily="34" charset="-120"/>
+              </a:rPr>
+              <a:t>Pi 4 reboots: power flags logged every 2 s showed the modem's current drawn through the Pi's USB; the unit needs its own supply.</a:t>
+            </a:r>
+            <a:endParaRPr lang="en-US" sz="2500" dirty="0"/>
+          </a:p>
+          <a:p>
+            <a:pPr marL="406400" indent="-406400">
+              <a:spcAft>
+                <a:spcPts val="1400"/>
+              </a:spcAft>
+              <a:buSzPct val="100000"/>
+              <a:buChar char="•"/>
+            </a:pPr>
+            <a:r>
+              <a:rPr lang="en-US" sz="2500" dirty="0">
+                <a:solidFill>
+                  <a:srgbClr val="1B1F24"/>
+                </a:solidFill>
+                <a:latin typeface="Calibri" pitchFamily="34" charset="0"/>
+                <a:ea typeface="Calibri" pitchFamily="34" charset="-122"/>
+                <a:cs typeface="Calibri" pitchFamily="34" charset="-120"/>
+              </a:rPr>
+              <a:t>Outage test: the ingest's broker session silently stopped delivery; made opt-in, records backfilled.</a:t>
+            </a:r>
+            <a:endParaRPr lang="en-US" sz="2500" dirty="0"/>
           </a:p>
         </p:txBody>
       </p:sp>
@@ -2922,12 +2964,12 @@
         </p:nvSpPr>
         <p:spPr>
           <a:xfrm>
-            <a:off x="15549372" y="34569250"/>
-            <a:ext cx="13629132" cy="5399174"/>
+            <a:off x="15549372" y="35026450"/>
+            <a:ext cx="13629132" cy="4941974"/>
           </a:xfrm>
           <a:prstGeom prst="roundRect">
             <a:avLst>
-              <a:gd name="adj" fmla="val 5928"/>
+              <a:gd name="adj" fmla="val 6476"/>
             </a:avLst>
           </a:prstGeom>
           <a:solidFill>
@@ -2949,7 +2991,7 @@
         </p:nvSpPr>
         <p:spPr>
           <a:xfrm>
-            <a:off x="16052292" y="35026450"/>
+            <a:off x="16052292" y="35483650"/>
             <a:ext cx="1143000" cy="1143000"/>
           </a:xfrm>
           <a:prstGeom prst="ellipse">
@@ -2974,7 +3016,7 @@
         </p:nvSpPr>
         <p:spPr>
           <a:xfrm>
-            <a:off x="16052292" y="35026450"/>
+            <a:off x="16052292" y="35483650"/>
             <a:ext cx="1143000" cy="1143000"/>
           </a:xfrm>
           <a:prstGeom prst="rect">
@@ -3013,7 +3055,7 @@
         </p:nvSpPr>
         <p:spPr>
           <a:xfrm>
-            <a:off x="17515332" y="34980730"/>
+            <a:off x="17515332" y="35437930"/>
             <a:ext cx="11251692" cy="1234440"/>
           </a:xfrm>
           <a:prstGeom prst="rect">
@@ -3052,8 +3094,8 @@
         </p:nvSpPr>
         <p:spPr>
           <a:xfrm>
-            <a:off x="16189452" y="36580930"/>
-            <a:ext cx="12348972" cy="3113174"/>
+            <a:off x="16189452" y="37038130"/>
+            <a:ext cx="12348972" cy="2747414"/>
           </a:xfrm>
           <a:prstGeom prst="rect">
             <a:avLst/>
@@ -3073,7 +3115,7 @@
               <a:buChar char="•"/>
             </a:pPr>
             <a:r>
-              <a:rPr lang="en-US" sz="2700" dirty="0">
+              <a:rPr lang="en-US" sz="2600" dirty="0">
                 <a:solidFill>
                   <a:srgbClr val="1B1F24"/>
                 </a:solidFill>
@@ -3081,9 +3123,9 @@
                 <a:ea typeface="Calibri" pitchFamily="34" charset="-122"/>
                 <a:cs typeface="Calibri" pitchFamily="34" charset="-120"/>
               </a:rPr>
-              <a:t>Every subsystem runs together on the target hardware; hazards, navigation and spoken directions run on the existing dashboard (Pi 5).</a:t>
-            </a:r>
-            <a:endParaRPr lang="en-US" sz="2700" dirty="0"/>
+              <a:t>Every subsystem runs together on the target hardware; hazards, navigation and destination search run on the existing dashboard (Pi 5).</a:t>
+            </a:r>
+            <a:endParaRPr lang="en-US" sz="2600" dirty="0"/>
           </a:p>
           <a:p>
             <a:pPr marL="406400" indent="-406400">
@@ -3094,7 +3136,7 @@
               <a:buChar char="•"/>
             </a:pPr>
             <a:r>
-              <a:rPr lang="en-US" sz="2700" dirty="0">
+              <a:rPr lang="en-US" sz="2600" dirty="0">
                 <a:solidFill>
                   <a:srgbClr val="1B1F24"/>
                 </a:solidFill>
@@ -3102,9 +3144,9 @@
                 <a:ea typeface="Calibri" pitchFamily="34" charset="-122"/>
                 <a:cs typeface="Calibri" pitchFamily="34" charset="-120"/>
               </a:rPr>
-              <a:t>In progress: central database with backlog replay (v0.7.4) and the pothole model on the Pi 4.</a:t>
-            </a:r>
-            <a:endParaRPr lang="en-US" sz="2700" dirty="0"/>
+              <a:t>Firmware v0.7.4: no record lost across a 10-minute outage. Pothole path built, off by default: too slow beside the detector on a Pi 4.</a:t>
+            </a:r>
+            <a:endParaRPr lang="en-US" sz="2600" dirty="0"/>
           </a:p>
           <a:p>
             <a:pPr marL="406400" indent="-406400">
@@ -3115,7 +3157,7 @@
               <a:buChar char="•"/>
             </a:pPr>
             <a:r>
-              <a:rPr lang="en-US" sz="2700" dirty="0">
+              <a:rPr lang="en-US" sz="2600" dirty="0">
                 <a:solidFill>
                   <a:srgbClr val="1B1F24"/>
                 </a:solidFill>
@@ -3123,9 +3165,9 @@
                 <a:ea typeface="Calibri" pitchFamily="34" charset="-122"/>
                 <a:cs typeface="Calibri" pitchFamily="34" charset="-120"/>
               </a:rPr>
-              <a:t>Next: road test (planned 14 Oct), recalibrate in place, answer RQ3 and RQ4 on the move.</a:t>
-            </a:r>
-            <a:endParaRPr lang="en-US" sz="2700" dirty="0"/>
+              <a:t>Next: road test (planned 14 Oct), recalibrate, end-to-end latency with GNSS time, RQ1, RQ3 and RQ4 on the move, glance time.</a:t>
+            </a:r>
+            <a:endParaRPr lang="en-US" sz="2600" dirty="0"/>
           </a:p>
         </p:txBody>
       </p:sp>

</xml_diff>

<commit_message>
Oral and poster: deck and A1 poster rebuilt with the 27 Oct results and final report figures, no SW-7; script, Q&A, examiner prep and numbers cheat sheet updated
</commit_message>
<xml_diff>
--- a/Presentation/SW7_Poster_A1.pptx
+++ b/Presentation/SW7_Poster_A1.pptx
@@ -10,8 +10,8 @@
   <p:notesMasterIdLst>
     <p:notesMasterId r:id="rId3"/>
   </p:notesMasterIdLst>
-  <p:sldSz cx="30275784" cy="42803064"/>
-  <p:notesSz cx="42803064" cy="30275784"/>
+  <p:sldSz cx="21384000" cy="30276000"/>
+  <p:notesSz cx="30276000" cy="21384000"/>
   <p:defaultTextStyle>
     <a:lvl1pPr marL="0" algn="l" defTabSz="914400" rtl="0" eaLnBrk="1" latinLnBrk="0" hangingPunct="1">
       <a:defRPr sz="1800" kern="1200">
@@ -105,6 +105,361 @@
     </a:lvl9pPr>
   </p:defaultTextStyle>
 </p:presentation>
+</file>
+
+<file path=ppt/charts/chart1.xml><?xml version="1.0" encoding="utf-8"?>
+<c:chartSpace xmlns:c="http://schemas.openxmlformats.org/drawingml/2006/chart" xmlns:a="http://schemas.openxmlformats.org/drawingml/2006/main" xmlns:r="http://schemas.openxmlformats.org/officeDocument/2006/relationships">
+  <c:date1904 val="0"/>
+  <c:roundedCorners val="1"/>
+  <c:chart>
+    <c:title>
+      <c:tx>
+        <c:rich>
+          <a:bodyPr/>
+          <a:lstStyle/>
+          <a:p>
+            <a:pPr>
+              <a:defRPr sz="2600" b="0" i="0" u="none" strike="noStrike">
+                <a:solidFill>
+                  <a:srgbClr val="14305C"/>
+                </a:solidFill>
+                <a:latin typeface="Calibri"/>
+              </a:defRPr>
+            </a:pPr>
+            <a:r>
+              <a:rPr sz="2600" b="0" i="0" u="none" strike="noStrike">
+                <a:solidFill>
+                  <a:srgbClr val="14305C"/>
+                </a:solidFill>
+                <a:latin typeface="Calibri"/>
+              </a:rPr>
+              <a:t>Mean weighted vibration per pass, 10 km/h (m/s²)</a:t>
+            </a:r>
+          </a:p>
+        </c:rich>
+      </c:tx>
+      <c:layout/>
+      <c:overlay val="0"/>
+    </c:title>
+    <c:autoTitleDeleted val="0"/>
+    <c:plotArea>
+      <c:layout/>
+      <c:barChart>
+        <c:barDir val="col"/>
+        <c:grouping val="clustered"/>
+        <c:varyColors val="0"/>
+        <c:ser>
+          <c:idx val="0"/>
+          <c:order val="0"/>
+          <c:tx>
+            <c:strRef>
+              <c:f>Sheet1!$B$1</c:f>
+              <c:strCache>
+                <c:ptCount val="1"/>
+                <c:pt idx="0">
+                  <c:v>Rear</c:v>
+                </c:pt>
+              </c:strCache>
+            </c:strRef>
+          </c:tx>
+          <c:spPr>
+            <a:solidFill>
+              <a:srgbClr val="14305C"/>
+            </a:solidFill>
+            <a:effectLst/>
+          </c:spPr>
+          <c:invertIfNegative val="0"/>
+          <c:dLbls>
+            <c:numFmt formatCode="0.00" sourceLinked="0"/>
+            <c:txPr>
+              <a:bodyPr/>
+              <a:lstStyle/>
+              <a:p>
+                <a:pPr>
+                  <a:defRPr b="0" i="0" strike="noStrike" sz="2400" u="none">
+                    <a:solidFill>
+                      <a:srgbClr val="1B1F24"/>
+                    </a:solidFill>
+                    <a:latin typeface="Calibri"/>
+                  </a:defRPr>
+                </a:pPr>
+              </a:p>
+            </c:txPr>
+            <c:showLegendKey val="0"/>
+            <c:showVal val="1"/>
+            <c:showCatName val="0"/>
+            <c:showSerName val="0"/>
+            <c:showPercent val="0"/>
+            <c:showBubbleSize val="0"/>
+            <c:showLeaderLines val="0"/>
+          </c:dLbls>
+          <c:cat>
+            <c:multiLvlStrRef>
+              <c:f>Sheet1!$A$2:$A$3</c:f>
+              <c:multiLvlStrCache>
+                <c:ptCount val="2"/>
+                <c:lvl>
+                  <c:pt idx="0">
+                    <c:v>Smooth loop (5 passes)</c:v>
+                  </c:pt>
+                  <c:pt idx="1">
+                    <c:v>Rough strip (4 passes)</c:v>
+                  </c:pt>
+                </c:lvl>
+              </c:multiLvlStrCache>
+            </c:multiLvlStrRef>
+          </c:cat>
+          <c:val>
+            <c:numRef>
+              <c:f>Sheet1!$B$2:$B$3</c:f>
+              <c:numCache>
+                <c:formatCode>General</c:formatCode>
+                <c:ptCount val="2"/>
+                <c:pt idx="0">
+                  <c:v>1.78</c:v>
+                </c:pt>
+                <c:pt idx="1">
+                  <c:v>3.61</c:v>
+                </c:pt>
+              </c:numCache>
+            </c:numRef>
+          </c:val>
+        </c:ser>
+        <c:ser>
+          <c:idx val="1"/>
+          <c:order val="1"/>
+          <c:tx>
+            <c:strRef>
+              <c:f>Sheet1!$C$1</c:f>
+              <c:strCache>
+                <c:ptCount val="1"/>
+                <c:pt idx="0">
+                  <c:v>Front</c:v>
+                </c:pt>
+              </c:strCache>
+            </c:strRef>
+          </c:tx>
+          <c:spPr>
+            <a:solidFill>
+              <a:srgbClr val="5B9BD5"/>
+            </a:solidFill>
+            <a:effectLst/>
+          </c:spPr>
+          <c:invertIfNegative val="0"/>
+          <c:dLbls>
+            <c:numFmt formatCode="0.00" sourceLinked="0"/>
+            <c:txPr>
+              <a:bodyPr/>
+              <a:lstStyle/>
+              <a:p>
+                <a:pPr>
+                  <a:defRPr b="0" i="0" strike="noStrike" sz="2400" u="none">
+                    <a:solidFill>
+                      <a:srgbClr val="1B1F24"/>
+                    </a:solidFill>
+                    <a:latin typeface="Calibri"/>
+                  </a:defRPr>
+                </a:pPr>
+              </a:p>
+            </c:txPr>
+            <c:showLegendKey val="0"/>
+            <c:showVal val="1"/>
+            <c:showCatName val="0"/>
+            <c:showSerName val="0"/>
+            <c:showPercent val="0"/>
+            <c:showBubbleSize val="0"/>
+            <c:showLeaderLines val="0"/>
+          </c:dLbls>
+          <c:cat>
+            <c:multiLvlStrRef>
+              <c:f>Sheet1!$A$2:$A$3</c:f>
+              <c:multiLvlStrCache>
+                <c:ptCount val="2"/>
+                <c:lvl>
+                  <c:pt idx="0">
+                    <c:v>Smooth loop (5 passes)</c:v>
+                  </c:pt>
+                  <c:pt idx="1">
+                    <c:v>Rough strip (4 passes)</c:v>
+                  </c:pt>
+                </c:lvl>
+              </c:multiLvlStrCache>
+            </c:multiLvlStrRef>
+          </c:cat>
+          <c:val>
+            <c:numRef>
+              <c:f>Sheet1!$C$2:$C$3</c:f>
+              <c:numCache>
+                <c:formatCode>General</c:formatCode>
+                <c:ptCount val="2"/>
+                <c:pt idx="0">
+                  <c:v>1.16</c:v>
+                </c:pt>
+                <c:pt idx="1">
+                  <c:v>2.26</c:v>
+                </c:pt>
+              </c:numCache>
+            </c:numRef>
+          </c:val>
+        </c:ser>
+        <c:dLbls>
+          <c:numFmt formatCode="0.00" sourceLinked="0"/>
+          <c:txPr>
+            <a:bodyPr/>
+            <a:lstStyle/>
+            <a:p>
+              <a:pPr>
+                <a:defRPr b="0" i="0" strike="noStrike" sz="2400" u="none">
+                  <a:solidFill>
+                    <a:srgbClr val="1B1F24"/>
+                  </a:solidFill>
+                  <a:latin typeface="Calibri"/>
+                </a:defRPr>
+              </a:pPr>
+            </a:p>
+          </c:txPr>
+          <c:showLegendKey val="0"/>
+          <c:showVal val="1"/>
+          <c:showCatName val="0"/>
+          <c:showSerName val="0"/>
+          <c:showPercent val="0"/>
+          <c:showBubbleSize val="0"/>
+          <c:showLeaderLines val="0"/>
+        </c:dLbls>
+        <c:gapWidth val="60"/>
+        <c:overlap val="0"/>
+        <c:axId val="2094734554"/>
+        <c:axId val="2094734552"/>
+        <c:axId val="2094734556"/>
+      </c:barChart>
+      <c:catAx>
+        <c:axId val="2094734554"/>
+        <c:scaling>
+          <c:orientation val="minMax"/>
+        </c:scaling>
+        <c:delete val="0"/>
+        <c:axPos val="b"/>
+        <c:numFmt formatCode="General" sourceLinked="1"/>
+        <c:majorTickMark val="out"/>
+        <c:minorTickMark val="none"/>
+        <c:tickLblPos val="low"/>
+        <c:spPr>
+          <a:ln w="12700" cap="flat">
+            <a:solidFill>
+              <a:srgbClr val="888888"/>
+            </a:solidFill>
+            <a:prstDash val="solid"/>
+            <a:round/>
+          </a:ln>
+        </c:spPr>
+        <c:txPr>
+          <a:bodyPr/>
+          <a:lstStyle/>
+          <a:p>
+            <a:pPr>
+              <a:defRPr sz="2400" b="0" i="0" u="none" strike="noStrike">
+                <a:solidFill>
+                  <a:srgbClr val="1B1F24"/>
+                </a:solidFill>
+                <a:latin typeface="Calibri"/>
+              </a:defRPr>
+            </a:pPr>
+            <a:endParaRPr lang="en-US"/>
+          </a:p>
+        </c:txPr>
+        <c:crossAx val="2094734552"/>
+        <c:crosses val="autoZero"/>
+        <c:auto val="1"/>
+        <c:lblAlgn val="ctr"/>
+        <c:noMultiLvlLbl val="1"/>
+      </c:catAx>
+      <c:valAx>
+        <c:axId val="2094734552"/>
+        <c:scaling>
+          <c:orientation val="minMax"/>
+          <c:max val="4.4"/>
+          <c:min val="0"/>
+        </c:scaling>
+        <c:delete val="1"/>
+        <c:axPos val="l"/>
+        <c:numFmt formatCode="General" sourceLinked="0"/>
+        <c:majorTickMark val="out"/>
+        <c:minorTickMark val="none"/>
+        <c:tickLblPos val="nextTo"/>
+        <c:spPr>
+          <a:ln w="12700" cap="flat">
+            <a:solidFill>
+              <a:srgbClr val="888888"/>
+            </a:solidFill>
+            <a:prstDash val="solid"/>
+            <a:round/>
+          </a:ln>
+        </c:spPr>
+        <c:txPr>
+          <a:bodyPr/>
+          <a:lstStyle/>
+          <a:p>
+            <a:pPr>
+              <a:defRPr sz="1200" b="0" i="0" u="none" strike="noStrike">
+                <a:solidFill>
+                  <a:srgbClr val="000000"/>
+                </a:solidFill>
+                <a:latin typeface="Arial"/>
+              </a:defRPr>
+            </a:pPr>
+            <a:endParaRPr lang="en-US"/>
+          </a:p>
+        </c:txPr>
+        <c:crossAx val="2094734554"/>
+        <c:crosses val="autoZero"/>
+        <c:crossBetween val="between"/>
+      </c:valAx>
+      <c:spPr>
+        <a:solidFill>
+          <a:srgbClr val="E8F0FA"/>
+        </a:solidFill>
+        <a:ln>
+          <a:noFill/>
+        </a:ln>
+        <a:effectLst/>
+      </c:spPr>
+    </c:plotArea>
+    <c:legend>
+      <c:legendPos val="r"/>
+      <c:overlay val="0"/>
+      <c:txPr>
+        <a:bodyPr/>
+        <a:lstStyle/>
+        <a:p>
+          <a:pPr>
+            <a:defRPr sz="2400">
+              <a:solidFill>
+                <a:srgbClr val="1B1F24"/>
+              </a:solidFill>
+              <a:latin typeface="Calibri"/>
+              <a:cs typeface="Calibri"/>
+            </a:defRPr>
+          </a:pPr>
+          <a:endParaRPr lang="en-US"/>
+        </a:p>
+      </c:txPr>
+    </c:legend>
+    <c:plotVisOnly val="1"/>
+    <c:dispBlanksAs val="span"/>
+  </c:chart>
+  <c:spPr>
+    <a:solidFill>
+      <a:srgbClr val="E8F0FA"/>
+    </a:solidFill>
+    <a:ln>
+      <a:noFill/>
+    </a:ln>
+    <a:effectLst/>
+  </c:spPr>
+  <c:externalData r:id="rId1">
+    <c:autoUpdate val="0"/>
+  </c:externalData>
+</c:chartSpace>
 </file>
 
 <file path=ppt/notesMasters/notesMaster1.xml><?xml version="1.0" encoding="utf-8"?>
@@ -891,7 +1246,7 @@
         <p:spPr>
           <a:xfrm>
             <a:off x="0" y="0"/>
-            <a:ext cx="30275784" cy="9692640"/>
+            <a:ext cx="21384000" cy="6903720"/>
           </a:xfrm>
           <a:prstGeom prst="rect">
             <a:avLst/>
@@ -900,14 +1255,87 @@
       </p:pic>
       <p:sp>
         <p:nvSpPr>
-          <p:cNvPr id="3" name="Text 0"/>
+          <p:cNvPr id="3" name="Shape 0"/>
+          <p:cNvSpPr/>
+          <p:nvPr/>
+        </p:nvSpPr>
+        <p:spPr>
+          <a:xfrm>
+            <a:off x="0" y="0"/>
+            <a:ext cx="21384000" cy="6903720"/>
+          </a:xfrm>
+          <a:prstGeom prst="rect">
+            <a:avLst/>
+          </a:prstGeom>
+          <a:solidFill>
+            <a:srgbClr val="0B1F3F">
+              <a:alpha val="65000"/>
+            </a:srgbClr>
+          </a:solidFill>
+          <a:ln/>
+        </p:spPr>
+      </p:sp>
+      <p:sp>
+        <p:nvSpPr>
+          <p:cNvPr id="4" name="Shape 1"/>
+          <p:cNvSpPr/>
+          <p:nvPr/>
+        </p:nvSpPr>
+        <p:spPr>
+          <a:xfrm>
+            <a:off x="731520" y="320040"/>
+            <a:ext cx="2240280" cy="2240280"/>
+          </a:xfrm>
+          <a:prstGeom prst="roundRect">
+            <a:avLst>
+              <a:gd name="adj" fmla="val 8163"/>
+            </a:avLst>
+          </a:prstGeom>
+          <a:solidFill>
+            <a:srgbClr val="FFFFFF"/>
+          </a:solidFill>
+          <a:ln w="12700">
+            <a:solidFill>
+              <a:srgbClr val="FFFFFF"/>
+            </a:solidFill>
+            <a:prstDash val="solid"/>
+          </a:ln>
+        </p:spPr>
+      </p:sp>
+      <p:pic>
+        <p:nvPicPr>
+          <p:cNvPr id="5" name="Image 1" descr="University of Cape Town crest">    </p:cNvPr>
+          <p:cNvPicPr>
+            <a:picLocks noChangeAspect="1"/>
+          </p:cNvPicPr>
+          <p:nvPr/>
+        </p:nvPicPr>
+        <p:blipFill>
+          <a:blip r:embed="rId2"/>
+          <a:stretch>
+            <a:fillRect/>
+          </a:stretch>
+        </p:blipFill>
+        <p:spPr>
+          <a:xfrm>
+            <a:off x="841248" y="429768"/>
+            <a:ext cx="2020824" cy="2054747"/>
+          </a:xfrm>
+          <a:prstGeom prst="rect">
+            <a:avLst/>
+          </a:prstGeom>
+        </p:spPr>
+      </p:pic>
+      <p:sp>
+        <p:nvSpPr>
+          <p:cNvPr id="6" name="Text 2"/>
           <p:cNvSpPr txBox="1"/>
           <p:nvPr/>
         </p:nvSpPr>
         <p:spPr>
           <a:xfrm>
-            <a:off x="1097280" y="411480"/>
-            <a:ext cx="28081224" cy="731520"/>
+            <a:off x="3337560" y="594360"/>
+            <a:ext cx="17314920" cy="1691640"/>
           </a:xfrm>
           <a:prstGeom prst="rect">
             <a:avLst/>
@@ -919,7 +1347,24 @@
           <a:bodyPr wrap="square" lIns="0" tIns="0" rIns="0" bIns="0" rtlCol="0" anchor="ctr"/>
           <a:lstStyle/>
           <a:p>
-            <a:pPr algn="ctr" indent="0" marL="0">
+            <a:pPr indent="0" marL="0">
+              <a:buNone/>
+            </a:pPr>
+            <a:r>
+              <a:rPr lang="en-US" sz="3000" b="1" dirty="0">
+                <a:solidFill>
+                  <a:srgbClr val="FFFFFF"/>
+                </a:solidFill>
+                <a:latin typeface="Calibri" pitchFamily="34" charset="0"/>
+                <a:ea typeface="Calibri" pitchFamily="34" charset="-122"/>
+                <a:cs typeface="Calibri" pitchFamily="34" charset="-120"/>
+              </a:rPr>
+              <a:t>Department of Electrical Engineering, University of Cape Town</a:t>
+            </a:r>
+            <a:endParaRPr lang="en-US" sz="3000" dirty="0"/>
+          </a:p>
+          <a:p>
+            <a:pPr indent="0" marL="0">
               <a:buNone/>
             </a:pPr>
             <a:r>
@@ -931,7 +1376,7 @@
                 <a:ea typeface="Calibri" pitchFamily="34" charset="-122"/>
                 <a:cs typeface="Calibri" pitchFamily="34" charset="-120"/>
               </a:rPr>
-              <a:t>EEE4022S Final Year Project 2026, Department of Electrical Engineering, University of Cape Town</a:t>
+              <a:t>EEE4022S Final Year Project 2026</a:t>
             </a:r>
             <a:endParaRPr lang="en-US" sz="3000" dirty="0"/>
           </a:p>
@@ -939,14 +1384,14 @@
       </p:sp>
       <p:sp>
         <p:nvSpPr>
-          <p:cNvPr id="4" name="Text 1"/>
+          <p:cNvPr id="7" name="Text 3"/>
           <p:cNvSpPr txBox="1"/>
           <p:nvPr/>
         </p:nvSpPr>
         <p:spPr>
           <a:xfrm>
-            <a:off x="1097280" y="1234440"/>
-            <a:ext cx="28081224" cy="3017520"/>
+            <a:off x="548640" y="2697480"/>
+            <a:ext cx="20286720" cy="3246120"/>
           </a:xfrm>
           <a:prstGeom prst="rect">
             <a:avLst/>
@@ -966,10 +1411,13 @@
           <a:lstStyle/>
           <a:p>
             <a:pPr algn="ctr" indent="0" marL="0">
-              <a:buNone/>
-            </a:pPr>
-            <a:r>
-              <a:rPr lang="en-US" sz="7800" b="1" dirty="0">
+              <a:lnSpc>
+                <a:spcPct val="92000"/>
+              </a:lnSpc>
+              <a:buNone/>
+            </a:pPr>
+            <a:r>
+              <a:rPr lang="en-US" sz="8200" b="1" dirty="0">
                 <a:solidFill>
                   <a:srgbClr val="FFFFFF"/>
                 </a:solidFill>
@@ -977,39 +1425,22 @@
                 <a:ea typeface="Calibri" pitchFamily="34" charset="-122"/>
                 <a:cs typeface="Calibri" pitchFamily="34" charset="-120"/>
               </a:rPr>
-              <a:t>Embedded Telemetry with Road-Surface Characterisation</a:t>
-            </a:r>
-            <a:endParaRPr lang="en-US" sz="7800" dirty="0"/>
-          </a:p>
-          <a:p>
-            <a:pPr algn="ctr" indent="0" marL="0">
-              <a:buNone/>
-            </a:pPr>
-            <a:r>
-              <a:rPr lang="en-US" sz="7800" b="1" dirty="0">
-                <a:solidFill>
-                  <a:srgbClr val="FFFFFF"/>
-                </a:solidFill>
-                <a:latin typeface="Calibri" pitchFamily="34" charset="0"/>
-                <a:ea typeface="Calibri" pitchFamily="34" charset="-122"/>
-                <a:cs typeface="Calibri" pitchFamily="34" charset="-120"/>
-              </a:rPr>
-              <a:t>and Camera-Based Hazard Detection for the TUKZIE Electric Trike</a:t>
-            </a:r>
-            <a:endParaRPr lang="en-US" sz="7800" dirty="0"/>
-          </a:p>
-        </p:txBody>
-      </p:sp>
-      <p:sp>
-        <p:nvSpPr>
-          <p:cNvPr id="5" name="Text 2"/>
+              <a:t>Embedded Telemetry with Road-Surface Characterisation and Camera-Based Hazard Detection for the TUKZIE Electric Trike</a:t>
+            </a:r>
+            <a:endParaRPr lang="en-US" sz="8200" dirty="0"/>
+          </a:p>
+        </p:txBody>
+      </p:sp>
+      <p:sp>
+        <p:nvSpPr>
+          <p:cNvPr id="8" name="Text 4"/>
           <p:cNvSpPr txBox="1"/>
           <p:nvPr/>
         </p:nvSpPr>
         <p:spPr>
           <a:xfrm>
-            <a:off x="1097280" y="4434840"/>
-            <a:ext cx="28081224" cy="822960"/>
+            <a:off x="731520" y="6035040"/>
+            <a:ext cx="19920960" cy="640080"/>
           </a:xfrm>
           <a:prstGeom prst="rect">
             <a:avLst/>
@@ -1032,7 +1463,7 @@
               <a:buNone/>
             </a:pPr>
             <a:r>
-              <a:rPr lang="en-US" sz="3400" b="1" dirty="0">
+              <a:rPr lang="en-US" sz="3200" b="1" dirty="0">
                 <a:solidFill>
                   <a:srgbClr val="FFFFFF"/>
                 </a:solidFill>
@@ -1040,26 +1471,40 @@
                 <a:ea typeface="Calibri" pitchFamily="34" charset="-122"/>
                 <a:cs typeface="Calibri" pitchFamily="34" charset="-120"/>
               </a:rPr>
-              <a:t>Samson Okuthe (OKTSAM001)   |   Supervisor: A/Prof. Simon Winberg   |   Co-supervisor: Sampath Jayalath</a:t>
-            </a:r>
-            <a:endParaRPr lang="en-US" sz="3400" dirty="0"/>
-          </a:p>
-        </p:txBody>
-      </p:sp>
-      <p:sp>
-        <p:nvSpPr>
-          <p:cNvPr id="6" name="Shape 3"/>
+              <a:t>Samson Okuthe</a:t>
+            </a:r>
+            <a:pPr algn="ctr" indent="0" marL="0">
+              <a:buNone/>
+            </a:pPr>
+            <a:r>
+              <a:rPr lang="en-US" sz="3200" dirty="0">
+                <a:solidFill>
+                  <a:srgbClr val="FFFFFF"/>
+                </a:solidFill>
+                <a:latin typeface="Calibri" pitchFamily="34" charset="0"/>
+                <a:ea typeface="Calibri" pitchFamily="34" charset="-122"/>
+                <a:cs typeface="Calibri" pitchFamily="34" charset="-120"/>
+              </a:rPr>
+              <a:t>   |   Supervisor: A/Prof Simon Winberg   |   Co-supervisor: Sampath Jayalath</a:t>
+            </a:r>
+            <a:endParaRPr lang="en-US" sz="3200" dirty="0"/>
+          </a:p>
+        </p:txBody>
+      </p:sp>
+      <p:sp>
+        <p:nvSpPr>
+          <p:cNvPr id="9" name="Shape 5"/>
           <p:cNvSpPr/>
           <p:nvPr/>
         </p:nvSpPr>
         <p:spPr>
           <a:xfrm>
-            <a:off x="1097280" y="10515600"/>
-            <a:ext cx="13629132" cy="6035040"/>
+            <a:off x="731520" y="7406640"/>
+            <a:ext cx="9709020" cy="6035040"/>
           </a:xfrm>
           <a:prstGeom prst="roundRect">
             <a:avLst>
-              <a:gd name="adj" fmla="val 5303"/>
+              <a:gd name="adj" fmla="val 4545"/>
             </a:avLst>
           </a:prstGeom>
           <a:solidFill>
@@ -1075,14 +1520,14 @@
       </p:sp>
       <p:sp>
         <p:nvSpPr>
-          <p:cNvPr id="7" name="Shape 4"/>
+          <p:cNvPr id="10" name="Shape 6"/>
           <p:cNvSpPr/>
           <p:nvPr/>
         </p:nvSpPr>
         <p:spPr>
           <a:xfrm>
-            <a:off x="1600200" y="10972800"/>
-            <a:ext cx="1143000" cy="1143000"/>
+            <a:off x="1097280" y="7726680"/>
+            <a:ext cx="914400" cy="914400"/>
           </a:xfrm>
           <a:prstGeom prst="ellipse">
             <a:avLst/>
@@ -1100,14 +1545,14 @@
       </p:sp>
       <p:sp>
         <p:nvSpPr>
-          <p:cNvPr id="8" name="Text 5"/>
+          <p:cNvPr id="11" name="Text 7"/>
           <p:cNvSpPr txBox="1"/>
           <p:nvPr/>
         </p:nvSpPr>
         <p:spPr>
           <a:xfrm>
-            <a:off x="1600200" y="10972800"/>
-            <a:ext cx="1143000" cy="1143000"/>
+            <a:off x="1097280" y="7726680"/>
+            <a:ext cx="914400" cy="914400"/>
           </a:xfrm>
           <a:prstGeom prst="rect">
             <a:avLst/>
@@ -1123,7 +1568,7 @@
               <a:buNone/>
             </a:pPr>
             <a:r>
-              <a:rPr lang="en-US" sz="4400" b="1" dirty="0">
+              <a:rPr lang="en-US" sz="4000" b="1" dirty="0">
                 <a:solidFill>
                   <a:srgbClr val="FFFFFF"/>
                 </a:solidFill>
@@ -1133,20 +1578,20 @@
               </a:rPr>
               <a:t>1</a:t>
             </a:r>
-            <a:endParaRPr lang="en-US" sz="4400" dirty="0"/>
-          </a:p>
-        </p:txBody>
-      </p:sp>
-      <p:sp>
-        <p:nvSpPr>
-          <p:cNvPr id="9" name="Text 6"/>
+            <a:endParaRPr lang="en-US" sz="4000" dirty="0"/>
+          </a:p>
+        </p:txBody>
+      </p:sp>
+      <p:sp>
+        <p:nvSpPr>
+          <p:cNvPr id="12" name="Text 8"/>
           <p:cNvSpPr txBox="1"/>
           <p:nvPr/>
         </p:nvSpPr>
         <p:spPr>
           <a:xfrm>
-            <a:off x="3063240" y="10927080"/>
-            <a:ext cx="11251692" cy="1234440"/>
+            <a:off x="2240280" y="7680960"/>
+            <a:ext cx="7880220" cy="1005840"/>
           </a:xfrm>
           <a:prstGeom prst="rect">
             <a:avLst/>
@@ -1162,7 +1607,7 @@
               <a:buNone/>
             </a:pPr>
             <a:r>
-              <a:rPr lang="en-US" sz="5600" b="1" dirty="0">
+              <a:rPr lang="en-US" sz="4800" b="1" dirty="0">
                 <a:solidFill>
                   <a:srgbClr val="14305C"/>
                 </a:solidFill>
@@ -1170,22 +1615,22 @@
                 <a:ea typeface="Calibri" pitchFamily="34" charset="-122"/>
                 <a:cs typeface="Calibri" pitchFamily="34" charset="-120"/>
               </a:rPr>
-              <a:t>Background</a:t>
-            </a:r>
-            <a:endParaRPr lang="en-US" sz="5600" dirty="0"/>
-          </a:p>
-        </p:txBody>
-      </p:sp>
-      <p:sp>
-        <p:nvSpPr>
-          <p:cNvPr id="10" name="Text 7"/>
+              <a:t>Problem and aim</a:t>
+            </a:r>
+            <a:endParaRPr lang="en-US" sz="4800" dirty="0"/>
+          </a:p>
+        </p:txBody>
+      </p:sp>
+      <p:sp>
+        <p:nvSpPr>
+          <p:cNvPr id="13" name="Text 9"/>
           <p:cNvSpPr txBox="1"/>
           <p:nvPr/>
         </p:nvSpPr>
         <p:spPr>
           <a:xfrm>
-            <a:off x="1737360" y="12527280"/>
-            <a:ext cx="12348972" cy="3840480"/>
+            <a:off x="1188720" y="8915400"/>
+            <a:ext cx="5228460" cy="4297680"/>
           </a:xfrm>
           <a:prstGeom prst="rect">
             <a:avLst/>
@@ -1197,15 +1642,15 @@
           <a:bodyPr wrap="square" lIns="0" tIns="0" rIns="0" bIns="0" rtlCol="0" anchor="t"/>
           <a:lstStyle/>
           <a:p>
-            <a:pPr marL="406400" indent="-406400">
+            <a:pPr marL="355600" indent="-355600">
               <a:spcAft>
-                <a:spcPts val="1400"/>
+                <a:spcPts val="1000"/>
               </a:spcAft>
               <a:buSzPct val="100000"/>
               <a:buChar char="•"/>
             </a:pPr>
             <a:r>
-              <a:rPr lang="en-US" sz="3000" dirty="0">
+              <a:rPr lang="en-US" sz="2800" dirty="0">
                 <a:solidFill>
                   <a:srgbClr val="1B1F24"/>
                 </a:solidFill>
@@ -1213,20 +1658,34 @@
                 <a:ea typeface="Calibri" pitchFamily="34" charset="-122"/>
                 <a:cs typeface="Calibri" pitchFamily="34" charset="-120"/>
               </a:rPr>
-              <a:t>Electric cargo trikes are a low-cost route to last-mile freight in African cities, but their ride and road conditions go unmeasured.</a:t>
-            </a:r>
-            <a:endParaRPr lang="en-US" sz="3000" dirty="0"/>
-          </a:p>
-          <a:p>
-            <a:pPr marL="406400" indent="-406400">
-              <a:spcAft>
-                <a:spcPts val="1400"/>
-              </a:spcAft>
+              <a:t>Electric cargo trikes such as the TUKZIE carry last-mile freight cheaply, but their ride and the roads they use go unmeasured.</a:t>
+            </a:r>
+            <a:endParaRPr lang="en-US" sz="2800" dirty="0"/>
+          </a:p>
+          <a:p>
+            <a:pPr marL="355600" indent="-355600">
               <a:buSzPct val="100000"/>
               <a:buChar char="•"/>
             </a:pPr>
             <a:r>
-              <a:rPr lang="en-US" sz="3000" dirty="0">
+              <a:rPr lang="en-US" sz="2800" b="1" dirty="0">
+                <a:solidFill>
+                  <a:srgbClr val="14305C"/>
+                </a:solidFill>
+                <a:latin typeface="Calibri" pitchFamily="34" charset="0"/>
+                <a:ea typeface="Calibri" pitchFamily="34" charset="-122"/>
+                <a:cs typeface="Calibri" pitchFamily="34" charset="-120"/>
+              </a:rPr>
+              <a:t>Aim: </a:t>
+            </a:r>
+            <a:pPr indent="0" marL="0">
+              <a:spcAft>
+                <a:spcPts val="1000"/>
+              </a:spcAft>
+              <a:buNone/>
+            </a:pPr>
+            <a:r>
+              <a:rPr lang="en-US" sz="2800" dirty="0">
                 <a:solidFill>
                   <a:srgbClr val="1B1F24"/>
                 </a:solidFill>
@@ -1234,47 +1693,110 @@
                 <a:ea typeface="Calibri" pitchFamily="34" charset="-122"/>
                 <a:cs typeface="Calibri" pitchFamily="34" charset="-120"/>
               </a:rPr>
-              <a:t>Head-down displays draw the driver's eyes off the road; single glances should stay under 2 s.</a:t>
-            </a:r>
-            <a:endParaRPr lang="en-US" sz="3000" dirty="0"/>
-          </a:p>
-          <a:p>
-            <a:pPr marL="406400" indent="-406400">
-              <a:spcAft>
-                <a:spcPts val="1400"/>
-              </a:spcAft>
-              <a:buSzPct val="100000"/>
-              <a:buChar char="•"/>
-            </a:pPr>
-            <a:r>
-              <a:rPr lang="en-US" sz="3000" dirty="0">
-                <a:solidFill>
-                  <a:srgbClr val="1B1F24"/>
-                </a:solidFill>
-                <a:latin typeface="Calibri" pitchFamily="34" charset="0"/>
-                <a:ea typeface="Calibri" pitchFamily="34" charset="-122"/>
-                <a:cs typeface="Calibri" pitchFamily="34" charset="-120"/>
-              </a:rPr>
-              <a:t>Aim: a low-cost unit that characterises the ride at the edge and gives the driver only safety-relevant alerts, each stage tested before the next.</a:t>
-            </a:r>
-            <a:endParaRPr lang="en-US" sz="3000" dirty="0"/>
-          </a:p>
-        </p:txBody>
-      </p:sp>
-      <p:sp>
-        <p:nvSpPr>
-          <p:cNvPr id="11" name="Shape 8"/>
+              <a:t>a low-cost unit that measures the ride at both ends, warns the driver of hazards and keeps its data through coverage gaps.</a:t>
+            </a:r>
+            <a:endParaRPr lang="en-US" sz="2800" dirty="0"/>
+          </a:p>
+        </p:txBody>
+      </p:sp>
+      <p:pic>
+        <p:nvPicPr>
+          <p:cNvPr id="14" name="Image 2" descr="The trike on the road test of 27 October 2026, side view">    </p:cNvPr>
+          <p:cNvPicPr>
+            <a:picLocks noChangeAspect="1"/>
+          </p:cNvPicPr>
+          <p:nvPr/>
+        </p:nvPicPr>
+        <p:blipFill>
+          <a:blip r:embed="rId3"/>
+          <a:srcRect l="0" r="0" t="0" b="0"/>
+          <a:stretch/>
+        </p:blipFill>
+        <p:spPr>
+          <a:xfrm>
+            <a:off x="6737220" y="8961120"/>
+            <a:ext cx="3246120" cy="2700044"/>
+          </a:xfrm>
+          <a:prstGeom prst="rect">
+            <a:avLst/>
+          </a:prstGeom>
+        </p:spPr>
+      </p:pic>
+      <p:sp>
+        <p:nvSpPr>
+          <p:cNvPr id="15" name="Shape 10"/>
           <p:cNvSpPr/>
           <p:nvPr/>
         </p:nvSpPr>
         <p:spPr>
           <a:xfrm>
-            <a:off x="1097280" y="17373600"/>
-            <a:ext cx="13629132" cy="9144000"/>
+            <a:off x="6737220" y="8961120"/>
+            <a:ext cx="3246120" cy="2700044"/>
+          </a:xfrm>
+          <a:prstGeom prst="rect">
+            <a:avLst/>
+          </a:prstGeom>
+          <a:ln w="38100">
+            <a:solidFill>
+              <a:srgbClr val="FFFFFF"/>
+            </a:solidFill>
+            <a:prstDash val="solid"/>
+          </a:ln>
+        </p:spPr>
+      </p:sp>
+      <p:sp>
+        <p:nvSpPr>
+          <p:cNvPr id="16" name="Text 11"/>
+          <p:cNvSpPr txBox="1"/>
+          <p:nvPr/>
+        </p:nvSpPr>
+        <p:spPr>
+          <a:xfrm>
+            <a:off x="6737220" y="11706884"/>
+            <a:ext cx="3246120" cy="457200"/>
+          </a:xfrm>
+          <a:prstGeom prst="rect">
+            <a:avLst/>
+          </a:prstGeom>
+          <a:noFill/>
+          <a:ln/>
+        </p:spPr>
+        <p:txBody>
+          <a:bodyPr wrap="square" lIns="0" tIns="0" rIns="0" bIns="0" rtlCol="0" anchor="t"/>
+          <a:lstStyle/>
+          <a:p>
+            <a:pPr algn="ctr" indent="0" marL="0">
+              <a:buNone/>
+            </a:pPr>
+            <a:r>
+              <a:rPr lang="en-US" sz="2400" i="1" dirty="0">
+                <a:solidFill>
+                  <a:srgbClr val="3F4A5A"/>
+                </a:solidFill>
+                <a:latin typeface="Calibri" pitchFamily="34" charset="0"/>
+                <a:ea typeface="Calibri" pitchFamily="34" charset="-122"/>
+                <a:cs typeface="Calibri" pitchFamily="34" charset="-120"/>
+              </a:rPr>
+              <a:t>Road test, 27 Oct</a:t>
+            </a:r>
+            <a:endParaRPr lang="en-US" sz="2400" dirty="0"/>
+          </a:p>
+        </p:txBody>
+      </p:sp>
+      <p:sp>
+        <p:nvSpPr>
+          <p:cNvPr id="17" name="Shape 12"/>
+          <p:cNvSpPr/>
+          <p:nvPr/>
+        </p:nvSpPr>
+        <p:spPr>
+          <a:xfrm>
+            <a:off x="731520" y="13944600"/>
+            <a:ext cx="9709020" cy="9509760"/>
           </a:xfrm>
           <a:prstGeom prst="roundRect">
             <a:avLst>
-              <a:gd name="adj" fmla="val 3500"/>
+              <a:gd name="adj" fmla="val 2885"/>
             </a:avLst>
           </a:prstGeom>
           <a:solidFill>
@@ -1290,14 +1812,14 @@
       </p:sp>
       <p:sp>
         <p:nvSpPr>
-          <p:cNvPr id="12" name="Shape 9"/>
+          <p:cNvPr id="18" name="Shape 13"/>
           <p:cNvSpPr/>
           <p:nvPr/>
         </p:nvSpPr>
         <p:spPr>
           <a:xfrm>
-            <a:off x="1600200" y="17830800"/>
-            <a:ext cx="1143000" cy="1143000"/>
+            <a:off x="1097280" y="14264640"/>
+            <a:ext cx="914400" cy="914400"/>
           </a:xfrm>
           <a:prstGeom prst="ellipse">
             <a:avLst/>
@@ -1315,14 +1837,14 @@
       </p:sp>
       <p:sp>
         <p:nvSpPr>
-          <p:cNvPr id="13" name="Text 10"/>
+          <p:cNvPr id="19" name="Text 14"/>
           <p:cNvSpPr txBox="1"/>
           <p:nvPr/>
         </p:nvSpPr>
         <p:spPr>
           <a:xfrm>
-            <a:off x="1600200" y="17830800"/>
-            <a:ext cx="1143000" cy="1143000"/>
+            <a:off x="1097280" y="14264640"/>
+            <a:ext cx="914400" cy="914400"/>
           </a:xfrm>
           <a:prstGeom prst="rect">
             <a:avLst/>
@@ -1338,7 +1860,7 @@
               <a:buNone/>
             </a:pPr>
             <a:r>
-              <a:rPr lang="en-US" sz="4400" b="1" dirty="0">
+              <a:rPr lang="en-US" sz="4000" b="1" dirty="0">
                 <a:solidFill>
                   <a:srgbClr val="FFFFFF"/>
                 </a:solidFill>
@@ -1348,20 +1870,20 @@
               </a:rPr>
               <a:t>2</a:t>
             </a:r>
-            <a:endParaRPr lang="en-US" sz="4400" dirty="0"/>
-          </a:p>
-        </p:txBody>
-      </p:sp>
-      <p:sp>
-        <p:nvSpPr>
-          <p:cNvPr id="14" name="Text 11"/>
+            <a:endParaRPr lang="en-US" sz="4000" dirty="0"/>
+          </a:p>
+        </p:txBody>
+      </p:sp>
+      <p:sp>
+        <p:nvSpPr>
+          <p:cNvPr id="20" name="Text 15"/>
           <p:cNvSpPr txBox="1"/>
           <p:nvPr/>
         </p:nvSpPr>
         <p:spPr>
           <a:xfrm>
-            <a:off x="3063240" y="17785080"/>
-            <a:ext cx="11251692" cy="1234440"/>
+            <a:off x="2240280" y="14218920"/>
+            <a:ext cx="7880220" cy="1005840"/>
           </a:xfrm>
           <a:prstGeom prst="rect">
             <a:avLst/>
@@ -1377,7 +1899,7 @@
               <a:buNone/>
             </a:pPr>
             <a:r>
-              <a:rPr lang="en-US" sz="5600" b="1" dirty="0">
+              <a:rPr lang="en-US" sz="4800" b="1" dirty="0">
                 <a:solidFill>
                   <a:srgbClr val="14305C"/>
                 </a:solidFill>
@@ -1385,26 +1907,26 @@
                 <a:ea typeface="Calibri" pitchFamily="34" charset="-122"/>
                 <a:cs typeface="Calibri" pitchFamily="34" charset="-120"/>
               </a:rPr>
-              <a:t>System: front and rear</a:t>
-            </a:r>
-            <a:endParaRPr lang="en-US" sz="5600" dirty="0"/>
-          </a:p>
-        </p:txBody>
-      </p:sp>
-      <p:sp>
-        <p:nvSpPr>
-          <p:cNvPr id="15" name="Shape 12"/>
+              <a:t>System on the trike, 27 Oct</a:t>
+            </a:r>
+            <a:endParaRPr lang="en-US" sz="4800" dirty="0"/>
+          </a:p>
+        </p:txBody>
+      </p:sp>
+      <p:sp>
+        <p:nvSpPr>
+          <p:cNvPr id="21" name="Shape 16"/>
           <p:cNvSpPr/>
           <p:nvPr/>
         </p:nvSpPr>
         <p:spPr>
           <a:xfrm>
-            <a:off x="1737360" y="19385280"/>
-            <a:ext cx="4802886" cy="5760720"/>
+            <a:off x="1188720" y="15453360"/>
+            <a:ext cx="3703320" cy="3794760"/>
           </a:xfrm>
           <a:prstGeom prst="roundRect">
             <a:avLst>
-              <a:gd name="adj" fmla="val 3808"/>
+              <a:gd name="adj" fmla="val 3704"/>
             </a:avLst>
           </a:prstGeom>
           <a:solidFill>
@@ -1420,14 +1942,14 @@
       </p:sp>
       <p:sp>
         <p:nvSpPr>
-          <p:cNvPr id="16" name="Text 13"/>
+          <p:cNvPr id="22" name="Text 17"/>
           <p:cNvSpPr txBox="1"/>
           <p:nvPr/>
         </p:nvSpPr>
         <p:spPr>
           <a:xfrm>
-            <a:off x="2057400" y="19613880"/>
-            <a:ext cx="4162806" cy="1188720"/>
+            <a:off x="1417320" y="15590520"/>
+            <a:ext cx="3246120" cy="548640"/>
           </a:xfrm>
           <a:prstGeom prst="rect">
             <a:avLst/>
@@ -1443,7 +1965,7 @@
               <a:buNone/>
             </a:pPr>
             <a:r>
-              <a:rPr lang="en-US" sz="3000" b="1" dirty="0">
+              <a:rPr lang="en-US" sz="2800" b="1" dirty="0">
                 <a:solidFill>
                   <a:srgbClr val="14305C"/>
                 </a:solidFill>
@@ -1451,39 +1973,22 @@
                 <a:ea typeface="Calibri" pitchFamily="34" charset="-122"/>
                 <a:cs typeface="Calibri" pitchFamily="34" charset="-120"/>
               </a:rPr>
-              <a:t>Front: Raspberry Pi 5,</a:t>
-            </a:r>
-            <a:endParaRPr lang="en-US" sz="3000" dirty="0"/>
-          </a:p>
-          <a:p>
-            <a:pPr indent="0" marL="0">
-              <a:buNone/>
-            </a:pPr>
-            <a:r>
-              <a:rPr lang="en-US" sz="3000" b="1" dirty="0">
-                <a:solidFill>
-                  <a:srgbClr val="14305C"/>
-                </a:solidFill>
-                <a:latin typeface="Calibri" pitchFamily="34" charset="0"/>
-                <a:ea typeface="Calibri" pitchFamily="34" charset="-122"/>
-                <a:cs typeface="Calibri" pitchFamily="34" charset="-120"/>
-              </a:rPr>
-              <a:t>behind the dashboard</a:t>
-            </a:r>
-            <a:endParaRPr lang="en-US" sz="3000" dirty="0"/>
-          </a:p>
-        </p:txBody>
-      </p:sp>
-      <p:sp>
-        <p:nvSpPr>
-          <p:cNvPr id="17" name="Text 14"/>
+              <a:t>Front: Raspberry Pi 5</a:t>
+            </a:r>
+            <a:endParaRPr lang="en-US" sz="2800" dirty="0"/>
+          </a:p>
+        </p:txBody>
+      </p:sp>
+      <p:sp>
+        <p:nvSpPr>
+          <p:cNvPr id="23" name="Text 18"/>
           <p:cNvSpPr txBox="1"/>
           <p:nvPr/>
         </p:nvSpPr>
         <p:spPr>
           <a:xfrm>
-            <a:off x="2057400" y="20894040"/>
-            <a:ext cx="4162806" cy="4114800"/>
+            <a:off x="1417320" y="16230600"/>
+            <a:ext cx="3337560" cy="2926080"/>
           </a:xfrm>
           <a:prstGeom prst="rect">
             <a:avLst/>
@@ -1495,9 +2000,9 @@
           <a:bodyPr wrap="square" lIns="0" tIns="0" rIns="0" bIns="0" rtlCol="0" anchor="t"/>
           <a:lstStyle/>
           <a:p>
-            <a:pPr marL="406400" indent="-406400">
+            <a:pPr marL="279400" indent="-279400">
               <a:spcAft>
-                <a:spcPts val="1400"/>
+                <a:spcPts val="600"/>
               </a:spcAft>
               <a:buSzPct val="100000"/>
               <a:buChar char="•"/>
@@ -1511,14 +2016,14 @@
                 <a:ea typeface="Calibri" pitchFamily="34" charset="-122"/>
                 <a:cs typeface="Calibri" pitchFamily="34" charset="-120"/>
               </a:rPr>
-              <a:t>Front camera, detector and time-of-flight board</a:t>
+              <a:t>Front camera, detector</a:t>
             </a:r>
             <a:endParaRPr lang="en-US" sz="2400" dirty="0"/>
           </a:p>
           <a:p>
-            <a:pPr marL="406400" indent="-406400">
+            <a:pPr marL="279400" indent="-279400">
               <a:spcAft>
-                <a:spcPts val="1400"/>
+                <a:spcPts val="600"/>
               </a:spcAft>
               <a:buSzPct val="100000"/>
               <a:buChar char="•"/>
@@ -1532,14 +2037,14 @@
                 <a:ea typeface="Calibri" pitchFamily="34" charset="-122"/>
                 <a:cs typeface="Calibri" pitchFamily="34" charset="-120"/>
               </a:rPr>
-              <a:t>Front node: ESP32-S3 with one IMU at 200 Hz</a:t>
+              <a:t>Dashboard, 10.1 in screen</a:t>
             </a:r>
             <a:endParaRPr lang="en-US" sz="2400" dirty="0"/>
           </a:p>
           <a:p>
-            <a:pPr marL="406400" indent="-406400">
+            <a:pPr marL="279400" indent="-279400">
               <a:spcAft>
-                <a:spcPts val="1400"/>
+                <a:spcPts val="600"/>
               </a:spcAft>
               <a:buSzPct val="100000"/>
               <a:buChar char="•"/>
@@ -1553,14 +2058,14 @@
                 <a:ea typeface="Calibri" pitchFamily="34" charset="-122"/>
                 <a:cs typeface="Calibri" pitchFamily="34" charset="-120"/>
               </a:rPr>
-              <a:t>Dashboard on the 10.1 in touchscreen</a:t>
+              <a:t>Front node: ESP32-S3, IMU at 200 Hz</a:t>
             </a:r>
             <a:endParaRPr lang="en-US" sz="2400" dirty="0"/>
           </a:p>
           <a:p>
-            <a:pPr marL="406400" indent="-406400">
+            <a:pPr marL="279400" indent="-279400">
               <a:spcAft>
-                <a:spcPts val="1400"/>
+                <a:spcPts val="600"/>
               </a:spcAft>
               <a:buSzPct val="100000"/>
               <a:buChar char="•"/>
@@ -1574,7 +2079,7 @@
                 <a:ea typeface="Calibri" pitchFamily="34" charset="-122"/>
                 <a:cs typeface="Calibri" pitchFamily="34" charset="-120"/>
               </a:rPr>
-              <a:t>Phone GNSS for speed; road recorder</a:t>
+              <a:t>Recorder; phone GNSS</a:t>
             </a:r>
             <a:endParaRPr lang="en-US" sz="2400" dirty="0"/>
           </a:p>
@@ -1582,18 +2087,18 @@
       </p:sp>
       <p:sp>
         <p:nvSpPr>
-          <p:cNvPr id="18" name="Shape 15"/>
+          <p:cNvPr id="24" name="Shape 19"/>
           <p:cNvSpPr/>
           <p:nvPr/>
         </p:nvSpPr>
         <p:spPr>
           <a:xfrm>
-            <a:off x="9283446" y="19385280"/>
-            <a:ext cx="4802886" cy="5760720"/>
+            <a:off x="6280020" y="15453360"/>
+            <a:ext cx="3703320" cy="3794760"/>
           </a:xfrm>
           <a:prstGeom prst="roundRect">
             <a:avLst>
-              <a:gd name="adj" fmla="val 3808"/>
+              <a:gd name="adj" fmla="val 3704"/>
             </a:avLst>
           </a:prstGeom>
           <a:solidFill>
@@ -1609,14 +2114,14 @@
       </p:sp>
       <p:sp>
         <p:nvSpPr>
-          <p:cNvPr id="19" name="Text 16"/>
+          <p:cNvPr id="25" name="Text 20"/>
           <p:cNvSpPr txBox="1"/>
           <p:nvPr/>
         </p:nvSpPr>
         <p:spPr>
           <a:xfrm>
-            <a:off x="9603486" y="19613880"/>
-            <a:ext cx="4162806" cy="1188720"/>
+            <a:off x="6508620" y="15590520"/>
+            <a:ext cx="3246120" cy="548640"/>
           </a:xfrm>
           <a:prstGeom prst="rect">
             <a:avLst/>
@@ -1632,7 +2137,7 @@
               <a:buNone/>
             </a:pPr>
             <a:r>
-              <a:rPr lang="en-US" sz="3000" b="1" dirty="0">
+              <a:rPr lang="en-US" sz="2800" b="1" dirty="0">
                 <a:solidFill>
                   <a:srgbClr val="14305C"/>
                 </a:solidFill>
@@ -1640,39 +2145,22 @@
                 <a:ea typeface="Calibri" pitchFamily="34" charset="-122"/>
                 <a:cs typeface="Calibri" pitchFamily="34" charset="-120"/>
               </a:rPr>
-              <a:t>Rear: Raspberry Pi 4,</a:t>
-            </a:r>
-            <a:endParaRPr lang="en-US" sz="3000" dirty="0"/>
-          </a:p>
-          <a:p>
-            <a:pPr indent="0" marL="0">
-              <a:buNone/>
-            </a:pPr>
-            <a:r>
-              <a:rPr lang="en-US" sz="3000" b="1" dirty="0">
-                <a:solidFill>
-                  <a:srgbClr val="14305C"/>
-                </a:solidFill>
-                <a:latin typeface="Calibri" pitchFamily="34" charset="0"/>
-                <a:ea typeface="Calibri" pitchFamily="34" charset="-122"/>
-                <a:cs typeface="Calibri" pitchFamily="34" charset="-120"/>
-              </a:rPr>
-              <a:t>beside the battery</a:t>
-            </a:r>
-            <a:endParaRPr lang="en-US" sz="3000" dirty="0"/>
-          </a:p>
-        </p:txBody>
-      </p:sp>
-      <p:sp>
-        <p:nvSpPr>
-          <p:cNvPr id="20" name="Text 17"/>
+              <a:t>Rear: Raspberry Pi 4</a:t>
+            </a:r>
+            <a:endParaRPr lang="en-US" sz="2800" dirty="0"/>
+          </a:p>
+        </p:txBody>
+      </p:sp>
+      <p:sp>
+        <p:nvSpPr>
+          <p:cNvPr id="26" name="Text 21"/>
           <p:cNvSpPr txBox="1"/>
           <p:nvPr/>
         </p:nvSpPr>
         <p:spPr>
           <a:xfrm>
-            <a:off x="9603486" y="20894040"/>
-            <a:ext cx="4162806" cy="4114800"/>
+            <a:off x="6508620" y="16230600"/>
+            <a:ext cx="3337560" cy="2926080"/>
           </a:xfrm>
           <a:prstGeom prst="rect">
             <a:avLst/>
@@ -1684,9 +2172,9 @@
           <a:bodyPr wrap="square" lIns="0" tIns="0" rIns="0" bIns="0" rtlCol="0" anchor="t"/>
           <a:lstStyle/>
           <a:p>
-            <a:pPr marL="406400" indent="-406400">
+            <a:pPr marL="279400" indent="-279400">
               <a:spcAft>
-                <a:spcPts val="1400"/>
+                <a:spcPts val="600"/>
               </a:spcAft>
               <a:buSzPct val="100000"/>
               <a:buChar char="•"/>
@@ -1700,14 +2188,14 @@
                 <a:ea typeface="Calibri" pitchFamily="34" charset="-122"/>
                 <a:cs typeface="Calibri" pitchFamily="34" charset="-120"/>
               </a:rPr>
-              <a:t>Rear camera, detector and time-of-flight board</a:t>
+              <a:t>Rear camera, detector</a:t>
             </a:r>
             <a:endParaRPr lang="en-US" sz="2400" dirty="0"/>
           </a:p>
           <a:p>
-            <a:pPr marL="406400" indent="-406400">
+            <a:pPr marL="279400" indent="-279400">
               <a:spcAft>
-                <a:spcPts val="1400"/>
+                <a:spcPts val="600"/>
               </a:spcAft>
               <a:buSzPct val="100000"/>
               <a:buChar char="•"/>
@@ -1721,14 +2209,14 @@
                 <a:ea typeface="Calibri" pitchFamily="34" charset="-122"/>
                 <a:cs typeface="Calibri" pitchFamily="34" charset="-120"/>
               </a:rPr>
-              <a:t>Rear node: ESP32-S3 with one IMU at 200 Hz</a:t>
+              <a:t>Rear node: ESP32-S3, IMU at 200 Hz</a:t>
             </a:r>
             <a:endParaRPr lang="en-US" sz="2400" dirty="0"/>
           </a:p>
           <a:p>
-            <a:pPr marL="406400" indent="-406400">
+            <a:pPr marL="279400" indent="-279400">
               <a:spcAft>
-                <a:spcPts val="1400"/>
+                <a:spcPts val="600"/>
               </a:spcAft>
               <a:buSzPct val="100000"/>
               <a:buChar char="•"/>
@@ -1742,43 +2230,22 @@
                 <a:ea typeface="Calibri" pitchFamily="34" charset="-122"/>
                 <a:cs typeface="Calibri" pitchFamily="34" charset="-120"/>
               </a:rPr>
-              <a:t>LTE, GNSS, battery over Bluetooth</a:t>
+              <a:t>Telemetry unit: ESP32-S3 with battery, GNSS and LTE</a:t>
             </a:r>
             <a:endParaRPr lang="en-US" sz="2400" dirty="0"/>
           </a:p>
-          <a:p>
-            <a:pPr marL="406400" indent="-406400">
-              <a:spcAft>
-                <a:spcPts val="1400"/>
-              </a:spcAft>
-              <a:buSzPct val="100000"/>
-              <a:buChar char="•"/>
-            </a:pPr>
-            <a:r>
-              <a:rPr lang="en-US" sz="2400" dirty="0">
-                <a:solidFill>
-                  <a:srgbClr val="1B1F24"/>
-                </a:solidFill>
-                <a:latin typeface="Calibri" pitchFamily="34" charset="0"/>
-                <a:ea typeface="Calibri" pitchFamily="34" charset="-122"/>
-                <a:cs typeface="Calibri" pitchFamily="34" charset="-120"/>
-              </a:rPr>
-              <a:t>Local log and LTE uplink to a database</a:t>
-            </a:r>
-            <a:endParaRPr lang="en-US" sz="2400" dirty="0"/>
-          </a:p>
-        </p:txBody>
-      </p:sp>
-      <p:sp>
-        <p:nvSpPr>
-          <p:cNvPr id="21" name="Shape 18"/>
+        </p:txBody>
+      </p:sp>
+      <p:sp>
+        <p:nvSpPr>
+          <p:cNvPr id="27" name="Shape 22"/>
           <p:cNvSpPr/>
           <p:nvPr/>
         </p:nvSpPr>
         <p:spPr>
           <a:xfrm>
-            <a:off x="6723126" y="22265640"/>
-            <a:ext cx="2377440" cy="0"/>
+            <a:off x="4983480" y="17350740"/>
+            <a:ext cx="1205100" cy="0"/>
           </a:xfrm>
           <a:prstGeom prst="line">
             <a:avLst/>
@@ -1796,14 +2263,14 @@
       </p:sp>
       <p:sp>
         <p:nvSpPr>
-          <p:cNvPr id="22" name="Text 19"/>
+          <p:cNvPr id="28" name="Text 23"/>
           <p:cNvSpPr txBox="1"/>
           <p:nvPr/>
         </p:nvSpPr>
         <p:spPr>
           <a:xfrm>
-            <a:off x="6723126" y="21396960"/>
-            <a:ext cx="2377440" cy="640080"/>
+            <a:off x="4800600" y="16756380"/>
+            <a:ext cx="1570860" cy="457200"/>
           </a:xfrm>
           <a:prstGeom prst="rect">
             <a:avLst/>
@@ -1819,7 +2286,7 @@
               <a:buNone/>
             </a:pPr>
             <a:r>
-              <a:rPr lang="en-US" sz="2800" b="1" dirty="0">
+              <a:rPr lang="en-US" sz="2400" b="1" dirty="0">
                 <a:solidFill>
                   <a:srgbClr val="14305C"/>
                 </a:solidFill>
@@ -1829,20 +2296,155 @@
               </a:rPr>
               <a:t>Ethernet</a:t>
             </a:r>
-            <a:endParaRPr lang="en-US" sz="2800" dirty="0"/>
-          </a:p>
-        </p:txBody>
-      </p:sp>
-      <p:sp>
-        <p:nvSpPr>
-          <p:cNvPr id="23" name="Text 20"/>
+            <a:endParaRPr lang="en-US" sz="2400" dirty="0"/>
+          </a:p>
+        </p:txBody>
+      </p:sp>
+      <p:pic>
+        <p:nvPicPr>
+          <p:cNvPr id="29" name="Image 3" descr="Front: Raspberry Pi 5 and front node under the dashboard">    </p:cNvPr>
+          <p:cNvPicPr>
+            <a:picLocks noChangeAspect="1"/>
+          </p:cNvPicPr>
+          <p:nvPr/>
+        </p:nvPicPr>
+        <p:blipFill>
+          <a:blip r:embed="rId4"/>
+          <a:srcRect l="0" r="0" t="0" b="0"/>
+          <a:stretch/>
+        </p:blipFill>
+        <p:spPr>
+          <a:xfrm>
+            <a:off x="1188720" y="19568160"/>
+            <a:ext cx="2779140" cy="3337560"/>
+          </a:xfrm>
+          <a:prstGeom prst="rect">
+            <a:avLst/>
+          </a:prstGeom>
+        </p:spPr>
+      </p:pic>
+      <p:sp>
+        <p:nvSpPr>
+          <p:cNvPr id="30" name="Shape 24"/>
+          <p:cNvSpPr/>
+          <p:nvPr/>
+        </p:nvSpPr>
+        <p:spPr>
+          <a:xfrm>
+            <a:off x="1188720" y="19568160"/>
+            <a:ext cx="2779140" cy="3337560"/>
+          </a:xfrm>
+          <a:prstGeom prst="rect">
+            <a:avLst/>
+          </a:prstGeom>
+          <a:ln w="38100">
+            <a:solidFill>
+              <a:srgbClr val="FFFFFF"/>
+            </a:solidFill>
+            <a:prstDash val="solid"/>
+          </a:ln>
+        </p:spPr>
+      </p:sp>
+      <p:pic>
+        <p:nvPicPr>
+          <p:cNvPr id="31" name="Image 4" descr="Front camera in its printed housing on the frame">    </p:cNvPr>
+          <p:cNvPicPr>
+            <a:picLocks noChangeAspect="1"/>
+          </p:cNvPicPr>
+          <p:nvPr/>
+        </p:nvPicPr>
+        <p:blipFill>
+          <a:blip r:embed="rId5"/>
+          <a:srcRect l="0" r="0" t="0" b="0"/>
+          <a:stretch/>
+        </p:blipFill>
+        <p:spPr>
+          <a:xfrm>
+            <a:off x="4196460" y="19568160"/>
+            <a:ext cx="2779140" cy="3337560"/>
+          </a:xfrm>
+          <a:prstGeom prst="rect">
+            <a:avLst/>
+          </a:prstGeom>
+        </p:spPr>
+      </p:pic>
+      <p:sp>
+        <p:nvSpPr>
+          <p:cNvPr id="32" name="Shape 25"/>
+          <p:cNvSpPr/>
+          <p:nvPr/>
+        </p:nvSpPr>
+        <p:spPr>
+          <a:xfrm>
+            <a:off x="4196460" y="19568160"/>
+            <a:ext cx="2779140" cy="3337560"/>
+          </a:xfrm>
+          <a:prstGeom prst="rect">
+            <a:avLst/>
+          </a:prstGeom>
+          <a:ln w="38100">
+            <a:solidFill>
+              <a:srgbClr val="FFFFFF"/>
+            </a:solidFill>
+            <a:prstDash val="solid"/>
+          </a:ln>
+        </p:spPr>
+      </p:sp>
+      <p:pic>
+        <p:nvPicPr>
+          <p:cNvPr id="33" name="Image 5" descr="Rear unit in its printed enclosure on the cargo bed">    </p:cNvPr>
+          <p:cNvPicPr>
+            <a:picLocks noChangeAspect="1"/>
+          </p:cNvPicPr>
+          <p:nvPr/>
+        </p:nvPicPr>
+        <p:blipFill>
+          <a:blip r:embed="rId6"/>
+          <a:srcRect l="0" r="0" t="0" b="0"/>
+          <a:stretch/>
+        </p:blipFill>
+        <p:spPr>
+          <a:xfrm>
+            <a:off x="7204200" y="19568160"/>
+            <a:ext cx="2779140" cy="3337560"/>
+          </a:xfrm>
+          <a:prstGeom prst="rect">
+            <a:avLst/>
+          </a:prstGeom>
+        </p:spPr>
+      </p:pic>
+      <p:sp>
+        <p:nvSpPr>
+          <p:cNvPr id="34" name="Shape 26"/>
+          <p:cNvSpPr/>
+          <p:nvPr/>
+        </p:nvSpPr>
+        <p:spPr>
+          <a:xfrm>
+            <a:off x="7204200" y="19568160"/>
+            <a:ext cx="2779140" cy="3337560"/>
+          </a:xfrm>
+          <a:prstGeom prst="rect">
+            <a:avLst/>
+          </a:prstGeom>
+          <a:ln w="38100">
+            <a:solidFill>
+              <a:srgbClr val="FFFFFF"/>
+            </a:solidFill>
+            <a:prstDash val="solid"/>
+          </a:ln>
+        </p:spPr>
+      </p:sp>
+      <p:sp>
+        <p:nvSpPr>
+          <p:cNvPr id="35" name="Text 27"/>
           <p:cNvSpPr txBox="1"/>
           <p:nvPr/>
         </p:nvSpPr>
         <p:spPr>
           <a:xfrm>
-            <a:off x="6723126" y="22494240"/>
-            <a:ext cx="2377440" cy="1097280"/>
+            <a:off x="1188720" y="22978872"/>
+            <a:ext cx="2779140" cy="411480"/>
           </a:xfrm>
           <a:prstGeom prst="rect">
             <a:avLst/>
@@ -1858,47 +2460,69 @@
               <a:buNone/>
             </a:pPr>
             <a:r>
-              <a:rPr lang="en-US" sz="2200" dirty="0">
-                <a:solidFill>
-                  <a:srgbClr val="4A5566"/>
-                </a:solidFill>
-                <a:latin typeface="Calibri" pitchFamily="34" charset="0"/>
-                <a:ea typeface="Calibri" pitchFamily="34" charset="-122"/>
-                <a:cs typeface="Calibri" pitchFamily="34" charset="-120"/>
-              </a:rPr>
-              <a:t>1000 Mb/s</a:t>
-            </a:r>
-            <a:endParaRPr lang="en-US" sz="2200" dirty="0"/>
-          </a:p>
+              <a:rPr lang="en-US" sz="2400" i="1" dirty="0">
+                <a:solidFill>
+                  <a:srgbClr val="3F4A5A"/>
+                </a:solidFill>
+                <a:latin typeface="Calibri" pitchFamily="34" charset="0"/>
+                <a:ea typeface="Calibri" pitchFamily="34" charset="-122"/>
+                <a:cs typeface="Calibri" pitchFamily="34" charset="-120"/>
+              </a:rPr>
+              <a:t>Front computer</a:t>
+            </a:r>
+            <a:endParaRPr lang="en-US" sz="2400" dirty="0"/>
+          </a:p>
+        </p:txBody>
+      </p:sp>
+      <p:sp>
+        <p:nvSpPr>
+          <p:cNvPr id="36" name="Text 28"/>
+          <p:cNvSpPr txBox="1"/>
+          <p:nvPr/>
+        </p:nvSpPr>
+        <p:spPr>
+          <a:xfrm>
+            <a:off x="4196460" y="22978872"/>
+            <a:ext cx="2779140" cy="411480"/>
+          </a:xfrm>
+          <a:prstGeom prst="rect">
+            <a:avLst/>
+          </a:prstGeom>
+          <a:noFill/>
+          <a:ln/>
+        </p:spPr>
+        <p:txBody>
+          <a:bodyPr wrap="square" lIns="0" tIns="0" rIns="0" bIns="0" rtlCol="0" anchor="t"/>
+          <a:lstStyle/>
           <a:p>
             <a:pPr algn="ctr" indent="0" marL="0">
               <a:buNone/>
             </a:pPr>
             <a:r>
-              <a:rPr lang="en-US" sz="2200" dirty="0">
-                <a:solidFill>
-                  <a:srgbClr val="4A5566"/>
-                </a:solidFill>
-                <a:latin typeface="Calibri" pitchFamily="34" charset="0"/>
-                <a:ea typeface="Calibri" pitchFamily="34" charset="-122"/>
-                <a:cs typeface="Calibri" pitchFamily="34" charset="-120"/>
-              </a:rPr>
-              <a:t>0.22 to 0.25 ms</a:t>
-            </a:r>
-            <a:endParaRPr lang="en-US" sz="2200" dirty="0"/>
-          </a:p>
-        </p:txBody>
-      </p:sp>
-      <p:sp>
-        <p:nvSpPr>
-          <p:cNvPr id="24" name="Text 21"/>
+              <a:rPr lang="en-US" sz="2400" i="1" dirty="0">
+                <a:solidFill>
+                  <a:srgbClr val="3F4A5A"/>
+                </a:solidFill>
+                <a:latin typeface="Calibri" pitchFamily="34" charset="0"/>
+                <a:ea typeface="Calibri" pitchFamily="34" charset="-122"/>
+                <a:cs typeface="Calibri" pitchFamily="34" charset="-120"/>
+              </a:rPr>
+              <a:t>Front camera</a:t>
+            </a:r>
+            <a:endParaRPr lang="en-US" sz="2400" dirty="0"/>
+          </a:p>
+        </p:txBody>
+      </p:sp>
+      <p:sp>
+        <p:nvSpPr>
+          <p:cNvPr id="37" name="Text 29"/>
           <p:cNvSpPr txBox="1"/>
           <p:nvPr/>
         </p:nvSpPr>
         <p:spPr>
           <a:xfrm>
-            <a:off x="1737360" y="25374600"/>
-            <a:ext cx="12348972" cy="1005840"/>
+            <a:off x="7204200" y="22978872"/>
+            <a:ext cx="2779140" cy="411480"/>
           </a:xfrm>
           <a:prstGeom prst="rect">
             <a:avLst/>
@@ -1910,19 +2534,19 @@
           <a:bodyPr wrap="square" lIns="0" tIns="0" rIns="0" bIns="0" rtlCol="0" anchor="t"/>
           <a:lstStyle/>
           <a:p>
-            <a:pPr indent="0" marL="0">
+            <a:pPr algn="ctr" indent="0" marL="0">
               <a:buNone/>
             </a:pPr>
             <a:r>
               <a:rPr lang="en-US" sz="2400" i="1" dirty="0">
                 <a:solidFill>
-                  <a:srgbClr val="4A5566"/>
-                </a:solidFill>
-                <a:latin typeface="Calibri" pitchFamily="34" charset="0"/>
-                <a:ea typeface="Calibri" pitchFamily="34" charset="-122"/>
-                <a:cs typeface="Calibri" pitchFamily="34" charset="-120"/>
-              </a:rPr>
-              <a:t>Two sides since 15 October: the battery's Bluetooth did not reach the front, and the Pi 5 runs the detector more than twice as fast.</a:t>
+                  <a:srgbClr val="3F4A5A"/>
+                </a:solidFill>
+                <a:latin typeface="Calibri" pitchFamily="34" charset="0"/>
+                <a:ea typeface="Calibri" pitchFamily="34" charset="-122"/>
+                <a:cs typeface="Calibri" pitchFamily="34" charset="-120"/>
+              </a:rPr>
+              <a:t>Rear unit</a:t>
             </a:r>
             <a:endParaRPr lang="en-US" sz="2400" dirty="0"/>
           </a:p>
@@ -1930,18 +2554,18 @@
       </p:sp>
       <p:sp>
         <p:nvSpPr>
-          <p:cNvPr id="25" name="Shape 22"/>
+          <p:cNvPr id="38" name="Shape 30"/>
           <p:cNvSpPr/>
           <p:nvPr/>
         </p:nvSpPr>
         <p:spPr>
           <a:xfrm>
-            <a:off x="1097280" y="27340560"/>
-            <a:ext cx="13629132" cy="12627864"/>
+            <a:off x="731520" y="23957280"/>
+            <a:ext cx="9709020" cy="5587200"/>
           </a:xfrm>
           <a:prstGeom prst="roundRect">
             <a:avLst>
-              <a:gd name="adj" fmla="val 2534"/>
+              <a:gd name="adj" fmla="val 4910"/>
             </a:avLst>
           </a:prstGeom>
           <a:solidFill>
@@ -1957,14 +2581,14 @@
       </p:sp>
       <p:sp>
         <p:nvSpPr>
-          <p:cNvPr id="26" name="Shape 23"/>
+          <p:cNvPr id="39" name="Shape 31"/>
           <p:cNvSpPr/>
           <p:nvPr/>
         </p:nvSpPr>
         <p:spPr>
           <a:xfrm>
-            <a:off x="1600200" y="27797760"/>
-            <a:ext cx="1143000" cy="1143000"/>
+            <a:off x="1097280" y="24277320"/>
+            <a:ext cx="914400" cy="914400"/>
           </a:xfrm>
           <a:prstGeom prst="ellipse">
             <a:avLst/>
@@ -1982,14 +2606,14 @@
       </p:sp>
       <p:sp>
         <p:nvSpPr>
-          <p:cNvPr id="27" name="Text 24"/>
+          <p:cNvPr id="40" name="Text 32"/>
           <p:cNvSpPr txBox="1"/>
           <p:nvPr/>
         </p:nvSpPr>
         <p:spPr>
           <a:xfrm>
-            <a:off x="1600200" y="27797760"/>
-            <a:ext cx="1143000" cy="1143000"/>
+            <a:off x="1097280" y="24277320"/>
+            <a:ext cx="914400" cy="914400"/>
           </a:xfrm>
           <a:prstGeom prst="rect">
             <a:avLst/>
@@ -2005,7 +2629,7 @@
               <a:buNone/>
             </a:pPr>
             <a:r>
-              <a:rPr lang="en-US" sz="4400" b="1" dirty="0">
+              <a:rPr lang="en-US" sz="4000" b="1" dirty="0">
                 <a:solidFill>
                   <a:srgbClr val="FFFFFF"/>
                 </a:solidFill>
@@ -2015,20 +2639,20 @@
               </a:rPr>
               <a:t>3</a:t>
             </a:r>
-            <a:endParaRPr lang="en-US" sz="4400" dirty="0"/>
-          </a:p>
-        </p:txBody>
-      </p:sp>
-      <p:sp>
-        <p:nvSpPr>
-          <p:cNvPr id="28" name="Text 25"/>
+            <a:endParaRPr lang="en-US" sz="4000" dirty="0"/>
+          </a:p>
+        </p:txBody>
+      </p:sp>
+      <p:sp>
+        <p:nvSpPr>
+          <p:cNvPr id="41" name="Text 33"/>
           <p:cNvSpPr txBox="1"/>
           <p:nvPr/>
         </p:nvSpPr>
         <p:spPr>
           <a:xfrm>
-            <a:off x="3063240" y="27752040"/>
-            <a:ext cx="11251692" cy="1234440"/>
+            <a:off x="2240280" y="24231600"/>
+            <a:ext cx="7880220" cy="1005840"/>
           </a:xfrm>
           <a:prstGeom prst="rect">
             <a:avLst/>
@@ -2044,7 +2668,7 @@
               <a:buNone/>
             </a:pPr>
             <a:r>
-              <a:rPr lang="en-US" sz="5600" b="1" dirty="0">
+              <a:rPr lang="en-US" sz="4800" b="1" dirty="0">
                 <a:solidFill>
                   <a:srgbClr val="14305C"/>
                 </a:solidFill>
@@ -2052,70 +2676,22 @@
                 <a:ea typeface="Calibri" pitchFamily="34" charset="-122"/>
                 <a:cs typeface="Calibri" pitchFamily="34" charset="-120"/>
               </a:rPr>
-              <a:t>Hazard warnings on the dashboard</a:t>
-            </a:r>
-            <a:endParaRPr lang="en-US" sz="5600" dirty="0"/>
-          </a:p>
-        </p:txBody>
-      </p:sp>
-      <p:pic>
-        <p:nvPicPr>
-          <p:cNvPr id="29" name="Image 1" descr="C:\Users\0geda\OneDrive - University of Cape Town\Documents\PlatformIO\Projects\Tukzie-HPEC-HUD\Report\figures\ui\ui_dualcam_front.png">    </p:cNvPr>
-          <p:cNvPicPr>
-            <a:picLocks noChangeAspect="1"/>
-          </p:cNvPicPr>
-          <p:nvPr/>
-        </p:nvPicPr>
-        <p:blipFill>
-          <a:blip r:embed="rId2"/>
-          <a:stretch>
-            <a:fillRect/>
-          </a:stretch>
-        </p:blipFill>
-        <p:spPr>
-          <a:xfrm>
-            <a:off x="1737360" y="29352240"/>
-            <a:ext cx="5945886" cy="3716179"/>
-          </a:xfrm>
-          <a:prstGeom prst="rect">
-            <a:avLst/>
-          </a:prstGeom>
-        </p:spPr>
-      </p:pic>
-      <p:pic>
-        <p:nvPicPr>
-          <p:cNvPr id="30" name="Image 2" descr="C:\Users\0geda\OneDrive - University of Cape Town\Documents\PlatformIO\Projects\Tukzie-HPEC-HUD\Report\figures\ui\ui_dualcam_rear_approaching.png">    </p:cNvPr>
-          <p:cNvPicPr>
-            <a:picLocks noChangeAspect="1"/>
-          </p:cNvPicPr>
-          <p:nvPr/>
-        </p:nvPicPr>
-        <p:blipFill>
-          <a:blip r:embed="rId3"/>
-          <a:stretch>
-            <a:fillRect/>
-          </a:stretch>
-        </p:blipFill>
-        <p:spPr>
-          <a:xfrm>
-            <a:off x="8140446" y="29352240"/>
-            <a:ext cx="5945886" cy="3716179"/>
-          </a:xfrm>
-          <a:prstGeom prst="rect">
-            <a:avLst/>
-          </a:prstGeom>
-        </p:spPr>
-      </p:pic>
-      <p:sp>
-        <p:nvSpPr>
-          <p:cNvPr id="31" name="Text 26"/>
+              <a:t>Method</a:t>
+            </a:r>
+            <a:endParaRPr lang="en-US" sz="4800" dirty="0"/>
+          </a:p>
+        </p:txBody>
+      </p:sp>
+      <p:sp>
+        <p:nvSpPr>
+          <p:cNvPr id="42" name="Text 34"/>
           <p:cNvSpPr txBox="1"/>
           <p:nvPr/>
         </p:nvSpPr>
         <p:spPr>
           <a:xfrm>
-            <a:off x="1737360" y="33205579"/>
-            <a:ext cx="5945886" cy="822960"/>
+            <a:off x="1188720" y="25466040"/>
+            <a:ext cx="8794620" cy="3849840"/>
           </a:xfrm>
           <a:prstGeom prst="rect">
             <a:avLst/>
@@ -2127,92 +2703,28 @@
           <a:bodyPr wrap="square" lIns="0" tIns="0" rIns="0" bIns="0" rtlCol="0" anchor="t"/>
           <a:lstStyle/>
           <a:p>
-            <a:pPr indent="0" marL="0">
-              <a:buNone/>
-            </a:pPr>
-            <a:r>
-              <a:rPr lang="en-US" sz="2400" i="1" dirty="0">
-                <a:solidFill>
-                  <a:srgbClr val="4A5566"/>
-                </a:solidFill>
-                <a:latin typeface="Calibri" pitchFamily="34" charset="0"/>
-                <a:ea typeface="Calibri" pitchFamily="34" charset="-122"/>
-                <a:cs typeface="Calibri" pitchFamily="34" charset="-120"/>
-              </a:rPr>
-              <a:t>Front | Rear switch on the existing dashboard (test images).</a:t>
-            </a:r>
-            <a:endParaRPr lang="en-US" sz="2400" dirty="0"/>
-          </a:p>
-        </p:txBody>
-      </p:sp>
-      <p:sp>
-        <p:nvSpPr>
-          <p:cNvPr id="32" name="Text 27"/>
-          <p:cNvSpPr txBox="1"/>
-          <p:nvPr/>
-        </p:nvSpPr>
-        <p:spPr>
-          <a:xfrm>
-            <a:off x="8140446" y="33205579"/>
-            <a:ext cx="5945886" cy="822960"/>
-          </a:xfrm>
-          <a:prstGeom prst="rect">
-            <a:avLst/>
-          </a:prstGeom>
-          <a:noFill/>
-          <a:ln/>
-        </p:spPr>
-        <p:txBody>
-          <a:bodyPr wrap="square" lIns="0" tIns="0" rIns="0" bIns="0" rtlCol="0" anchor="t"/>
-          <a:lstStyle/>
-          <a:p>
-            <a:pPr indent="0" marL="0">
-              <a:buNone/>
-            </a:pPr>
-            <a:r>
-              <a:rPr lang="en-US" sz="2400" i="1" dirty="0">
-                <a:solidFill>
-                  <a:srgbClr val="4A5566"/>
-                </a:solidFill>
-                <a:latin typeface="Calibri" pitchFamily="34" charset="0"/>
-                <a:ea typeface="Calibri" pitchFamily="34" charset="-122"/>
-                <a:cs typeface="Calibri" pitchFamily="34" charset="-120"/>
-              </a:rPr>
-              <a:t>Rear view mirrored; a car approaching at 1.6 s.</a:t>
-            </a:r>
-            <a:endParaRPr lang="en-US" sz="2400" dirty="0"/>
-          </a:p>
-        </p:txBody>
-      </p:sp>
-      <p:sp>
-        <p:nvSpPr>
-          <p:cNvPr id="33" name="Text 28"/>
-          <p:cNvSpPr txBox="1"/>
-          <p:nvPr/>
-        </p:nvSpPr>
-        <p:spPr>
-          <a:xfrm>
-            <a:off x="1737360" y="34211419"/>
-            <a:ext cx="12348972" cy="5391245"/>
-          </a:xfrm>
-          <a:prstGeom prst="rect">
-            <a:avLst/>
-          </a:prstGeom>
-          <a:noFill/>
-          <a:ln/>
-        </p:spPr>
-        <p:txBody>
-          <a:bodyPr wrap="square" lIns="0" tIns="0" rIns="0" bIns="0" rtlCol="0" anchor="t"/>
-          <a:lstStyle/>
-          <a:p>
-            <a:pPr marL="406400" indent="-406400">
-              <a:spcAft>
-                <a:spcPts val="1400"/>
-              </a:spcAft>
+            <a:pPr marL="355600" indent="-355600">
               <a:buSzPct val="100000"/>
               <a:buChar char="•"/>
             </a:pPr>
             <a:r>
+              <a:rPr lang="en-US" sz="2800" b="1" dirty="0">
+                <a:solidFill>
+                  <a:srgbClr val="14305C"/>
+                </a:solidFill>
+                <a:latin typeface="Calibri" pitchFamily="34" charset="0"/>
+                <a:ea typeface="Calibri" pitchFamily="34" charset="-122"/>
+                <a:cs typeface="Calibri" pitchFamily="34" charset="-120"/>
+              </a:rPr>
+              <a:t>Requirements first: </a:t>
+            </a:r>
+            <a:pPr indent="0" marL="0">
+              <a:spcAft>
+                <a:spcPts val="1000"/>
+              </a:spcAft>
+              <a:buNone/>
+            </a:pPr>
+            <a:r>
               <a:rPr lang="en-US" sz="2800" dirty="0">
                 <a:solidFill>
                   <a:srgbClr val="1B1F24"/>
@@ -2221,19 +2733,33 @@
                 <a:ea typeface="Calibri" pitchFamily="34" charset="-122"/>
                 <a:cs typeface="Calibri" pitchFamily="34" charset="-120"/>
               </a:rPr>
-              <a:t>Detection on the Pi 5 beside the display: 51 to 54 ms median from sensor readout at 19.2 fps, against 118 to 122 ms on the Pi 4 with the whole system.</a:t>
+              <a:t>thirteen requirements, each with a criterion fixed before its test; bench tests, then the vehicle.</a:t>
             </a:r>
             <a:endParaRPr lang="en-US" sz="2800" dirty="0"/>
           </a:p>
           <a:p>
-            <a:pPr marL="406400" indent="-406400">
-              <a:spcAft>
-                <a:spcPts val="1400"/>
-              </a:spcAft>
+            <a:pPr marL="355600" indent="-355600">
               <a:buSzPct val="100000"/>
               <a:buChar char="•"/>
             </a:pPr>
             <a:r>
+              <a:rPr lang="en-US" sz="2800" b="1" dirty="0">
+                <a:solidFill>
+                  <a:srgbClr val="14305C"/>
+                </a:solidFill>
+                <a:latin typeface="Calibri" pitchFamily="34" charset="0"/>
+                <a:ea typeface="Calibri" pitchFamily="34" charset="-122"/>
+                <a:cs typeface="Calibri" pitchFamily="34" charset="-120"/>
+              </a:rPr>
+              <a:t>Road, 27 Oct: </a:t>
+            </a:r>
+            <a:pPr indent="0" marL="0">
+              <a:spcAft>
+                <a:spcPts val="1000"/>
+              </a:spcAft>
+              <a:buNone/>
+            </a:pPr>
+            <a:r>
               <a:rPr lang="en-US" sz="2800" dirty="0">
                 <a:solidFill>
                   <a:srgbClr val="1B1F24"/>
@@ -2242,19 +2768,30 @@
                 <a:ea typeface="Calibri" pitchFamily="34" charset="-122"/>
                 <a:cs typeface="Calibri" pitchFamily="34" charset="-120"/>
               </a:rPr>
-              <a:t>Approaching objects: time to contact from the growth of the box, τ = w / (dw/dt), with no focal length or object size (Lee 1976). Warning under 4 s, immediate under 2 s.</a:t>
+              <a:t>five passes of a smooth loop and four of a rough strip at 10 km/h; phone GNSS as the speed reference.</a:t>
             </a:r>
             <a:endParaRPr lang="en-US" sz="2800" dirty="0"/>
           </a:p>
           <a:p>
-            <a:pPr marL="406400" indent="-406400">
-              <a:spcAft>
-                <a:spcPts val="1400"/>
-              </a:spcAft>
+            <a:pPr marL="355600" indent="-355600">
               <a:buSzPct val="100000"/>
               <a:buChar char="•"/>
             </a:pPr>
             <a:r>
+              <a:rPr lang="en-US" sz="2800" b="1" dirty="0">
+                <a:solidFill>
+                  <a:srgbClr val="14305C"/>
+                </a:solidFill>
+                <a:latin typeface="Calibri" pitchFamily="34" charset="0"/>
+                <a:ea typeface="Calibri" pitchFamily="34" charset="-122"/>
+                <a:cs typeface="Calibri" pitchFamily="34" charset="-120"/>
+              </a:rPr>
+              <a:t>Analysis: </a:t>
+            </a:r>
+            <a:pPr indent="0" marL="0">
+              <a:buNone/>
+            </a:pPr>
+            <a:r>
               <a:rPr lang="en-US" sz="2800" dirty="0">
                 <a:solidFill>
                   <a:srgbClr val="1B1F24"/>
@@ -2263,47 +2800,71 @@
                 <a:ea typeface="Calibri" pitchFamily="34" charset="-122"/>
                 <a:cs typeface="Calibri" pitchFamily="34" charset="-120"/>
               </a:rPr>
-              <a:t>Synthetic tests within 2 %; not yet tested on a real approach. Live data only; frames never stored.</a:t>
+              <a:t>ISO 2631-1 weighted vibration </a:t>
+            </a:r>
+            <a:pPr indent="0" marL="0">
+              <a:buNone/>
+            </a:pPr>
+            <a:r>
+              <a:rPr lang="en-US" sz="2800" dirty="0">
+                <a:solidFill>
+                  <a:srgbClr val="1B1F24"/>
+                </a:solidFill>
+                <a:latin typeface="Calibri" pitchFamily="34" charset="0"/>
+                <a:ea typeface="Calibri" pitchFamily="34" charset="-122"/>
+                <a:cs typeface="Calibri" pitchFamily="34" charset="-120"/>
+              </a:rPr>
+              <a:t>a</a:t>
+            </a:r>
+            <a:pPr indent="0" marL="0">
+              <a:buNone/>
+            </a:pPr>
+            <a:r>
+              <a:rPr lang="en-US" sz="2800" baseline="-40000" dirty="0">
+                <a:solidFill>
+                  <a:srgbClr val="1B1F24"/>
+                </a:solidFill>
+                <a:latin typeface="Calibri" pitchFamily="34" charset="0"/>
+                <a:ea typeface="Calibri" pitchFamily="34" charset="-122"/>
+                <a:cs typeface="Calibri" pitchFamily="34" charset="-120"/>
+              </a:rPr>
+              <a:t>w</a:t>
+            </a:r>
+            <a:pPr indent="0" marL="0">
+              <a:spcAft>
+                <a:spcPts val="1000"/>
+              </a:spcAft>
+              <a:buNone/>
+            </a:pPr>
+            <a:r>
+              <a:rPr lang="en-US" sz="2800" dirty="0">
+                <a:solidFill>
+                  <a:srgbClr val="1B1F24"/>
+                </a:solidFill>
+                <a:latin typeface="Calibri" pitchFamily="34" charset="0"/>
+                <a:ea typeface="Calibri" pitchFamily="34" charset="-122"/>
+                <a:cs typeface="Calibri" pitchFamily="34" charset="-120"/>
+              </a:rPr>
+              <a:t> per pass; CV over passes (criterion 10 %); ICC in 8 m cells (0.75); share of the stand-run motor lines in the road spectrum.</a:t>
             </a:r>
             <a:endParaRPr lang="en-US" sz="2800" dirty="0"/>
           </a:p>
-          <a:p>
-            <a:pPr marL="406400" indent="-406400">
-              <a:spcAft>
-                <a:spcPts val="1400"/>
-              </a:spcAft>
-              <a:buSzPct val="100000"/>
-              <a:buChar char="•"/>
-            </a:pPr>
-            <a:r>
-              <a:rPr lang="en-US" sz="2800" dirty="0">
-                <a:solidFill>
-                  <a:srgbClr val="1B1F24"/>
-                </a:solidFill>
-                <a:latin typeface="Calibri" pitchFamily="34" charset="0"/>
-                <a:ea typeface="Calibri" pitchFamily="34" charset="-122"/>
-                <a:cs typeface="Calibri" pitchFamily="34" charset="-120"/>
-              </a:rPr>
-              <a:t>Legibility at 0.70 m (ISO 15008: 16 arc minutes acceptable, 20 recommended): speed digits 84, alert banner 9, labels a median of 9. The speed is legible at a glance; the warnings are not. Glance time needs a participant.</a:t>
-            </a:r>
-            <a:endParaRPr lang="en-US" sz="2800" dirty="0"/>
-          </a:p>
-        </p:txBody>
-      </p:sp>
-      <p:sp>
-        <p:nvSpPr>
-          <p:cNvPr id="34" name="Shape 29"/>
+        </p:txBody>
+      </p:sp>
+      <p:sp>
+        <p:nvSpPr>
+          <p:cNvPr id="43" name="Shape 35"/>
           <p:cNvSpPr/>
           <p:nvPr/>
         </p:nvSpPr>
         <p:spPr>
           <a:xfrm>
-            <a:off x="15549372" y="10515600"/>
-            <a:ext cx="13629132" cy="10927080"/>
+            <a:off x="10943460" y="7406640"/>
+            <a:ext cx="9709020" cy="13167360"/>
           </a:xfrm>
           <a:prstGeom prst="roundRect">
             <a:avLst>
-              <a:gd name="adj" fmla="val 2929"/>
+              <a:gd name="adj" fmla="val 2825"/>
             </a:avLst>
           </a:prstGeom>
           <a:solidFill>
@@ -2319,14 +2880,14 @@
       </p:sp>
       <p:sp>
         <p:nvSpPr>
-          <p:cNvPr id="35" name="Shape 30"/>
+          <p:cNvPr id="44" name="Shape 36"/>
           <p:cNvSpPr/>
           <p:nvPr/>
         </p:nvSpPr>
         <p:spPr>
           <a:xfrm>
-            <a:off x="16052292" y="10972800"/>
-            <a:ext cx="1143000" cy="1143000"/>
+            <a:off x="11309220" y="7726680"/>
+            <a:ext cx="914400" cy="914400"/>
           </a:xfrm>
           <a:prstGeom prst="ellipse">
             <a:avLst/>
@@ -2344,14 +2905,14 @@
       </p:sp>
       <p:sp>
         <p:nvSpPr>
-          <p:cNvPr id="36" name="Text 31"/>
+          <p:cNvPr id="45" name="Text 37"/>
           <p:cNvSpPr txBox="1"/>
           <p:nvPr/>
         </p:nvSpPr>
         <p:spPr>
           <a:xfrm>
-            <a:off x="16052292" y="10972800"/>
-            <a:ext cx="1143000" cy="1143000"/>
+            <a:off x="11309220" y="7726680"/>
+            <a:ext cx="914400" cy="914400"/>
           </a:xfrm>
           <a:prstGeom prst="rect">
             <a:avLst/>
@@ -2367,7 +2928,7 @@
               <a:buNone/>
             </a:pPr>
             <a:r>
-              <a:rPr lang="en-US" sz="4400" b="1" dirty="0">
+              <a:rPr lang="en-US" sz="4000" b="1" dirty="0">
                 <a:solidFill>
                   <a:srgbClr val="FFFFFF"/>
                 </a:solidFill>
@@ -2377,20 +2938,20 @@
               </a:rPr>
               <a:t>4</a:t>
             </a:r>
-            <a:endParaRPr lang="en-US" sz="4400" dirty="0"/>
-          </a:p>
-        </p:txBody>
-      </p:sp>
-      <p:sp>
-        <p:nvSpPr>
-          <p:cNvPr id="37" name="Text 32"/>
+            <a:endParaRPr lang="en-US" sz="4000" dirty="0"/>
+          </a:p>
+        </p:txBody>
+      </p:sp>
+      <p:sp>
+        <p:nvSpPr>
+          <p:cNvPr id="46" name="Text 38"/>
           <p:cNvSpPr txBox="1"/>
           <p:nvPr/>
         </p:nvSpPr>
         <p:spPr>
           <a:xfrm>
-            <a:off x="17515332" y="10927080"/>
-            <a:ext cx="11251692" cy="1234440"/>
+            <a:off x="12452220" y="7680960"/>
+            <a:ext cx="7880220" cy="1005840"/>
           </a:xfrm>
           <a:prstGeom prst="rect">
             <a:avLst/>
@@ -2406,7 +2967,7 @@
               <a:buNone/>
             </a:pPr>
             <a:r>
-              <a:rPr lang="en-US" sz="5600" b="1" dirty="0">
+              <a:rPr lang="en-US" sz="4800" b="1" dirty="0">
                 <a:solidFill>
                   <a:srgbClr val="14305C"/>
                 </a:solidFill>
@@ -2414,26 +2975,42 @@
                 <a:ea typeface="Calibri" pitchFamily="34" charset="-122"/>
                 <a:cs typeface="Calibri" pitchFamily="34" charset="-120"/>
               </a:rPr>
-              <a:t>Bench results</a:t>
-            </a:r>
-            <a:endParaRPr lang="en-US" sz="5600" dirty="0"/>
-          </a:p>
-        </p:txBody>
-      </p:sp>
-      <p:sp>
-        <p:nvSpPr>
-          <p:cNvPr id="38" name="Shape 33"/>
+              <a:t>Key results on the road</a:t>
+            </a:r>
+            <a:endParaRPr lang="en-US" sz="4800" dirty="0"/>
+          </a:p>
+        </p:txBody>
+      </p:sp>
+      <p:graphicFrame>
+        <p:nvGraphicFramePr>
+          <p:cNvPr id="47" name="Chart 0" descr=""/>
+          <p:cNvGraphicFramePr/>
+          <p:nvPr/>
+        </p:nvGraphicFramePr>
+        <p:xfrm>
+          <a:off x="11400660" y="8823960"/>
+          <a:ext cx="8794620" cy="3429000"/>
+        </p:xfrm>
+        <a:graphic xmlns:a="http://schemas.openxmlformats.org/drawingml/2006/main">
+          <a:graphicData uri="http://schemas.openxmlformats.org/drawingml/2006/chart">
+            <c:chart xmlns:c="http://schemas.openxmlformats.org/drawingml/2006/chart" r:id="rId7"/>
+          </a:graphicData>
+        </a:graphic>
+      </p:graphicFrame>
+      <p:sp>
+        <p:nvSpPr>
+          <p:cNvPr id="48" name="Shape 39"/>
           <p:cNvSpPr/>
           <p:nvPr/>
         </p:nvSpPr>
         <p:spPr>
           <a:xfrm>
-            <a:off x="16189452" y="12527280"/>
-            <a:ext cx="5945886" cy="2606040"/>
+            <a:off x="11400660" y="12481560"/>
+            <a:ext cx="4296726" cy="1783080"/>
           </a:xfrm>
           <a:prstGeom prst="roundRect">
             <a:avLst>
-              <a:gd name="adj" fmla="val 7018"/>
+              <a:gd name="adj" fmla="val 6154"/>
             </a:avLst>
           </a:prstGeom>
           <a:solidFill>
@@ -2449,14 +3026,14 @@
       </p:sp>
       <p:sp>
         <p:nvSpPr>
-          <p:cNvPr id="39" name="Text 34"/>
+          <p:cNvPr id="49" name="Text 40"/>
           <p:cNvSpPr txBox="1"/>
           <p:nvPr/>
         </p:nvSpPr>
         <p:spPr>
           <a:xfrm>
-            <a:off x="16463772" y="12664440"/>
-            <a:ext cx="5397246" cy="1234440"/>
+            <a:off x="11583540" y="12573000"/>
+            <a:ext cx="3930966" cy="731520"/>
           </a:xfrm>
           <a:prstGeom prst="rect">
             <a:avLst/>
@@ -2472,30 +3049,30 @@
               <a:buNone/>
             </a:pPr>
             <a:r>
-              <a:rPr lang="en-US" sz="6000" b="1" dirty="0">
-                <a:solidFill>
-                  <a:srgbClr val="14305C"/>
-                </a:solidFill>
-                <a:latin typeface="Calibri" pitchFamily="34" charset="0"/>
-                <a:ea typeface="Calibri" pitchFamily="34" charset="-122"/>
-                <a:cs typeface="Calibri" pitchFamily="34" charset="-120"/>
-              </a:rPr>
-              <a:t>200 Hz</a:t>
-            </a:r>
-            <a:endParaRPr lang="en-US" sz="6000" dirty="0"/>
-          </a:p>
-        </p:txBody>
-      </p:sp>
-      <p:sp>
-        <p:nvSpPr>
-          <p:cNvPr id="40" name="Text 35"/>
+              <a:rPr lang="en-US" sz="4200" b="1" dirty="0">
+                <a:solidFill>
+                  <a:srgbClr val="1B7F3B"/>
+                </a:solidFill>
+                <a:latin typeface="Calibri" pitchFamily="34" charset="0"/>
+                <a:ea typeface="Calibri" pitchFamily="34" charset="-122"/>
+                <a:cs typeface="Calibri" pitchFamily="34" charset="-120"/>
+              </a:rPr>
+              <a:t>5.0 % / 5.3 %</a:t>
+            </a:r>
+            <a:endParaRPr lang="en-US" sz="4200" dirty="0"/>
+          </a:p>
+        </p:txBody>
+      </p:sp>
+      <p:sp>
+        <p:nvSpPr>
+          <p:cNvPr id="50" name="Text 41"/>
           <p:cNvSpPr txBox="1"/>
           <p:nvPr/>
         </p:nvSpPr>
         <p:spPr>
           <a:xfrm>
-            <a:off x="16463772" y="13944600"/>
-            <a:ext cx="5397246" cy="1097280"/>
+            <a:off x="11583540" y="13322808"/>
+            <a:ext cx="3976686" cy="896112"/>
           </a:xfrm>
           <a:prstGeom prst="rect">
             <a:avLst/>
@@ -2513,13 +3090,55 @@
             <a:r>
               <a:rPr lang="en-US" sz="2400" dirty="0">
                 <a:solidFill>
-                  <a:srgbClr val="4A5566"/>
-                </a:solidFill>
-                <a:latin typeface="Calibri" pitchFamily="34" charset="0"/>
-                <a:ea typeface="Calibri" pitchFamily="34" charset="-122"/>
-                <a:cs typeface="Calibri" pitchFamily="34" charset="-120"/>
-              </a:rPr>
-              <a:t>both IMUs, no samples dropped; 149 of 149 windows fused</a:t>
+                  <a:srgbClr val="1B1F24"/>
+                </a:solidFill>
+                <a:latin typeface="Calibri" pitchFamily="34" charset="0"/>
+                <a:ea typeface="Calibri" pitchFamily="34" charset="-122"/>
+                <a:cs typeface="Calibri" pitchFamily="34" charset="-120"/>
+              </a:rPr>
+              <a:t>CV of </a:t>
+            </a:r>
+            <a:pPr indent="0" marL="0">
+              <a:buNone/>
+            </a:pPr>
+            <a:r>
+              <a:rPr lang="en-US" sz="2400" dirty="0">
+                <a:solidFill>
+                  <a:srgbClr val="1B1F24"/>
+                </a:solidFill>
+                <a:latin typeface="Calibri" pitchFamily="34" charset="0"/>
+                <a:ea typeface="Calibri" pitchFamily="34" charset="-122"/>
+                <a:cs typeface="Calibri" pitchFamily="34" charset="-120"/>
+              </a:rPr>
+              <a:t>a</a:t>
+            </a:r>
+            <a:pPr indent="0" marL="0">
+              <a:buNone/>
+            </a:pPr>
+            <a:r>
+              <a:rPr lang="en-US" sz="2400" baseline="-40000" dirty="0">
+                <a:solidFill>
+                  <a:srgbClr val="1B1F24"/>
+                </a:solidFill>
+                <a:latin typeface="Calibri" pitchFamily="34" charset="0"/>
+                <a:ea typeface="Calibri" pitchFamily="34" charset="-122"/>
+                <a:cs typeface="Calibri" pitchFamily="34" charset="-120"/>
+              </a:rPr>
+              <a:t>w</a:t>
+            </a:r>
+            <a:pPr indent="0" marL="0">
+              <a:buNone/>
+            </a:pPr>
+            <a:r>
+              <a:rPr lang="en-US" sz="2400" dirty="0">
+                <a:solidFill>
+                  <a:srgbClr val="1B1F24"/>
+                </a:solidFill>
+                <a:latin typeface="Calibri" pitchFamily="34" charset="0"/>
+                <a:ea typeface="Calibri" pitchFamily="34" charset="-122"/>
+                <a:cs typeface="Calibri" pitchFamily="34" charset="-120"/>
+              </a:rPr>
+              <a:t> over 5 passes, rear / front; criterion 10 %: met</a:t>
             </a:r>
             <a:endParaRPr lang="en-US" sz="2400" dirty="0"/>
           </a:p>
@@ -2527,18 +3146,18 @@
       </p:sp>
       <p:sp>
         <p:nvSpPr>
-          <p:cNvPr id="41" name="Shape 36"/>
+          <p:cNvPr id="51" name="Shape 42"/>
           <p:cNvSpPr/>
           <p:nvPr/>
         </p:nvSpPr>
         <p:spPr>
           <a:xfrm>
-            <a:off x="22592538" y="12527280"/>
-            <a:ext cx="5945886" cy="2606040"/>
+            <a:off x="15898554" y="12481560"/>
+            <a:ext cx="4296726" cy="1783080"/>
           </a:xfrm>
           <a:prstGeom prst="roundRect">
             <a:avLst>
-              <a:gd name="adj" fmla="val 7018"/>
+              <a:gd name="adj" fmla="val 6154"/>
             </a:avLst>
           </a:prstGeom>
           <a:solidFill>
@@ -2554,14 +3173,14 @@
       </p:sp>
       <p:sp>
         <p:nvSpPr>
-          <p:cNvPr id="42" name="Text 37"/>
+          <p:cNvPr id="52" name="Text 43"/>
           <p:cNvSpPr txBox="1"/>
           <p:nvPr/>
         </p:nvSpPr>
         <p:spPr>
           <a:xfrm>
-            <a:off x="22866858" y="12664440"/>
-            <a:ext cx="5397246" cy="1234440"/>
+            <a:off x="16081434" y="12573000"/>
+            <a:ext cx="3930966" cy="731520"/>
           </a:xfrm>
           <a:prstGeom prst="rect">
             <a:avLst/>
@@ -2577,7 +3196,7 @@
               <a:buNone/>
             </a:pPr>
             <a:r>
-              <a:rPr lang="en-US" sz="6000" b="1" dirty="0">
+              <a:rPr lang="en-US" sz="4200" b="1" dirty="0">
                 <a:solidFill>
                   <a:srgbClr val="14305C"/>
                 </a:solidFill>
@@ -2585,22 +3204,22 @@
                 <a:ea typeface="Calibri" pitchFamily="34" charset="-122"/>
                 <a:cs typeface="Calibri" pitchFamily="34" charset="-120"/>
               </a:rPr>
-              <a:t>51 to 54 ms</a:t>
-            </a:r>
-            <a:endParaRPr lang="en-US" sz="6000" dirty="0"/>
-          </a:p>
-        </p:txBody>
-      </p:sp>
-      <p:sp>
-        <p:nvSpPr>
-          <p:cNvPr id="43" name="Text 38"/>
+              <a:t>about 2 ×</a:t>
+            </a:r>
+            <a:endParaRPr lang="en-US" sz="4200" dirty="0"/>
+          </a:p>
+        </p:txBody>
+      </p:sp>
+      <p:sp>
+        <p:nvSpPr>
+          <p:cNvPr id="53" name="Text 44"/>
           <p:cNvSpPr txBox="1"/>
           <p:nvPr/>
         </p:nvSpPr>
         <p:spPr>
           <a:xfrm>
-            <a:off x="22866858" y="13944600"/>
-            <a:ext cx="5397246" cy="1097280"/>
+            <a:off x="16081434" y="13322808"/>
+            <a:ext cx="3976686" cy="896112"/>
           </a:xfrm>
           <a:prstGeom prst="rect">
             <a:avLst/>
@@ -2618,13 +3237,13 @@
             <a:r>
               <a:rPr lang="en-US" sz="2400" dirty="0">
                 <a:solidFill>
-                  <a:srgbClr val="4A5566"/>
-                </a:solidFill>
-                <a:latin typeface="Calibri" pitchFamily="34" charset="0"/>
-                <a:ea typeface="Calibri" pitchFamily="34" charset="-122"/>
-                <a:cs typeface="Calibri" pitchFamily="34" charset="-120"/>
-              </a:rPr>
-              <a:t>median detection on the Pi 5 at 19.2 fps (Pi 4: about 120 ms)</a:t>
+                  <a:srgbClr val="1B1F24"/>
+                </a:solidFill>
+                <a:latin typeface="Calibri" pitchFamily="34" charset="0"/>
+                <a:ea typeface="Calibri" pitchFamily="34" charset="-122"/>
+                <a:cs typeface="Calibri" pitchFamily="34" charset="-120"/>
+              </a:rPr>
+              <a:t>rough strip against the smooth loop, at both ends</a:t>
             </a:r>
             <a:endParaRPr lang="en-US" sz="2400" dirty="0"/>
           </a:p>
@@ -2632,18 +3251,18 @@
       </p:sp>
       <p:sp>
         <p:nvSpPr>
-          <p:cNvPr id="44" name="Shape 39"/>
+          <p:cNvPr id="54" name="Shape 45"/>
           <p:cNvSpPr/>
           <p:nvPr/>
         </p:nvSpPr>
         <p:spPr>
           <a:xfrm>
-            <a:off x="16189452" y="15453360"/>
-            <a:ext cx="5945886" cy="2606040"/>
+            <a:off x="11400660" y="14465808"/>
+            <a:ext cx="4296726" cy="1783080"/>
           </a:xfrm>
           <a:prstGeom prst="roundRect">
             <a:avLst>
-              <a:gd name="adj" fmla="val 7018"/>
+              <a:gd name="adj" fmla="val 6154"/>
             </a:avLst>
           </a:prstGeom>
           <a:solidFill>
@@ -2659,14 +3278,14 @@
       </p:sp>
       <p:sp>
         <p:nvSpPr>
-          <p:cNvPr id="45" name="Text 40"/>
+          <p:cNvPr id="55" name="Text 46"/>
           <p:cNvSpPr txBox="1"/>
           <p:nvPr/>
         </p:nvSpPr>
         <p:spPr>
           <a:xfrm>
-            <a:off x="16463772" y="15590520"/>
-            <a:ext cx="5397246" cy="1234440"/>
+            <a:off x="11583540" y="14557248"/>
+            <a:ext cx="3930966" cy="731520"/>
           </a:xfrm>
           <a:prstGeom prst="rect">
             <a:avLst/>
@@ -2682,30 +3301,30 @@
               <a:buNone/>
             </a:pPr>
             <a:r>
-              <a:rPr lang="en-US" sz="6000" b="1" dirty="0">
-                <a:solidFill>
-                  <a:srgbClr val="14305C"/>
-                </a:solidFill>
-                <a:latin typeface="Calibri" pitchFamily="34" charset="0"/>
-                <a:ea typeface="Calibri" pitchFamily="34" charset="-122"/>
-                <a:cs typeface="Calibri" pitchFamily="34" charset="-120"/>
-              </a:rPr>
-              <a:t>2.7 m</a:t>
-            </a:r>
-            <a:endParaRPr lang="en-US" sz="6000" dirty="0"/>
-          </a:p>
-        </p:txBody>
-      </p:sp>
-      <p:sp>
-        <p:nvSpPr>
-          <p:cNvPr id="46" name="Text 41"/>
+              <a:rPr lang="en-US" sz="4200" b="1" dirty="0">
+                <a:solidFill>
+                  <a:srgbClr val="B45309"/>
+                </a:solidFill>
+                <a:latin typeface="Calibri" pitchFamily="34" charset="0"/>
+                <a:ea typeface="Calibri" pitchFamily="34" charset="-122"/>
+                <a:cs typeface="Calibri" pitchFamily="34" charset="-120"/>
+              </a:rPr>
+              <a:t>ICC 0.16 vs 0.75</a:t>
+            </a:r>
+            <a:endParaRPr lang="en-US" sz="4200" dirty="0"/>
+          </a:p>
+        </p:txBody>
+      </p:sp>
+      <p:sp>
+        <p:nvSpPr>
+          <p:cNvPr id="56" name="Text 47"/>
           <p:cNvSpPr txBox="1"/>
           <p:nvPr/>
         </p:nvSpPr>
         <p:spPr>
           <a:xfrm>
-            <a:off x="16463772" y="16870680"/>
-            <a:ext cx="5397246" cy="1097280"/>
+            <a:off x="11583540" y="15307056"/>
+            <a:ext cx="3976686" cy="896112"/>
           </a:xfrm>
           <a:prstGeom prst="rect">
             <a:avLst/>
@@ -2723,13 +3342,13 @@
             <a:r>
               <a:rPr lang="en-US" sz="2400" dirty="0">
                 <a:solidFill>
-                  <a:srgbClr val="4A5566"/>
-                </a:solidFill>
-                <a:latin typeface="Calibri" pitchFamily="34" charset="0"/>
-                <a:ea typeface="Calibri" pitchFamily="34" charset="-122"/>
-                <a:cs typeface="Calibri" pitchFamily="34" charset="-120"/>
-              </a:rPr>
-              <a:t>median GNSS error against a phone, 104 fixes</a:t>
+                  <a:srgbClr val="1B1F24"/>
+                </a:solidFill>
+                <a:latin typeface="Calibri" pitchFamily="34" charset="0"/>
+                <a:ea typeface="Calibri" pitchFamily="34" charset="-122"/>
+                <a:cs typeface="Calibri" pitchFamily="34" charset="-120"/>
+              </a:rPr>
+              <a:t>not met: repeats over whole passes, not place by place</a:t>
             </a:r>
             <a:endParaRPr lang="en-US" sz="2400" dirty="0"/>
           </a:p>
@@ -2737,18 +3356,18 @@
       </p:sp>
       <p:sp>
         <p:nvSpPr>
-          <p:cNvPr id="47" name="Shape 42"/>
+          <p:cNvPr id="57" name="Shape 48"/>
           <p:cNvSpPr/>
           <p:nvPr/>
         </p:nvSpPr>
         <p:spPr>
           <a:xfrm>
-            <a:off x="22592538" y="15453360"/>
-            <a:ext cx="5945886" cy="2606040"/>
+            <a:off x="15898554" y="14465808"/>
+            <a:ext cx="4296726" cy="1783080"/>
           </a:xfrm>
           <a:prstGeom prst="roundRect">
             <a:avLst>
-              <a:gd name="adj" fmla="val 7018"/>
+              <a:gd name="adj" fmla="val 6154"/>
             </a:avLst>
           </a:prstGeom>
           <a:solidFill>
@@ -2764,14 +3383,14 @@
       </p:sp>
       <p:sp>
         <p:nvSpPr>
-          <p:cNvPr id="48" name="Text 43"/>
+          <p:cNvPr id="58" name="Text 49"/>
           <p:cNvSpPr txBox="1"/>
           <p:nvPr/>
         </p:nvSpPr>
         <p:spPr>
           <a:xfrm>
-            <a:off x="22866858" y="15590520"/>
-            <a:ext cx="5397246" cy="1234440"/>
+            <a:off x="16081434" y="14557248"/>
+            <a:ext cx="3930966" cy="731520"/>
           </a:xfrm>
           <a:prstGeom prst="rect">
             <a:avLst/>
@@ -2787,7 +3406,7 @@
               <a:buNone/>
             </a:pPr>
             <a:r>
-              <a:rPr lang="en-US" sz="6000" b="1" dirty="0">
+              <a:rPr lang="en-US" sz="4200" b="1" dirty="0">
                 <a:solidFill>
                   <a:srgbClr val="14305C"/>
                 </a:solidFill>
@@ -2795,22 +3414,22 @@
                 <a:ea typeface="Calibri" pitchFamily="34" charset="-122"/>
                 <a:cs typeface="Calibri" pitchFamily="34" charset="-120"/>
               </a:rPr>
-              <a:t>112 / 112</a:t>
-            </a:r>
-            <a:endParaRPr lang="en-US" sz="6000" dirty="0"/>
-          </a:p>
-        </p:txBody>
-      </p:sp>
-      <p:sp>
-        <p:nvSpPr>
-          <p:cNvPr id="49" name="Text 44"/>
+              <a:t>0.9 to 3.1 %</a:t>
+            </a:r>
+            <a:endParaRPr lang="en-US" sz="4200" dirty="0"/>
+          </a:p>
+        </p:txBody>
+      </p:sp>
+      <p:sp>
+        <p:nvSpPr>
+          <p:cNvPr id="59" name="Text 50"/>
           <p:cNvSpPr txBox="1"/>
           <p:nvPr/>
         </p:nvSpPr>
         <p:spPr>
           <a:xfrm>
-            <a:off x="22866858" y="16870680"/>
-            <a:ext cx="5397246" cy="1097280"/>
+            <a:off x="16081434" y="15307056"/>
+            <a:ext cx="3976686" cy="896112"/>
           </a:xfrm>
           <a:prstGeom prst="rect">
             <a:avLst/>
@@ -2828,13 +3447,13 @@
             <a:r>
               <a:rPr lang="en-US" sz="2400" dirty="0">
                 <a:solidFill>
-                  <a:srgbClr val="4A5566"/>
-                </a:solidFill>
-                <a:latin typeface="Calibri" pitchFamily="34" charset="0"/>
-                <a:ea typeface="Calibri" pitchFamily="34" charset="-122"/>
-                <a:cs typeface="Calibri" pitchFamily="34" charset="-120"/>
-              </a:rPr>
-              <a:t>records stored in the database across a 10-minute LTE outage</a:t>
+                  <a:srgbClr val="1B1F24"/>
+                </a:solidFill>
+                <a:latin typeface="Calibri" pitchFamily="34" charset="0"/>
+                <a:ea typeface="Calibri" pitchFamily="34" charset="-122"/>
+                <a:cs typeface="Calibri" pitchFamily="34" charset="-120"/>
+              </a:rPr>
+              <a:t>of road vibration energy in the motor lines, powered passes</a:t>
             </a:r>
             <a:endParaRPr lang="en-US" sz="2400" dirty="0"/>
           </a:p>
@@ -2842,18 +3461,18 @@
       </p:sp>
       <p:sp>
         <p:nvSpPr>
-          <p:cNvPr id="50" name="Shape 45"/>
+          <p:cNvPr id="60" name="Shape 51"/>
           <p:cNvSpPr/>
           <p:nvPr/>
         </p:nvSpPr>
         <p:spPr>
           <a:xfrm>
-            <a:off x="16189452" y="18379440"/>
-            <a:ext cx="5945886" cy="2606040"/>
+            <a:off x="11400660" y="16450056"/>
+            <a:ext cx="4296726" cy="1783080"/>
           </a:xfrm>
           <a:prstGeom prst="roundRect">
             <a:avLst>
-              <a:gd name="adj" fmla="val 7018"/>
+              <a:gd name="adj" fmla="val 6154"/>
             </a:avLst>
           </a:prstGeom>
           <a:solidFill>
@@ -2869,14 +3488,14 @@
       </p:sp>
       <p:sp>
         <p:nvSpPr>
-          <p:cNvPr id="51" name="Text 46"/>
+          <p:cNvPr id="61" name="Text 52"/>
           <p:cNvSpPr txBox="1"/>
           <p:nvPr/>
         </p:nvSpPr>
         <p:spPr>
           <a:xfrm>
-            <a:off x="16463772" y="18516600"/>
-            <a:ext cx="5397246" cy="1234440"/>
+            <a:off x="11583540" y="16541496"/>
+            <a:ext cx="3930966" cy="731520"/>
           </a:xfrm>
           <a:prstGeom prst="rect">
             <a:avLst/>
@@ -2892,30 +3511,30 @@
               <a:buNone/>
             </a:pPr>
             <a:r>
-              <a:rPr lang="en-US" sz="6000" b="1" dirty="0">
-                <a:solidFill>
-                  <a:srgbClr val="14305C"/>
-                </a:solidFill>
-                <a:latin typeface="Calibri" pitchFamily="34" charset="0"/>
-                <a:ea typeface="Calibri" pitchFamily="34" charset="-122"/>
-                <a:cs typeface="Calibri" pitchFamily="34" charset="-120"/>
-              </a:rPr>
-              <a:t>within 2 %</a:t>
-            </a:r>
-            <a:endParaRPr lang="en-US" sz="6000" dirty="0"/>
-          </a:p>
-        </p:txBody>
-      </p:sp>
-      <p:sp>
-        <p:nvSpPr>
-          <p:cNvPr id="52" name="Text 47"/>
+              <a:rPr lang="en-US" sz="4200" b="1" dirty="0">
+                <a:solidFill>
+                  <a:srgbClr val="1B7F3B"/>
+                </a:solidFill>
+                <a:latin typeface="Calibri" pitchFamily="34" charset="0"/>
+                <a:ea typeface="Calibri" pitchFamily="34" charset="-122"/>
+                <a:cs typeface="Calibri" pitchFamily="34" charset="-120"/>
+              </a:rPr>
+              <a:t>0 gaps</a:t>
+            </a:r>
+            <a:endParaRPr lang="en-US" sz="4200" dirty="0"/>
+          </a:p>
+        </p:txBody>
+      </p:sp>
+      <p:sp>
+        <p:nvSpPr>
+          <p:cNvPr id="62" name="Text 53"/>
           <p:cNvSpPr txBox="1"/>
           <p:nvPr/>
         </p:nvSpPr>
         <p:spPr>
           <a:xfrm>
-            <a:off x="16463772" y="19796760"/>
-            <a:ext cx="5397246" cy="1097280"/>
+            <a:off x="11583540" y="17291304"/>
+            <a:ext cx="3976686" cy="896112"/>
           </a:xfrm>
           <a:prstGeom prst="rect">
             <a:avLst/>
@@ -2933,13 +3552,13 @@
             <a:r>
               <a:rPr lang="en-US" sz="2400" dirty="0">
                 <a:solidFill>
-                  <a:srgbClr val="4A5566"/>
-                </a:solidFill>
-                <a:latin typeface="Calibri" pitchFamily="34" charset="0"/>
-                <a:ea typeface="Calibri" pitchFamily="34" charset="-122"/>
-                <a:cs typeface="Calibri" pitchFamily="34" charset="-120"/>
-              </a:rPr>
-              <a:t>time to contact in 40 synthetic tests; 0.27 ms per frame</a:t>
+                  <a:srgbClr val="1B1F24"/>
+                </a:solidFill>
+                <a:latin typeface="Calibri" pitchFamily="34" charset="0"/>
+                <a:ea typeface="Calibri" pitchFamily="34" charset="-122"/>
+                <a:cs typeface="Calibri" pitchFamily="34" charset="-120"/>
+              </a:rPr>
+              <a:t>front IMU at 200 Hz; rear 0.08 % of samples lost</a:t>
             </a:r>
             <a:endParaRPr lang="en-US" sz="2400" dirty="0"/>
           </a:p>
@@ -2947,18 +3566,18 @@
       </p:sp>
       <p:sp>
         <p:nvSpPr>
-          <p:cNvPr id="53" name="Shape 48"/>
+          <p:cNvPr id="63" name="Shape 54"/>
           <p:cNvSpPr/>
           <p:nvPr/>
         </p:nvSpPr>
         <p:spPr>
           <a:xfrm>
-            <a:off x="22592538" y="18379440"/>
-            <a:ext cx="5945886" cy="2606040"/>
+            <a:off x="15898554" y="16450056"/>
+            <a:ext cx="4296726" cy="1783080"/>
           </a:xfrm>
           <a:prstGeom prst="roundRect">
             <a:avLst>
-              <a:gd name="adj" fmla="val 7018"/>
+              <a:gd name="adj" fmla="val 6154"/>
             </a:avLst>
           </a:prstGeom>
           <a:solidFill>
@@ -2974,14 +3593,14 @@
       </p:sp>
       <p:sp>
         <p:nvSpPr>
-          <p:cNvPr id="54" name="Text 49"/>
+          <p:cNvPr id="64" name="Text 55"/>
           <p:cNvSpPr txBox="1"/>
           <p:nvPr/>
         </p:nvSpPr>
         <p:spPr>
           <a:xfrm>
-            <a:off x="22866858" y="18516600"/>
-            <a:ext cx="5397246" cy="1234440"/>
+            <a:off x="16081434" y="16541496"/>
+            <a:ext cx="3930966" cy="731520"/>
           </a:xfrm>
           <a:prstGeom prst="rect">
             <a:avLst/>
@@ -2997,30 +3616,30 @@
               <a:buNone/>
             </a:pPr>
             <a:r>
-              <a:rPr lang="en-US" sz="6000" b="1" dirty="0">
-                <a:solidFill>
-                  <a:srgbClr val="14305C"/>
-                </a:solidFill>
-                <a:latin typeface="Calibri" pitchFamily="34" charset="0"/>
-                <a:ea typeface="Calibri" pitchFamily="34" charset="-122"/>
-                <a:cs typeface="Calibri" pitchFamily="34" charset="-120"/>
-              </a:rPr>
-              <a:t>about 20 W</a:t>
-            </a:r>
-            <a:endParaRPr lang="en-US" sz="6000" dirty="0"/>
-          </a:p>
-        </p:txBody>
-      </p:sp>
-      <p:sp>
-        <p:nvSpPr>
-          <p:cNvPr id="55" name="Text 50"/>
+              <a:rPr lang="en-US" sz="4200" b="1" dirty="0">
+                <a:solidFill>
+                  <a:srgbClr val="1B7F3B"/>
+                </a:solidFill>
+                <a:latin typeface="Calibri" pitchFamily="34" charset="0"/>
+                <a:ea typeface="Calibri" pitchFamily="34" charset="-122"/>
+                <a:cs typeface="Calibri" pitchFamily="34" charset="-120"/>
+              </a:rPr>
+              <a:t>99.9 %</a:t>
+            </a:r>
+            <a:endParaRPr lang="en-US" sz="4200" dirty="0"/>
+          </a:p>
+        </p:txBody>
+      </p:sp>
+      <p:sp>
+        <p:nvSpPr>
+          <p:cNvPr id="65" name="Text 56"/>
           <p:cNvSpPr txBox="1"/>
           <p:nvPr/>
         </p:nvSpPr>
         <p:spPr>
           <a:xfrm>
-            <a:off x="22866858" y="19796760"/>
-            <a:ext cx="5397246" cy="1097280"/>
+            <a:off x="16081434" y="17291304"/>
+            <a:ext cx="3976686" cy="896112"/>
           </a:xfrm>
           <a:prstGeom prst="rect">
             <a:avLst/>
@@ -3038,13 +3657,13 @@
             <a:r>
               <a:rPr lang="en-US" sz="2400" dirty="0">
                 <a:solidFill>
-                  <a:srgbClr val="4A5566"/>
-                </a:solidFill>
-                <a:latin typeface="Calibri" pitchFamily="34" charset="0"/>
-                <a:ea typeface="Calibri" pitchFamily="34" charset="-122"/>
-                <a:cs typeface="Calibri" pitchFamily="34" charset="-120"/>
-              </a:rPr>
-              <a:t>power budget, 0.27 A from the 72 V pack; only the Pi 5 measured</a:t>
+                  <a:srgbClr val="1B1F24"/>
+                </a:solidFill>
+                <a:latin typeface="Calibri" pitchFamily="34" charset="0"/>
+                <a:ea typeface="Calibri" pitchFamily="34" charset="-122"/>
+                <a:cs typeface="Calibri" pitchFamily="34" charset="-120"/>
+              </a:rPr>
+              <a:t>of records over the wired link to the Raspberry Pi 4</a:t>
             </a:r>
             <a:endParaRPr lang="en-US" sz="2400" dirty="0"/>
           </a:p>
@@ -3052,18 +3671,228 @@
       </p:sp>
       <p:sp>
         <p:nvSpPr>
-          <p:cNvPr id="56" name="Shape 51"/>
+          <p:cNvPr id="66" name="Shape 57"/>
           <p:cNvSpPr/>
           <p:nvPr/>
         </p:nvSpPr>
         <p:spPr>
           <a:xfrm>
-            <a:off x="15549372" y="22265640"/>
-            <a:ext cx="13629132" cy="6035040"/>
+            <a:off x="11400660" y="18434304"/>
+            <a:ext cx="4296726" cy="1783080"/>
           </a:xfrm>
           <a:prstGeom prst="roundRect">
             <a:avLst>
-              <a:gd name="adj" fmla="val 5303"/>
+              <a:gd name="adj" fmla="val 6154"/>
+            </a:avLst>
+          </a:prstGeom>
+          <a:solidFill>
+            <a:srgbClr val="FFFFFF"/>
+          </a:solidFill>
+          <a:ln w="12700">
+            <a:solidFill>
+              <a:srgbClr val="FFFFFF"/>
+            </a:solidFill>
+            <a:prstDash val="solid"/>
+          </a:ln>
+        </p:spPr>
+      </p:sp>
+      <p:sp>
+        <p:nvSpPr>
+          <p:cNvPr id="67" name="Text 58"/>
+          <p:cNvSpPr txBox="1"/>
+          <p:nvPr/>
+        </p:nvSpPr>
+        <p:spPr>
+          <a:xfrm>
+            <a:off x="11583540" y="18525744"/>
+            <a:ext cx="3930966" cy="731520"/>
+          </a:xfrm>
+          <a:prstGeom prst="rect">
+            <a:avLst/>
+          </a:prstGeom>
+          <a:noFill/>
+          <a:ln/>
+        </p:spPr>
+        <p:txBody>
+          <a:bodyPr wrap="square" lIns="0" tIns="0" rIns="0" bIns="0" rtlCol="0" anchor="ctr"/>
+          <a:lstStyle/>
+          <a:p>
+            <a:pPr indent="0" marL="0">
+              <a:buNone/>
+            </a:pPr>
+            <a:r>
+              <a:rPr lang="en-US" sz="4200" b="1" dirty="0">
+                <a:solidFill>
+                  <a:srgbClr val="14305C"/>
+                </a:solidFill>
+                <a:latin typeface="Calibri" pitchFamily="34" charset="0"/>
+                <a:ea typeface="Calibri" pitchFamily="34" charset="-122"/>
+                <a:cs typeface="Calibri" pitchFamily="34" charset="-120"/>
+              </a:rPr>
+              <a:t>153 records</a:t>
+            </a:r>
+            <a:endParaRPr lang="en-US" sz="4200" dirty="0"/>
+          </a:p>
+        </p:txBody>
+      </p:sp>
+      <p:sp>
+        <p:nvSpPr>
+          <p:cNvPr id="68" name="Text 59"/>
+          <p:cNvSpPr txBox="1"/>
+          <p:nvPr/>
+        </p:nvSpPr>
+        <p:spPr>
+          <a:xfrm>
+            <a:off x="11583540" y="19275552"/>
+            <a:ext cx="3976686" cy="896112"/>
+          </a:xfrm>
+          <a:prstGeom prst="rect">
+            <a:avLst/>
+          </a:prstGeom>
+          <a:noFill/>
+          <a:ln/>
+        </p:spPr>
+        <p:txBody>
+          <a:bodyPr wrap="square" lIns="0" tIns="0" rIns="0" bIns="0" rtlCol="0" anchor="t"/>
+          <a:lstStyle/>
+          <a:p>
+            <a:pPr indent="0" marL="0">
+              <a:buNone/>
+            </a:pPr>
+            <a:r>
+              <a:rPr lang="en-US" sz="2400" dirty="0">
+                <a:solidFill>
+                  <a:srgbClr val="1B1F24"/>
+                </a:solidFill>
+                <a:latin typeface="Calibri" pitchFamily="34" charset="0"/>
+                <a:ea typeface="Calibri" pitchFamily="34" charset="-122"/>
+                <a:cs typeface="Calibri" pitchFamily="34" charset="-120"/>
+              </a:rPr>
+              <a:t>over LTE, 116 replayed after the drop; median 0.44 s (n = 9)</a:t>
+            </a:r>
+            <a:endParaRPr lang="en-US" sz="2400" dirty="0"/>
+          </a:p>
+        </p:txBody>
+      </p:sp>
+      <p:sp>
+        <p:nvSpPr>
+          <p:cNvPr id="69" name="Shape 60"/>
+          <p:cNvSpPr/>
+          <p:nvPr/>
+        </p:nvSpPr>
+        <p:spPr>
+          <a:xfrm>
+            <a:off x="15898554" y="18434304"/>
+            <a:ext cx="4296726" cy="1783080"/>
+          </a:xfrm>
+          <a:prstGeom prst="roundRect">
+            <a:avLst>
+              <a:gd name="adj" fmla="val 6154"/>
+            </a:avLst>
+          </a:prstGeom>
+          <a:solidFill>
+            <a:srgbClr val="FFFFFF"/>
+          </a:solidFill>
+          <a:ln w="12700">
+            <a:solidFill>
+              <a:srgbClr val="FFFFFF"/>
+            </a:solidFill>
+            <a:prstDash val="solid"/>
+          </a:ln>
+        </p:spPr>
+      </p:sp>
+      <p:sp>
+        <p:nvSpPr>
+          <p:cNvPr id="70" name="Text 61"/>
+          <p:cNvSpPr txBox="1"/>
+          <p:nvPr/>
+        </p:nvSpPr>
+        <p:spPr>
+          <a:xfrm>
+            <a:off x="16081434" y="18525744"/>
+            <a:ext cx="3930966" cy="731520"/>
+          </a:xfrm>
+          <a:prstGeom prst="rect">
+            <a:avLst/>
+          </a:prstGeom>
+          <a:noFill/>
+          <a:ln/>
+        </p:spPr>
+        <p:txBody>
+          <a:bodyPr wrap="square" lIns="0" tIns="0" rIns="0" bIns="0" rtlCol="0" anchor="ctr"/>
+          <a:lstStyle/>
+          <a:p>
+            <a:pPr indent="0" marL="0">
+              <a:buNone/>
+            </a:pPr>
+            <a:r>
+              <a:rPr lang="en-US" sz="4200" b="1" dirty="0">
+                <a:solidFill>
+                  <a:srgbClr val="14305C"/>
+                </a:solidFill>
+                <a:latin typeface="Calibri" pitchFamily="34" charset="0"/>
+                <a:ea typeface="Calibri" pitchFamily="34" charset="-122"/>
+                <a:cs typeface="Calibri" pitchFamily="34" charset="-120"/>
+              </a:rPr>
+              <a:t>23.3 / 12.1 fps</a:t>
+            </a:r>
+            <a:endParaRPr lang="en-US" sz="4200" dirty="0"/>
+          </a:p>
+        </p:txBody>
+      </p:sp>
+      <p:sp>
+        <p:nvSpPr>
+          <p:cNvPr id="71" name="Text 62"/>
+          <p:cNvSpPr txBox="1"/>
+          <p:nvPr/>
+        </p:nvSpPr>
+        <p:spPr>
+          <a:xfrm>
+            <a:off x="16081434" y="19275552"/>
+            <a:ext cx="3976686" cy="896112"/>
+          </a:xfrm>
+          <a:prstGeom prst="rect">
+            <a:avLst/>
+          </a:prstGeom>
+          <a:noFill/>
+          <a:ln/>
+        </p:spPr>
+        <p:txBody>
+          <a:bodyPr wrap="square" lIns="0" tIns="0" rIns="0" bIns="0" rtlCol="0" anchor="t"/>
+          <a:lstStyle/>
+          <a:p>
+            <a:pPr indent="0" marL="0">
+              <a:buNone/>
+            </a:pPr>
+            <a:r>
+              <a:rPr lang="en-US" sz="2400" dirty="0">
+                <a:solidFill>
+                  <a:srgbClr val="1B1F24"/>
+                </a:solidFill>
+                <a:latin typeface="Calibri" pitchFamily="34" charset="0"/>
+                <a:ea typeface="Calibri" pitchFamily="34" charset="-122"/>
+                <a:cs typeface="Calibri" pitchFamily="34" charset="-120"/>
+              </a:rPr>
+              <a:t>detection, front / rear; median 68 / 103 ms</a:t>
+            </a:r>
+            <a:endParaRPr lang="en-US" sz="2400" dirty="0"/>
+          </a:p>
+        </p:txBody>
+      </p:sp>
+      <p:sp>
+        <p:nvSpPr>
+          <p:cNvPr id="72" name="Shape 63"/>
+          <p:cNvSpPr/>
+          <p:nvPr/>
+        </p:nvSpPr>
+        <p:spPr>
+          <a:xfrm>
+            <a:off x="10943460" y="21076920"/>
+            <a:ext cx="9709020" cy="4114800"/>
+          </a:xfrm>
+          <a:prstGeom prst="roundRect">
+            <a:avLst>
+              <a:gd name="adj" fmla="val 6667"/>
             </a:avLst>
           </a:prstGeom>
           <a:solidFill>
@@ -3079,14 +3908,14 @@
       </p:sp>
       <p:sp>
         <p:nvSpPr>
-          <p:cNvPr id="57" name="Shape 52"/>
+          <p:cNvPr id="73" name="Shape 64"/>
           <p:cNvSpPr/>
           <p:nvPr/>
         </p:nvSpPr>
         <p:spPr>
           <a:xfrm>
-            <a:off x="16052292" y="22722840"/>
-            <a:ext cx="1143000" cy="1143000"/>
+            <a:off x="11309220" y="21396960"/>
+            <a:ext cx="914400" cy="914400"/>
           </a:xfrm>
           <a:prstGeom prst="ellipse">
             <a:avLst/>
@@ -3104,14 +3933,14 @@
       </p:sp>
       <p:sp>
         <p:nvSpPr>
-          <p:cNvPr id="58" name="Text 53"/>
+          <p:cNvPr id="74" name="Text 65"/>
           <p:cNvSpPr txBox="1"/>
           <p:nvPr/>
         </p:nvSpPr>
         <p:spPr>
           <a:xfrm>
-            <a:off x="16052292" y="22722840"/>
-            <a:ext cx="1143000" cy="1143000"/>
+            <a:off x="11309220" y="21396960"/>
+            <a:ext cx="914400" cy="914400"/>
           </a:xfrm>
           <a:prstGeom prst="rect">
             <a:avLst/>
@@ -3127,7 +3956,7 @@
               <a:buNone/>
             </a:pPr>
             <a:r>
-              <a:rPr lang="en-US" sz="4400" b="1" dirty="0">
+              <a:rPr lang="en-US" sz="4000" b="1" dirty="0">
                 <a:solidFill>
                   <a:srgbClr val="FFFFFF"/>
                 </a:solidFill>
@@ -3137,20 +3966,20 @@
               </a:rPr>
               <a:t>5</a:t>
             </a:r>
-            <a:endParaRPr lang="en-US" sz="4400" dirty="0"/>
-          </a:p>
-        </p:txBody>
-      </p:sp>
-      <p:sp>
-        <p:nvSpPr>
-          <p:cNvPr id="59" name="Text 54"/>
+            <a:endParaRPr lang="en-US" sz="4000" dirty="0"/>
+          </a:p>
+        </p:txBody>
+      </p:sp>
+      <p:sp>
+        <p:nvSpPr>
+          <p:cNvPr id="75" name="Text 66"/>
           <p:cNvSpPr txBox="1"/>
           <p:nvPr/>
         </p:nvSpPr>
         <p:spPr>
           <a:xfrm>
-            <a:off x="17515332" y="22677120"/>
-            <a:ext cx="11251692" cy="1234440"/>
+            <a:off x="12452220" y="21351240"/>
+            <a:ext cx="7880220" cy="1005840"/>
           </a:xfrm>
           <a:prstGeom prst="rect">
             <a:avLst/>
@@ -3166,7 +3995,7 @@
               <a:buNone/>
             </a:pPr>
             <a:r>
-              <a:rPr lang="en-US" sz="5600" b="1" dirty="0">
+              <a:rPr lang="en-US" sz="4800" b="1" dirty="0">
                 <a:solidFill>
                   <a:srgbClr val="14305C"/>
                 </a:solidFill>
@@ -3174,22 +4003,22 @@
                 <a:ea typeface="Calibri" pitchFamily="34" charset="-122"/>
                 <a:cs typeface="Calibri" pitchFamily="34" charset="-120"/>
               </a:rPr>
-              <a:t>Fault investigations</a:t>
-            </a:r>
-            <a:endParaRPr lang="en-US" sz="5600" dirty="0"/>
-          </a:p>
-        </p:txBody>
-      </p:sp>
-      <p:sp>
-        <p:nvSpPr>
-          <p:cNvPr id="60" name="Text 55"/>
+              <a:t>Limitations</a:t>
+            </a:r>
+            <a:endParaRPr lang="en-US" sz="4800" dirty="0"/>
+          </a:p>
+        </p:txBody>
+      </p:sp>
+      <p:sp>
+        <p:nvSpPr>
+          <p:cNvPr id="76" name="Text 67"/>
           <p:cNvSpPr txBox="1"/>
           <p:nvPr/>
         </p:nvSpPr>
         <p:spPr>
           <a:xfrm>
-            <a:off x="16189452" y="24277320"/>
-            <a:ext cx="12348972" cy="3840480"/>
+            <a:off x="11400660" y="22585680"/>
+            <a:ext cx="8794620" cy="2514600"/>
           </a:xfrm>
           <a:prstGeom prst="rect">
             <a:avLst/>
@@ -3201,15 +4030,15 @@
           <a:bodyPr wrap="square" lIns="0" tIns="0" rIns="0" bIns="0" rtlCol="0" anchor="t"/>
           <a:lstStyle/>
           <a:p>
-            <a:pPr marL="406400" indent="-406400">
+            <a:pPr marL="355600" indent="-355600">
               <a:spcAft>
-                <a:spcPts val="1400"/>
+                <a:spcPts val="1000"/>
               </a:spcAft>
               <a:buSzPct val="100000"/>
               <a:buChar char="•"/>
             </a:pPr>
             <a:r>
-              <a:rPr lang="en-US" sz="2800" dirty="0">
+              <a:rPr lang="en-US" sz="2500" dirty="0">
                 <a:solidFill>
                   <a:srgbClr val="1B1F24"/>
                 </a:solidFill>
@@ -3217,20 +4046,20 @@
                 <a:ea typeface="Calibri" pitchFamily="34" charset="-122"/>
                 <a:cs typeface="Calibri" pitchFamily="34" charset="-120"/>
               </a:rPr>
-              <a:t>Seven faults diagnosed as symptom, candidate causes, deciding test, cause and fix, from a flash-mode boot loop to a battery checksum off by 3.</a:t>
-            </a:r>
-            <a:endParaRPr lang="en-US" sz="2800" dirty="0"/>
-          </a:p>
-          <a:p>
-            <a:pPr marL="406400" indent="-406400">
+              <a:t>One vehicle, two short low-speed sessions; no reference accelerometer, so repeatability, not accuracy.</a:t>
+            </a:r>
+            <a:endParaRPr lang="en-US" sz="2500" dirty="0"/>
+          </a:p>
+          <a:p>
+            <a:pPr marL="355600" indent="-355600">
               <a:spcAft>
-                <a:spcPts val="1400"/>
+                <a:spcPts val="1000"/>
               </a:spcAft>
               <a:buSzPct val="100000"/>
               <a:buChar char="•"/>
             </a:pPr>
             <a:r>
-              <a:rPr lang="en-US" sz="2800" dirty="0">
+              <a:rPr lang="en-US" sz="2500" dirty="0">
                 <a:solidFill>
                   <a:srgbClr val="1B1F24"/>
                 </a:solidFill>
@@ -3238,26 +4067,47 @@
                 <a:ea typeface="Calibri" pitchFamily="34" charset="-122"/>
                 <a:cs typeface="Calibri" pitchFamily="34" charset="-120"/>
               </a:rPr>
-              <a:t>The one that mattered most: Pi 4 reboots. Power flags logged every 2 s showed under-voltage 14 s after the modem came up on its USB port; it returned in the closed box (76.9 °C), so the unit needs its own supply.</a:t>
-            </a:r>
-            <a:endParaRPr lang="en-US" sz="2800" dirty="0"/>
-          </a:p>
-        </p:txBody>
-      </p:sp>
-      <p:sp>
-        <p:nvSpPr>
-          <p:cNvPr id="61" name="Shape 56"/>
+              <a:t>LTE did not reconnect after 11:51; the vehicle's GNSS lay 8 to 25 m from the phone's.</a:t>
+            </a:r>
+            <a:endParaRPr lang="en-US" sz="2500" dirty="0"/>
+          </a:p>
+          <a:p>
+            <a:pPr marL="355600" indent="-355600">
+              <a:spcAft>
+                <a:spcPts val="1000"/>
+              </a:spcAft>
+              <a:buSzPct val="100000"/>
+              <a:buChar char="•"/>
+            </a:pPr>
+            <a:r>
+              <a:rPr lang="en-US" sz="2500" dirty="0">
+                <a:solidFill>
+                  <a:srgbClr val="1B1F24"/>
+                </a:solidFill>
+                <a:latin typeface="Calibri" pitchFamily="34" charset="0"/>
+                <a:ea typeface="Calibri" pitchFamily="34" charset="-122"/>
+                <a:cs typeface="Calibri" pitchFamily="34" charset="-120"/>
+              </a:rPr>
+              <a:t>Warnings below ISO 15008 legibility; the driver's glance time was not measured.</a:t>
+            </a:r>
+            <a:endParaRPr lang="en-US" sz="2500" dirty="0"/>
+          </a:p>
+        </p:txBody>
+      </p:sp>
+      <p:sp>
+        <p:nvSpPr>
+          <p:cNvPr id="77" name="Shape 68"/>
           <p:cNvSpPr/>
           <p:nvPr/>
         </p:nvSpPr>
         <p:spPr>
           <a:xfrm>
-            <a:off x="15549372" y="29123640"/>
-            <a:ext cx="13629132" cy="10844784"/>
+            <a:off x="10943460" y="25694640"/>
+            <a:ext cx="9709020" cy="3849840"/>
           </a:xfrm>
           <a:prstGeom prst="roundRect">
             <a:avLst>
-              <a:gd name="adj" fmla="val 2951"/>
+              <a:gd name="adj" fmla="val 7125"/>
             </a:avLst>
           </a:prstGeom>
           <a:solidFill>
@@ -3273,14 +4123,14 @@
       </p:sp>
       <p:sp>
         <p:nvSpPr>
-          <p:cNvPr id="62" name="Shape 57"/>
+          <p:cNvPr id="78" name="Shape 69"/>
           <p:cNvSpPr/>
           <p:nvPr/>
         </p:nvSpPr>
         <p:spPr>
           <a:xfrm>
-            <a:off x="16052292" y="29580840"/>
-            <a:ext cx="1143000" cy="1143000"/>
+            <a:off x="11309220" y="26014680"/>
+            <a:ext cx="914400" cy="914400"/>
           </a:xfrm>
           <a:prstGeom prst="ellipse">
             <a:avLst/>
@@ -3298,14 +4148,14 @@
       </p:sp>
       <p:sp>
         <p:nvSpPr>
-          <p:cNvPr id="63" name="Text 58"/>
+          <p:cNvPr id="79" name="Text 70"/>
           <p:cNvSpPr txBox="1"/>
           <p:nvPr/>
         </p:nvSpPr>
         <p:spPr>
           <a:xfrm>
-            <a:off x="16052292" y="29580840"/>
-            <a:ext cx="1143000" cy="1143000"/>
+            <a:off x="11309220" y="26014680"/>
+            <a:ext cx="914400" cy="914400"/>
           </a:xfrm>
           <a:prstGeom prst="rect">
             <a:avLst/>
@@ -3321,7 +4171,7 @@
               <a:buNone/>
             </a:pPr>
             <a:r>
-              <a:rPr lang="en-US" sz="4400" b="1" dirty="0">
+              <a:rPr lang="en-US" sz="4000" b="1" dirty="0">
                 <a:solidFill>
                   <a:srgbClr val="FFFFFF"/>
                 </a:solidFill>
@@ -3331,20 +4181,20 @@
               </a:rPr>
               <a:t>6</a:t>
             </a:r>
-            <a:endParaRPr lang="en-US" sz="4400" dirty="0"/>
-          </a:p>
-        </p:txBody>
-      </p:sp>
-      <p:sp>
-        <p:nvSpPr>
-          <p:cNvPr id="64" name="Text 59"/>
+            <a:endParaRPr lang="en-US" sz="4000" dirty="0"/>
+          </a:p>
+        </p:txBody>
+      </p:sp>
+      <p:sp>
+        <p:nvSpPr>
+          <p:cNvPr id="80" name="Text 71"/>
           <p:cNvSpPr txBox="1"/>
           <p:nvPr/>
         </p:nvSpPr>
         <p:spPr>
           <a:xfrm>
-            <a:off x="17515332" y="29535120"/>
-            <a:ext cx="11251692" cy="1234440"/>
+            <a:off x="12452220" y="25968960"/>
+            <a:ext cx="7880220" cy="1005840"/>
           </a:xfrm>
           <a:prstGeom prst="rect">
             <a:avLst/>
@@ -3360,7 +4210,7 @@
               <a:buNone/>
             </a:pPr>
             <a:r>
-              <a:rPr lang="en-US" sz="5600" b="1" dirty="0">
+              <a:rPr lang="en-US" sz="4800" b="1" dirty="0">
                 <a:solidFill>
                   <a:srgbClr val="14305C"/>
                 </a:solidFill>
@@ -3368,22 +4218,22 @@
                 <a:ea typeface="Calibri" pitchFamily="34" charset="-122"/>
                 <a:cs typeface="Calibri" pitchFamily="34" charset="-120"/>
               </a:rPr>
-              <a:t>On the vehicle: road and stands</a:t>
-            </a:r>
-            <a:endParaRPr lang="en-US" sz="5600" dirty="0"/>
-          </a:p>
-        </p:txBody>
-      </p:sp>
-      <p:sp>
-        <p:nvSpPr>
-          <p:cNvPr id="65" name="Text 60"/>
+              <a:t>Conclusion</a:t>
+            </a:r>
+            <a:endParaRPr lang="en-US" sz="4800" dirty="0"/>
+          </a:p>
+        </p:txBody>
+      </p:sp>
+      <p:sp>
+        <p:nvSpPr>
+          <p:cNvPr id="81" name="Text 72"/>
           <p:cNvSpPr txBox="1"/>
           <p:nvPr/>
         </p:nvSpPr>
         <p:spPr>
           <a:xfrm>
-            <a:off x="16189452" y="31135320"/>
-            <a:ext cx="12348972" cy="1828800"/>
+            <a:off x="11400660" y="27203400"/>
+            <a:ext cx="5594220" cy="2203920"/>
           </a:xfrm>
           <a:prstGeom prst="rect">
             <a:avLst/>
@@ -3395,15 +4245,15 @@
           <a:bodyPr wrap="square" lIns="0" tIns="0" rIns="0" bIns="0" rtlCol="0" anchor="t"/>
           <a:lstStyle/>
           <a:p>
-            <a:pPr marL="406400" indent="-406400">
+            <a:pPr marL="355600" indent="-355600">
               <a:spcAft>
-                <a:spcPts val="1400"/>
+                <a:spcPts val="1000"/>
               </a:spcAft>
               <a:buSzPct val="100000"/>
               <a:buChar char="•"/>
             </a:pPr>
             <a:r>
-              <a:rPr lang="en-US" sz="2800" dirty="0">
+              <a:rPr lang="en-US" sz="2500" dirty="0">
                 <a:solidFill>
                   <a:srgbClr val="1B1F24"/>
                 </a:solidFill>
@@ -3411,30 +4261,76 @@
                 <a:ea typeface="Calibri" pitchFamily="34" charset="-122"/>
                 <a:cs typeface="Calibri" pitchFamily="34" charset="-120"/>
               </a:rPr>
-              <a:t>Road session, 19 Oct: 108.6 min recorded, about 16 min driving. 200 Hz with no counted drops, but one 2 s stall: R1 not met on the vehicle. Battery link held at up to 46.9 A. No GNSS fix (no antenna).</a:t>
-            </a:r>
-            <a:endParaRPr lang="en-US" sz="2800" dirty="0"/>
-          </a:p>
-        </p:txBody>
+              <a:t>The unit ran on the trike; its ride reading repeats over whole passes, separates two surfaces and is dominated by the road.</a:t>
+            </a:r>
+            <a:endParaRPr lang="en-US" sz="2500" dirty="0"/>
+          </a:p>
+          <a:p>
+            <a:pPr marL="355600" indent="-355600">
+              <a:spcAft>
+                <a:spcPts val="1000"/>
+              </a:spcAft>
+              <a:buSzPct val="100000"/>
+              <a:buChar char="•"/>
+            </a:pPr>
+            <a:r>
+              <a:rPr lang="en-US" sz="2500" dirty="0">
+                <a:solidFill>
+                  <a:srgbClr val="1B1F24"/>
+                </a:solidFill>
+                <a:latin typeface="Calibri" pitchFamily="34" charset="0"/>
+                <a:ea typeface="Calibri" pitchFamily="34" charset="-122"/>
+                <a:cs typeface="Calibri" pitchFamily="34" charset="-120"/>
+              </a:rPr>
+              <a:t>Next: own supply, larger warnings, glance time.</a:t>
+            </a:r>
+            <a:endParaRPr lang="en-US" sz="2500" dirty="0"/>
+          </a:p>
+        </p:txBody>
+      </p:sp>
+      <p:sp>
+        <p:nvSpPr>
+          <p:cNvPr id="82" name="Shape 73"/>
+          <p:cNvSpPr/>
+          <p:nvPr/>
+        </p:nvSpPr>
+        <p:spPr>
+          <a:xfrm>
+            <a:off x="17863560" y="26014680"/>
+            <a:ext cx="2331720" cy="2331720"/>
+          </a:xfrm>
+          <a:prstGeom prst="rect">
+            <a:avLst/>
+          </a:prstGeom>
+          <a:solidFill>
+            <a:srgbClr val="FFFFFF"/>
+          </a:solidFill>
+          <a:ln w="12700">
+            <a:solidFill>
+              <a:srgbClr val="FFFFFF"/>
+            </a:solidFill>
+            <a:prstDash val="solid"/>
+          </a:ln>
+        </p:spPr>
       </p:sp>
       <p:pic>
         <p:nvPicPr>
-          <p:cNvPr id="66" name="Image 3" descr="C:\Users\0geda\OneDrive - University of Cape Town\Documents\PlatformIO\Projects\Tukzie-HPEC-HUD\Report\figures\results\stand_spectra_1023.png">    </p:cNvPr>
+          <p:cNvPr id="83" name="Image 6" descr="QR code to https://tuksense.site">    </p:cNvPr>
           <p:cNvPicPr>
             <a:picLocks noChangeAspect="1"/>
           </p:cNvPicPr>
           <p:nvPr/>
         </p:nvPicPr>
         <p:blipFill>
-          <a:blip r:embed="rId4"/>
+          <a:blip r:embed="rId8"/>
           <a:stretch>
             <a:fillRect/>
           </a:stretch>
         </p:blipFill>
         <p:spPr>
           <a:xfrm>
-            <a:off x="17060418" y="33055560"/>
-            <a:ext cx="10607040" cy="3818534"/>
+            <a:off x="17955000" y="26106120"/>
+            <a:ext cx="2148840" cy="2148840"/>
           </a:xfrm>
           <a:prstGeom prst="rect">
             <a:avLst/>
@@ -3443,14 +4339,14 @@
       </p:pic>
       <p:sp>
         <p:nvSpPr>
-          <p:cNvPr id="67" name="Text 61"/>
+          <p:cNvPr id="84" name="Text 74"/>
           <p:cNvSpPr txBox="1"/>
           <p:nvPr/>
         </p:nvSpPr>
         <p:spPr>
           <a:xfrm>
-            <a:off x="16189452" y="36965534"/>
-            <a:ext cx="12348972" cy="822960"/>
+            <a:off x="17040600" y="28419552"/>
+            <a:ext cx="3246120" cy="777240"/>
           </a:xfrm>
           <a:prstGeom prst="rect">
             <a:avLst/>
@@ -3462,166 +4358,28 @@
           <a:bodyPr wrap="square" lIns="0" tIns="0" rIns="0" bIns="0" rtlCol="0" anchor="t"/>
           <a:lstStyle/>
           <a:p>
-            <a:pPr indent="0" marL="0">
-              <a:buNone/>
-            </a:pPr>
-            <a:r>
-              <a:rPr lang="en-US" sz="2400" i="1" dirty="0">
-                <a:solidFill>
-                  <a:srgbClr val="4A5566"/>
-                </a:solidFill>
-                <a:latin typeface="Calibri" pitchFamily="34" charset="0"/>
-                <a:ea typeface="Calibri" pitchFamily="34" charset="-122"/>
-                <a:cs typeface="Calibri" pitchFamily="34" charset="-120"/>
-              </a:rPr>
-              <a:t>Stand runs, 23 Oct, drive wheel raised: rear vibration 5 to 7 times rest, energy 40 to 70 Hz; the same lines at the front (42.75, 49.0, 64.0 Hz). Throttle settings not recorded.</a:t>
+            <a:pPr algn="ctr" indent="0" marL="0">
+              <a:buNone/>
+            </a:pPr>
+            <a:r>
+              <a:rPr lang="en-US" sz="2400" b="1" dirty="0">
+                <a:solidFill>
+                  <a:srgbClr val="14305C"/>
+                </a:solidFill>
+                <a:latin typeface="Calibri" pitchFamily="34" charset="0"/>
+                <a:ea typeface="Calibri" pitchFamily="34" charset="-122"/>
+                <a:cs typeface="Calibri" pitchFamily="34" charset="-120"/>
+              </a:rPr>
+              <a:t>Videos of the system on the road</a:t>
             </a:r>
             <a:endParaRPr lang="en-US" sz="2400" dirty="0"/>
           </a:p>
-        </p:txBody>
-      </p:sp>
-      <p:sp>
-        <p:nvSpPr>
-          <p:cNvPr id="68" name="Text 62"/>
-          <p:cNvSpPr txBox="1"/>
-          <p:nvPr/>
-        </p:nvSpPr>
-        <p:spPr>
-          <a:xfrm>
-            <a:off x="16189452" y="37879934"/>
-            <a:ext cx="12348972" cy="1814170"/>
-          </a:xfrm>
-          <a:prstGeom prst="rect">
-            <a:avLst/>
-          </a:prstGeom>
-          <a:noFill/>
-          <a:ln/>
-        </p:spPr>
-        <p:txBody>
-          <a:bodyPr wrap="square" lIns="0" tIns="0" rIns="0" bIns="0" rtlCol="0" anchor="t"/>
-          <a:lstStyle/>
-          <a:p>
-            <a:pPr marL="406400" indent="-406400">
-              <a:buSzPct val="100000"/>
-              <a:buChar char="•"/>
-            </a:pPr>
-            <a:r>
-              <a:rPr lang="en-US" sz="2600" b="1" dirty="0">
-                <a:solidFill>
-                  <a:srgbClr val="D4700C"/>
-                </a:solidFill>
-                <a:latin typeface="Calibri" pitchFamily="34" charset="0"/>
-                <a:ea typeface="Calibri" pitchFamily="34" charset="-122"/>
-                <a:cs typeface="Calibri" pitchFamily="34" charset="-120"/>
-              </a:rPr>
-              <a:t>Pending, road run 26 Oct: </a:t>
-            </a:r>
-            <a:pPr indent="0" marL="0">
-              <a:spcAft>
-                <a:spcPts val="1000"/>
-              </a:spcAft>
-              <a:buNone/>
-            </a:pPr>
-            <a:r>
-              <a:rPr lang="en-US" sz="2600" dirty="0">
-                <a:solidFill>
-                  <a:srgbClr val="1B1F24"/>
-                </a:solidFill>
-                <a:latin typeface="Calibri" pitchFamily="34" charset="0"/>
-                <a:ea typeface="Calibri" pitchFamily="34" charset="-122"/>
-                <a:cs typeface="Calibri" pitchFamily="34" charset="-120"/>
-              </a:rPr>
-              <a:t>repeatability over passes (RQ1) and the stand lines' share of the road spectrum (RQ4).</a:t>
-            </a:r>
-            <a:endParaRPr lang="en-US" sz="2600" dirty="0"/>
-          </a:p>
-          <a:p>
-            <a:pPr marL="406400" indent="-406400">
-              <a:buSzPct val="100000"/>
-              <a:buChar char="•"/>
-            </a:pPr>
-            <a:r>
-              <a:rPr lang="en-US" sz="2600" b="1" dirty="0">
-                <a:solidFill>
-                  <a:srgbClr val="D4700C"/>
-                </a:solidFill>
-                <a:latin typeface="Calibri" pitchFamily="34" charset="0"/>
-                <a:ea typeface="Calibri" pitchFamily="34" charset="-122"/>
-                <a:cs typeface="Calibri" pitchFamily="34" charset="-120"/>
-              </a:rPr>
-              <a:t>Next: </a:t>
-            </a:r>
-            <a:pPr indent="0" marL="0">
-              <a:spcAft>
-                <a:spcPts val="1000"/>
-              </a:spcAft>
-              <a:buNone/>
-            </a:pPr>
-            <a:r>
-              <a:rPr lang="en-US" sz="2600" dirty="0">
-                <a:solidFill>
-                  <a:srgbClr val="1B1F24"/>
-                </a:solidFill>
-                <a:latin typeface="Calibri" pitchFamily="34" charset="0"/>
-                <a:ea typeface="Calibri" pitchFamily="34" charset="-122"/>
-                <a:cs typeface="Calibri" pitchFamily="34" charset="-120"/>
-              </a:rPr>
-              <a:t>enlarge the warnings, then glance time; the real approach test; a regulated supply for the telemetry unit.</a:t>
-            </a:r>
-            <a:endParaRPr lang="en-US" sz="2600" dirty="0"/>
-          </a:p>
-        </p:txBody>
-      </p:sp>
-      <p:pic>
-        <p:nvPicPr>
-          <p:cNvPr id="69" name="Image 4" descr="C:\Users\0geda\OneDrive - University of Cape Town\Documents\PlatformIO\Projects\Tukzie-HPEC-HUD\Presentation\source\assets\uct_logo.png">    </p:cNvPr>
-          <p:cNvPicPr>
-            <a:picLocks noChangeAspect="1"/>
-          </p:cNvPicPr>
-          <p:nvPr/>
-        </p:nvPicPr>
-        <p:blipFill>
-          <a:blip r:embed="rId5"/>
-          <a:stretch>
-            <a:fillRect/>
-          </a:stretch>
-        </p:blipFill>
-        <p:spPr>
-          <a:xfrm>
-            <a:off x="1097280" y="40288464"/>
-            <a:ext cx="2103120" cy="2139696"/>
-          </a:xfrm>
-          <a:prstGeom prst="rect">
-            <a:avLst/>
-          </a:prstGeom>
-        </p:spPr>
-      </p:pic>
-      <p:sp>
-        <p:nvSpPr>
-          <p:cNvPr id="70" name="Text 63"/>
-          <p:cNvSpPr txBox="1"/>
-          <p:nvPr/>
-        </p:nvSpPr>
-        <p:spPr>
-          <a:xfrm>
-            <a:off x="3749040" y="40882824"/>
-            <a:ext cx="25429464" cy="914400"/>
-          </a:xfrm>
-          <a:prstGeom prst="rect">
-            <a:avLst/>
-          </a:prstGeom>
-          <a:noFill/>
-          <a:ln/>
-        </p:spPr>
-        <p:txBody>
-          <a:bodyPr wrap="square" lIns="0" tIns="0" rIns="0" bIns="0" rtlCol="0" anchor="ctr"/>
-          <a:lstStyle/>
-          <a:p>
-            <a:pPr indent="0" marL="0">
-              <a:buNone/>
-            </a:pPr>
-            <a:r>
-              <a:rPr lang="en-US" sz="2800" dirty="0">
+          <a:p>
+            <a:pPr algn="ctr" indent="0" marL="0">
+              <a:buNone/>
+            </a:pPr>
+            <a:r>
+              <a:rPr lang="en-US" sz="2400" dirty="0">
                 <a:solidFill>
                   <a:srgbClr val="14305C"/>
                 </a:solidFill>
@@ -3629,9 +4387,9 @@
                 <a:ea typeface="Calibri" pitchFamily="34" charset="-122"/>
                 <a:cs typeface="Calibri" pitchFamily="34" charset="-120"/>
               </a:rPr>
-              <a:t>Department of Electrical Engineering, University of Cape Town   |   EEE4022S 2026   |   Project SW-7</a:t>
-            </a:r>
-            <a:endParaRPr lang="en-US" sz="2800" dirty="0"/>
+              <a:t>tuksense.site</a:t>
+            </a:r>
+            <a:endParaRPr lang="en-US" sz="2400" dirty="0"/>
           </a:p>
         </p:txBody>
       </p:sp>

</xml_diff>